<commit_message>
Interim snapshot: deck generator iteration (unreviewed)
Co-Authored-By: Claude Opus 5.5 <noreply@anthropic.com>
Claude-Session: https://claude.ai/code/session_01LnkFMdRYsdw8VhXMWXEpNu
</commit_message>
<xml_diff>
--- a/docs/presentations/stage1_procurement_build.pptx
+++ b/docs/presentations/stage1_procurement_build.pptx
@@ -121,20 +121,20 @@
   <p:extLst>
     <p:ext uri="{521415D9-36F7-43E2-AB2F-B90AF26B5E84}">
       <p14:sectionLst xmlns:p14="http://schemas.microsoft.com/office/powerpoint/2010/main">
-        <p14:section name="Introduction" id="{1d5cab18-347a-e9d5-e705-58ec513c4299}">
+        <p14:section name="Introduction" id="{cd27fa6f-d6bb-37df-746b-cffe9bf9d55a}">
           <p14:sldIdLst>
             <p14:sldId id="256"/>
             <p14:sldId id="257"/>
           </p14:sldIdLst>
         </p14:section>
-        <p14:section name="Scope of work" id="{14ae07ae-fb41-4779-022c-308c089e8477}">
+        <p14:section name="Scope of work" id="{aa3c779c-01cf-c66a-957f-7139096befb8}">
           <p14:sldIdLst>
             <p14:sldId id="258"/>
             <p14:sldId id="259"/>
             <p14:sldId id="260"/>
           </p14:sldIdLst>
         </p14:section>
-        <p14:section name="Procurement" id="{f8679e97-4f6a-19cd-9b6a-95329973c21b}">
+        <p14:section name="Procurement" id="{db809170-4a50-429f-b4aa-4428a6b325ce}">
           <p14:sldIdLst>
             <p14:sldId id="261"/>
             <p14:sldId id="262"/>
@@ -143,7 +143,7 @@
             <p14:sldId id="265"/>
           </p14:sldIdLst>
         </p14:section>
-        <p14:section name="Mechanical build" id="{fe30e4d6-b66d-0e1c-9d07-e31cd5b412cf}">
+        <p14:section name="Mechanical build" id="{72e91ee4-e390-f850-20f0-23f55a51ed74}">
           <p14:sldIdLst>
             <p14:sldId id="266"/>
             <p14:sldId id="267"/>
@@ -2966,8 +2966,8 @@
         </p:nvSpPr>
         <p:spPr>
           <a:xfrm>
-            <a:off x="6118777" y="1600200"/>
-            <a:ext cx="5387118" cy="605790"/>
+            <a:off x="6118777" y="1508760"/>
+            <a:ext cx="5387118" cy="788670"/>
           </a:xfrm>
           <a:prstGeom prst="rect">
             <a:avLst/>
@@ -3082,8 +3082,8 @@
         </p:nvSpPr>
         <p:spPr>
           <a:xfrm>
-            <a:off x="6118777" y="2846070"/>
-            <a:ext cx="5387118" cy="605790"/>
+            <a:off x="6118777" y="2754630"/>
+            <a:ext cx="5387118" cy="788670"/>
           </a:xfrm>
           <a:prstGeom prst="rect">
             <a:avLst/>
@@ -3198,8 +3198,8 @@
         </p:nvSpPr>
         <p:spPr>
           <a:xfrm>
-            <a:off x="6118777" y="4091940"/>
-            <a:ext cx="5387118" cy="605790"/>
+            <a:off x="6118777" y="4000500"/>
+            <a:ext cx="5387118" cy="788670"/>
           </a:xfrm>
           <a:prstGeom prst="rect">
             <a:avLst/>
@@ -3314,8 +3314,8 @@
         </p:nvSpPr>
         <p:spPr>
           <a:xfrm>
-            <a:off x="6118777" y="5337810"/>
-            <a:ext cx="5387118" cy="605790"/>
+            <a:off x="6118777" y="5246370"/>
+            <a:ext cx="5387118" cy="788670"/>
           </a:xfrm>
           <a:prstGeom prst="rect">
             <a:avLst/>
@@ -4196,11 +4196,11 @@
         <p:spPr>
           <a:xfrm>
             <a:off x="5067217" y="1417320"/>
-            <a:ext cx="6667278" cy="971550"/>
+            <a:ext cx="6667278" cy="919316"/>
           </a:xfrm>
           <a:prstGeom prst="roundRect">
             <a:avLst>
-              <a:gd name="adj" fmla="val 11294"/>
+              <a:gd name="adj" fmla="val 11936"/>
             </a:avLst>
           </a:prstGeom>
           <a:solidFill>
@@ -4217,7 +4217,7 @@
         </p:nvSpPr>
         <p:spPr>
           <a:xfrm>
-            <a:off x="5295817" y="1583055"/>
+            <a:off x="5295817" y="1556938"/>
             <a:ext cx="640080" cy="640080"/>
           </a:xfrm>
           <a:prstGeom prst="ellipse">
@@ -4245,7 +4245,7 @@
         </p:blipFill>
         <p:spPr>
           <a:xfrm>
-            <a:off x="5455837" y="1743075"/>
+            <a:off x="5455837" y="1716958"/>
             <a:ext cx="320040" cy="320040"/>
           </a:xfrm>
           <a:prstGeom prst="rect">
@@ -4261,8 +4261,8 @@
         </p:nvSpPr>
         <p:spPr>
           <a:xfrm>
-            <a:off x="6118777" y="1600200"/>
-            <a:ext cx="5387118" cy="605790"/>
+            <a:off x="6118777" y="1508760"/>
+            <a:ext cx="5387118" cy="736436"/>
           </a:xfrm>
           <a:prstGeom prst="rect">
             <a:avLst/>
@@ -4311,12 +4311,12 @@
         </p:nvSpPr>
         <p:spPr>
           <a:xfrm>
-            <a:off x="5067217" y="2663190"/>
-            <a:ext cx="6667278" cy="971550"/>
+            <a:off x="5067217" y="2610956"/>
+            <a:ext cx="6667278" cy="919316"/>
           </a:xfrm>
           <a:prstGeom prst="roundRect">
             <a:avLst>
-              <a:gd name="adj" fmla="val 11294"/>
+              <a:gd name="adj" fmla="val 11936"/>
             </a:avLst>
           </a:prstGeom>
           <a:solidFill>
@@ -4333,7 +4333,7 @@
         </p:nvSpPr>
         <p:spPr>
           <a:xfrm>
-            <a:off x="5295817" y="2828925"/>
+            <a:off x="5295817" y="2750574"/>
             <a:ext cx="640080" cy="640080"/>
           </a:xfrm>
           <a:prstGeom prst="ellipse">
@@ -4361,7 +4361,7 @@
         </p:blipFill>
         <p:spPr>
           <a:xfrm>
-            <a:off x="5455837" y="2988945"/>
+            <a:off x="5455837" y="2910594"/>
             <a:ext cx="320040" cy="320040"/>
           </a:xfrm>
           <a:prstGeom prst="rect">
@@ -4377,8 +4377,8 @@
         </p:nvSpPr>
         <p:spPr>
           <a:xfrm>
-            <a:off x="6118777" y="2846070"/>
-            <a:ext cx="5387118" cy="605790"/>
+            <a:off x="6118777" y="2702396"/>
+            <a:ext cx="5387118" cy="736436"/>
           </a:xfrm>
           <a:prstGeom prst="rect">
             <a:avLst/>
@@ -4427,12 +4427,12 @@
         </p:nvSpPr>
         <p:spPr>
           <a:xfrm>
-            <a:off x="5067217" y="3909060"/>
-            <a:ext cx="6667278" cy="971550"/>
+            <a:off x="5067217" y="3804592"/>
+            <a:ext cx="6667278" cy="919316"/>
           </a:xfrm>
           <a:prstGeom prst="roundRect">
             <a:avLst>
-              <a:gd name="adj" fmla="val 11294"/>
+              <a:gd name="adj" fmla="val 11936"/>
             </a:avLst>
           </a:prstGeom>
           <a:solidFill>
@@ -4449,7 +4449,7 @@
         </p:nvSpPr>
         <p:spPr>
           <a:xfrm>
-            <a:off x="5295817" y="4074795"/>
+            <a:off x="5295817" y="3944210"/>
             <a:ext cx="640080" cy="640080"/>
           </a:xfrm>
           <a:prstGeom prst="ellipse">
@@ -4477,7 +4477,7 @@
         </p:blipFill>
         <p:spPr>
           <a:xfrm>
-            <a:off x="5455837" y="4234815"/>
+            <a:off x="5455837" y="4104230"/>
             <a:ext cx="320040" cy="320040"/>
           </a:xfrm>
           <a:prstGeom prst="rect">
@@ -4493,8 +4493,8 @@
         </p:nvSpPr>
         <p:spPr>
           <a:xfrm>
-            <a:off x="6118777" y="4091940"/>
-            <a:ext cx="5387118" cy="605790"/>
+            <a:off x="6118777" y="3896032"/>
+            <a:ext cx="5387118" cy="736436"/>
           </a:xfrm>
           <a:prstGeom prst="rect">
             <a:avLst/>
@@ -4543,12 +4543,12 @@
         </p:nvSpPr>
         <p:spPr>
           <a:xfrm>
-            <a:off x="5067217" y="5154930"/>
-            <a:ext cx="6667278" cy="971550"/>
+            <a:off x="5067217" y="4998228"/>
+            <a:ext cx="6667278" cy="1128252"/>
           </a:xfrm>
           <a:prstGeom prst="roundRect">
             <a:avLst>
-              <a:gd name="adj" fmla="val 11294"/>
+              <a:gd name="adj" fmla="val 9725"/>
             </a:avLst>
           </a:prstGeom>
           <a:solidFill>
@@ -4565,7 +4565,7 @@
         </p:nvSpPr>
         <p:spPr>
           <a:xfrm>
-            <a:off x="5295817" y="5320665"/>
+            <a:off x="5295817" y="5242314"/>
             <a:ext cx="640080" cy="640080"/>
           </a:xfrm>
           <a:prstGeom prst="ellipse">
@@ -4593,7 +4593,7 @@
         </p:blipFill>
         <p:spPr>
           <a:xfrm>
-            <a:off x="5455837" y="5480685"/>
+            <a:off x="5455837" y="5402334"/>
             <a:ext cx="320040" cy="320040"/>
           </a:xfrm>
           <a:prstGeom prst="rect">
@@ -4609,8 +4609,8 @@
         </p:nvSpPr>
         <p:spPr>
           <a:xfrm>
-            <a:off x="6118777" y="5337810"/>
-            <a:ext cx="5387118" cy="605790"/>
+            <a:off x="6118777" y="5089668"/>
+            <a:ext cx="5387118" cy="945372"/>
           </a:xfrm>
           <a:prstGeom prst="rect">
             <a:avLst/>
@@ -5707,7 +5707,7 @@
         </p:blipFill>
         <p:spPr>
           <a:xfrm>
-            <a:off x="457200" y="1482852"/>
+            <a:off x="457200" y="1497657"/>
             <a:ext cx="411480" cy="411480"/>
           </a:xfrm>
           <a:prstGeom prst="rect">
@@ -5724,7 +5724,7 @@
         <p:spPr>
           <a:xfrm>
             <a:off x="1051560" y="1417320"/>
-            <a:ext cx="6263640" cy="542544"/>
+            <a:ext cx="6263640" cy="572153"/>
           </a:xfrm>
           <a:prstGeom prst="rect">
             <a:avLst/>
@@ -5767,7 +5767,7 @@
         </p:blipFill>
         <p:spPr>
           <a:xfrm>
-            <a:off x="457200" y="2299716"/>
+            <a:off x="457200" y="2252690"/>
             <a:ext cx="411480" cy="411480"/>
           </a:xfrm>
           <a:prstGeom prst="rect">
@@ -5783,8 +5783,8 @@
         </p:nvSpPr>
         <p:spPr>
           <a:xfrm>
-            <a:off x="1051560" y="2234184"/>
-            <a:ext cx="6263640" cy="542544"/>
+            <a:off x="1051560" y="2172353"/>
+            <a:ext cx="6263640" cy="572153"/>
           </a:xfrm>
           <a:prstGeom prst="rect">
             <a:avLst/>
@@ -5827,7 +5827,7 @@
         </p:blipFill>
         <p:spPr>
           <a:xfrm>
-            <a:off x="457200" y="3064111"/>
+            <a:off x="457200" y="2942191"/>
             <a:ext cx="411480" cy="411480"/>
           </a:xfrm>
           <a:prstGeom prst="rect">
@@ -5843,8 +5843,8 @@
         </p:nvSpPr>
         <p:spPr>
           <a:xfrm>
-            <a:off x="1051560" y="3051048"/>
-            <a:ext cx="6263640" cy="437606"/>
+            <a:off x="1051560" y="2927386"/>
+            <a:ext cx="6263640" cy="441089"/>
           </a:xfrm>
           <a:prstGeom prst="rect">
             <a:avLst/>
@@ -5887,7 +5887,7 @@
         </p:blipFill>
         <p:spPr>
           <a:xfrm>
-            <a:off x="457200" y="3776037"/>
+            <a:off x="457200" y="3566160"/>
             <a:ext cx="411480" cy="411480"/>
           </a:xfrm>
           <a:prstGeom prst="rect">
@@ -5903,8 +5903,8 @@
         </p:nvSpPr>
         <p:spPr>
           <a:xfrm>
-            <a:off x="1051560" y="3762974"/>
-            <a:ext cx="6263640" cy="437606"/>
+            <a:off x="1051560" y="3551355"/>
+            <a:ext cx="6263640" cy="441089"/>
           </a:xfrm>
           <a:prstGeom prst="rect">
             <a:avLst/>
@@ -5947,7 +5947,7 @@
         </p:blipFill>
         <p:spPr>
           <a:xfrm>
-            <a:off x="457200" y="4540431"/>
+            <a:off x="457200" y="4255661"/>
             <a:ext cx="411480" cy="411480"/>
           </a:xfrm>
           <a:prstGeom prst="rect">
@@ -5963,8 +5963,8 @@
         </p:nvSpPr>
         <p:spPr>
           <a:xfrm>
-            <a:off x="1051560" y="4474899"/>
-            <a:ext cx="6263640" cy="542544"/>
+            <a:off x="1051560" y="4175325"/>
+            <a:ext cx="6263640" cy="572153"/>
           </a:xfrm>
           <a:prstGeom prst="rect">
             <a:avLst/>
@@ -6007,7 +6007,7 @@
         </p:blipFill>
         <p:spPr>
           <a:xfrm>
-            <a:off x="457200" y="5304826"/>
+            <a:off x="457200" y="4945162"/>
             <a:ext cx="411480" cy="411480"/>
           </a:xfrm>
           <a:prstGeom prst="rect">
@@ -6023,8 +6023,8 @@
         </p:nvSpPr>
         <p:spPr>
           <a:xfrm>
-            <a:off x="1051560" y="5291763"/>
-            <a:ext cx="6263640" cy="437606"/>
+            <a:off x="1051560" y="4930358"/>
+            <a:ext cx="6263640" cy="441089"/>
           </a:xfrm>
           <a:prstGeom prst="rect">
             <a:avLst/>
@@ -6067,7 +6067,7 @@
         </p:blipFill>
         <p:spPr>
           <a:xfrm>
-            <a:off x="457200" y="6069221"/>
+            <a:off x="457200" y="5634663"/>
             <a:ext cx="411480" cy="411480"/>
           </a:xfrm>
           <a:prstGeom prst="rect">
@@ -6083,8 +6083,8 @@
         </p:nvSpPr>
         <p:spPr>
           <a:xfrm>
-            <a:off x="1051560" y="6003689"/>
-            <a:ext cx="6263640" cy="542544"/>
+            <a:off x="1051560" y="5554327"/>
+            <a:ext cx="6263640" cy="572153"/>
           </a:xfrm>
           <a:prstGeom prst="rect">
             <a:avLst/>
@@ -7046,7 +7046,7 @@
                   </a:tcPr>
                 </a:tc>
               </a:tr>
-              <a:tr h="462915">
+              <a:tr h="455023">
                 <a:tc>
                   <a:txBody>
                     <a:bodyPr/>
@@ -7231,7 +7231,7 @@
                   </a:tcPr>
                 </a:tc>
               </a:tr>
-              <a:tr h="462915">
+              <a:tr h="455023">
                 <a:tc>
                   <a:txBody>
                     <a:bodyPr/>
@@ -7416,7 +7416,7 @@
                   </a:tcPr>
                 </a:tc>
               </a:tr>
-              <a:tr h="462915">
+              <a:tr h="455023">
                 <a:tc>
                   <a:txBody>
                     <a:bodyPr/>
@@ -7601,7 +7601,7 @@
                   </a:tcPr>
                 </a:tc>
               </a:tr>
-              <a:tr h="462915">
+              <a:tr h="455023">
                 <a:tc>
                   <a:txBody>
                     <a:bodyPr/>
@@ -7786,7 +7786,7 @@
                   </a:tcPr>
                 </a:tc>
               </a:tr>
-              <a:tr h="462915">
+              <a:tr h="455023">
                 <a:tc>
                   <a:txBody>
                     <a:bodyPr/>
@@ -7971,7 +7971,7 @@
                   </a:tcPr>
                 </a:tc>
               </a:tr>
-              <a:tr h="462915">
+              <a:tr h="455023">
                 <a:tc>
                   <a:txBody>
                     <a:bodyPr/>
@@ -8341,7 +8341,7 @@
                   </a:tcPr>
                 </a:tc>
               </a:tr>
-              <a:tr h="462915">
+              <a:tr h="455023">
                 <a:tc>
                   <a:txBody>
                     <a:bodyPr/>
@@ -8539,7 +8539,7 @@
         <p:spPr>
           <a:xfrm>
             <a:off x="8961120" y="1417320"/>
-            <a:ext cx="2773375" cy="4215765"/>
+            <a:ext cx="2773375" cy="4160520"/>
           </a:xfrm>
           <a:prstGeom prst="roundRect">
             <a:avLst>
@@ -8560,7 +8560,7 @@
         </p:nvSpPr>
         <p:spPr>
           <a:xfrm>
-            <a:off x="9616288" y="2793683"/>
+            <a:off x="9616288" y="2766060"/>
             <a:ext cx="1463040" cy="1463040"/>
           </a:xfrm>
           <a:prstGeom prst="ellipse">
@@ -8588,7 +8588,7 @@
         </p:blipFill>
         <p:spPr>
           <a:xfrm>
-            <a:off x="9982048" y="3159443"/>
+            <a:off x="9982048" y="3131820"/>
             <a:ext cx="731520" cy="731520"/>
           </a:xfrm>
           <a:prstGeom prst="rect">
@@ -10551,7 +10551,7 @@
                   </a:tcPr>
                 </a:tc>
               </a:tr>
-              <a:tr h="462915">
+              <a:tr h="455023">
                 <a:tc>
                   <a:txBody>
                     <a:bodyPr/>
@@ -10675,7 +10675,7 @@
                   </a:tcPr>
                 </a:tc>
               </a:tr>
-              <a:tr h="462915">
+              <a:tr h="455023">
                 <a:tc>
                   <a:txBody>
                     <a:bodyPr/>
@@ -10799,7 +10799,7 @@
                   </a:tcPr>
                 </a:tc>
               </a:tr>
-              <a:tr h="462915">
+              <a:tr h="455023">
                 <a:tc>
                   <a:txBody>
                     <a:bodyPr/>
@@ -10923,7 +10923,7 @@
                   </a:tcPr>
                 </a:tc>
               </a:tr>
-              <a:tr h="462915">
+              <a:tr h="455023">
                 <a:tc>
                   <a:txBody>
                     <a:bodyPr/>
@@ -11047,7 +11047,7 @@
                   </a:tcPr>
                 </a:tc>
               </a:tr>
-              <a:tr h="462915">
+              <a:tr h="455023">
                 <a:tc>
                   <a:txBody>
                     <a:bodyPr/>
@@ -11171,7 +11171,7 @@
                   </a:tcPr>
                 </a:tc>
               </a:tr>
-              <a:tr h="462915">
+              <a:tr h="455023">
                 <a:tc>
                   <a:txBody>
                     <a:bodyPr/>
@@ -11419,7 +11419,7 @@
                   </a:tcPr>
                 </a:tc>
               </a:tr>
-              <a:tr h="462915">
+              <a:tr h="455023">
                 <a:tc>
                   <a:txBody>
                     <a:bodyPr/>

</xml_diff>

<commit_message>
Decks reviewed: build, buy, specification, run-out and preparation slides
Procurement and build deck (15 slides) gains what must be built, what must
be bought, the sphere and plate purchase specifications and the run-out
fixture; the micrometer method throughout; build-slide notes point to the
shop drawings. Test-procedure deck (15 slides) gains the preparation slide;
SGM parameters, tool load data, trigger through the communication software
and the pose-log location are added. Plate drawing pads placed as on
drawing SC1-05. Both decks validate; the content check passes; every slide
render reviewed.

Co-Authored-By: Claude Opus 5.5 <noreply@anthropic.com>
Claude-Session: https://claude.ai/code/session_01LnkFMdRYsdw8VhXMWXEpNu
</commit_message>
<xml_diff>
--- a/docs/presentations/stage1_procurement_build.pptx
+++ b/docs/presentations/stage1_procurement_build.pptx
@@ -121,20 +121,20 @@
   <p:extLst>
     <p:ext uri="{521415D9-36F7-43E2-AB2F-B90AF26B5E84}">
       <p14:sectionLst xmlns:p14="http://schemas.microsoft.com/office/powerpoint/2010/main">
-        <p14:section name="Introduction" id="{cd27fa6f-d6bb-37df-746b-cffe9bf9d55a}">
+        <p14:section name="Introduction" id="{a54f1a1d-a46b-8f63-ef00-023de9a958a4}">
           <p14:sldIdLst>
             <p14:sldId id="256"/>
             <p14:sldId id="257"/>
           </p14:sldIdLst>
         </p14:section>
-        <p14:section name="Scope of work" id="{aa3c779c-01cf-c66a-957f-7139096befb8}">
+        <p14:section name="Scope of work" id="{8f9132ad-4ce3-89e7-b00c-c3df993f14f9}">
           <p14:sldIdLst>
             <p14:sldId id="258"/>
             <p14:sldId id="259"/>
             <p14:sldId id="260"/>
           </p14:sldIdLst>
         </p14:section>
-        <p14:section name="Procurement" id="{db809170-4a50-429f-b4aa-4428a6b325ce}">
+        <p14:section name="Procurement" id="{175d0e93-2f74-411c-c88b-2ce8c86b17bb}">
           <p14:sldIdLst>
             <p14:sldId id="261"/>
             <p14:sldId id="262"/>
@@ -143,7 +143,7 @@
             <p14:sldId id="265"/>
           </p14:sldIdLst>
         </p14:section>
-        <p14:section name="Mechanical build" id="{72e91ee4-e390-f850-20f0-23f55a51ed74}">
+        <p14:section name="Mechanical build" id="{b31fbc3d-863b-d1a6-f66d-dabccb5b983f}">
           <p14:sldIdLst>
             <p14:sldId id="266"/>
             <p14:sldId id="267"/>
@@ -2967,7 +2967,7 @@
         <p:spPr>
           <a:xfrm>
             <a:off x="6118777" y="1508760"/>
-            <a:ext cx="5387118" cy="788670"/>
+            <a:ext cx="4975638" cy="788670"/>
           </a:xfrm>
           <a:prstGeom prst="rect">
             <a:avLst/>
@@ -3083,7 +3083,7 @@
         <p:spPr>
           <a:xfrm>
             <a:off x="6118777" y="2754630"/>
-            <a:ext cx="5387118" cy="788670"/>
+            <a:ext cx="4975638" cy="788670"/>
           </a:xfrm>
           <a:prstGeom prst="rect">
             <a:avLst/>
@@ -3199,7 +3199,7 @@
         <p:spPr>
           <a:xfrm>
             <a:off x="6118777" y="4000500"/>
-            <a:ext cx="5387118" cy="788670"/>
+            <a:ext cx="4975638" cy="788670"/>
           </a:xfrm>
           <a:prstGeom prst="rect">
             <a:avLst/>
@@ -3315,7 +3315,7 @@
         <p:spPr>
           <a:xfrm>
             <a:off x="6118777" y="5246370"/>
-            <a:ext cx="5387118" cy="788670"/>
+            <a:ext cx="4975638" cy="788670"/>
           </a:xfrm>
           <a:prstGeom prst="rect">
             <a:avLst/>
@@ -5707,7 +5707,7 @@
         </p:blipFill>
         <p:spPr>
           <a:xfrm>
-            <a:off x="457200" y="1497657"/>
+            <a:off x="457200" y="1469571"/>
             <a:ext cx="411480" cy="411480"/>
           </a:xfrm>
           <a:prstGeom prst="rect">
@@ -5724,7 +5724,7 @@
         <p:spPr>
           <a:xfrm>
             <a:off x="1051560" y="1417320"/>
-            <a:ext cx="6263640" cy="572153"/>
+            <a:ext cx="7360920" cy="515983"/>
           </a:xfrm>
           <a:prstGeom prst="rect">
             <a:avLst/>
@@ -5767,7 +5767,7 @@
         </p:blipFill>
         <p:spPr>
           <a:xfrm>
-            <a:off x="457200" y="2252690"/>
+            <a:off x="457200" y="2168434"/>
             <a:ext cx="411480" cy="411480"/>
           </a:xfrm>
           <a:prstGeom prst="rect">
@@ -5783,8 +5783,8 @@
         </p:nvSpPr>
         <p:spPr>
           <a:xfrm>
-            <a:off x="1051560" y="2172353"/>
-            <a:ext cx="6263640" cy="572153"/>
+            <a:off x="1051560" y="2116183"/>
+            <a:ext cx="7360920" cy="515983"/>
           </a:xfrm>
           <a:prstGeom prst="rect">
             <a:avLst/>
@@ -5827,7 +5827,7 @@
         </p:blipFill>
         <p:spPr>
           <a:xfrm>
-            <a:off x="457200" y="2942191"/>
+            <a:off x="457200" y="2867297"/>
             <a:ext cx="411480" cy="411480"/>
           </a:xfrm>
           <a:prstGeom prst="rect">
@@ -5843,8 +5843,8 @@
         </p:nvSpPr>
         <p:spPr>
           <a:xfrm>
-            <a:off x="1051560" y="2927386"/>
-            <a:ext cx="6263640" cy="441089"/>
+            <a:off x="1051560" y="2815046"/>
+            <a:ext cx="7360920" cy="515983"/>
           </a:xfrm>
           <a:prstGeom prst="rect">
             <a:avLst/>
@@ -5903,8 +5903,8 @@
         </p:nvSpPr>
         <p:spPr>
           <a:xfrm>
-            <a:off x="1051560" y="3551355"/>
-            <a:ext cx="6263640" cy="441089"/>
+            <a:off x="1051560" y="3513909"/>
+            <a:ext cx="7360920" cy="515983"/>
           </a:xfrm>
           <a:prstGeom prst="rect">
             <a:avLst/>
@@ -5947,7 +5947,7 @@
         </p:blipFill>
         <p:spPr>
           <a:xfrm>
-            <a:off x="457200" y="4255661"/>
+            <a:off x="457200" y="4265023"/>
             <a:ext cx="411480" cy="411480"/>
           </a:xfrm>
           <a:prstGeom prst="rect">
@@ -5963,8 +5963,8 @@
         </p:nvSpPr>
         <p:spPr>
           <a:xfrm>
-            <a:off x="1051560" y="4175325"/>
-            <a:ext cx="6263640" cy="572153"/>
+            <a:off x="1051560" y="4212771"/>
+            <a:ext cx="7360920" cy="515983"/>
           </a:xfrm>
           <a:prstGeom prst="rect">
             <a:avLst/>
@@ -6007,7 +6007,7 @@
         </p:blipFill>
         <p:spPr>
           <a:xfrm>
-            <a:off x="457200" y="4945162"/>
+            <a:off x="457200" y="4963886"/>
             <a:ext cx="411480" cy="411480"/>
           </a:xfrm>
           <a:prstGeom prst="rect">
@@ -6023,8 +6023,8 @@
         </p:nvSpPr>
         <p:spPr>
           <a:xfrm>
-            <a:off x="1051560" y="4930358"/>
-            <a:ext cx="6263640" cy="441089"/>
+            <a:off x="1051560" y="4911634"/>
+            <a:ext cx="7360920" cy="515983"/>
           </a:xfrm>
           <a:prstGeom prst="rect">
             <a:avLst/>
@@ -6067,7 +6067,7 @@
         </p:blipFill>
         <p:spPr>
           <a:xfrm>
-            <a:off x="457200" y="5634663"/>
+            <a:off x="457200" y="5662749"/>
             <a:ext cx="411480" cy="411480"/>
           </a:xfrm>
           <a:prstGeom prst="rect">
@@ -6083,8 +6083,8 @@
         </p:nvSpPr>
         <p:spPr>
           <a:xfrm>
-            <a:off x="1051560" y="5554327"/>
-            <a:ext cx="6263640" cy="572153"/>
+            <a:off x="1051560" y="5610497"/>
+            <a:ext cx="7360920" cy="515983"/>
           </a:xfrm>
           <a:prstGeom prst="rect">
             <a:avLst/>
@@ -6119,12 +6119,12 @@
         </p:nvSpPr>
         <p:spPr>
           <a:xfrm>
-            <a:off x="7589520" y="1417320"/>
-            <a:ext cx="4144975" cy="4709160"/>
+            <a:off x="8686800" y="1417320"/>
+            <a:ext cx="3047695" cy="4709160"/>
           </a:xfrm>
           <a:prstGeom prst="roundRect">
             <a:avLst>
-              <a:gd name="adj" fmla="val 2647"/>
+              <a:gd name="adj" fmla="val 3600"/>
             </a:avLst>
           </a:prstGeom>
           <a:solidFill>
@@ -6141,7 +6141,7 @@
         </p:nvSpPr>
         <p:spPr>
           <a:xfrm>
-            <a:off x="8473288" y="2583180"/>
+            <a:off x="9021928" y="2583180"/>
             <a:ext cx="2377440" cy="2377440"/>
           </a:xfrm>
           <a:prstGeom prst="ellipse">
@@ -6169,7 +6169,7 @@
         </p:blipFill>
         <p:spPr>
           <a:xfrm>
-            <a:off x="9067648" y="3177540"/>
+            <a:off x="9616288" y="3177540"/>
             <a:ext cx="1188720" cy="1188720"/>
           </a:xfrm>
           <a:prstGeom prst="rect">
@@ -8766,9 +8766,9 @@
             <a:tbl>
               <a:tblPr/>
               <a:tblGrid>
-                <a:gridCol w="4572000"/>
-                <a:gridCol w="4846320"/>
-                <a:gridCol w="1858975"/>
+                <a:gridCol w="4297680"/>
+                <a:gridCol w="5212080"/>
+                <a:gridCol w="1767535"/>
               </a:tblGrid>
               <a:tr h="457200">
                 <a:tc>
@@ -14550,8 +14550,8 @@
         </p:nvSpPr>
         <p:spPr>
           <a:xfrm>
-            <a:off x="9369400" y="2379726"/>
-            <a:ext cx="201168" cy="201168"/>
+            <a:off x="8708746" y="3810762"/>
+            <a:ext cx="205740" cy="205740"/>
           </a:xfrm>
           <a:prstGeom prst="ellipse">
             <a:avLst/>
@@ -14570,8 +14570,8 @@
         </p:nvSpPr>
         <p:spPr>
           <a:xfrm>
-            <a:off x="10576408" y="2379726"/>
-            <a:ext cx="201168" cy="201168"/>
+            <a:off x="11232490" y="3810762"/>
+            <a:ext cx="205740" cy="205740"/>
           </a:xfrm>
           <a:prstGeom prst="ellipse">
             <a:avLst/>
@@ -14590,8 +14590,8 @@
         </p:nvSpPr>
         <p:spPr>
           <a:xfrm>
-            <a:off x="9972904" y="3408426"/>
-            <a:ext cx="201168" cy="201168"/>
+            <a:off x="9970618" y="1972818"/>
+            <a:ext cx="205740" cy="205740"/>
           </a:xfrm>
           <a:prstGeom prst="ellipse">
             <a:avLst/>
@@ -14669,8 +14669,8 @@
         </p:nvSpPr>
         <p:spPr>
           <a:xfrm>
-            <a:off x="8829904" y="4768596"/>
-            <a:ext cx="201168" cy="201168"/>
+            <a:off x="8827618" y="4766310"/>
+            <a:ext cx="205740" cy="205740"/>
           </a:xfrm>
           <a:prstGeom prst="ellipse">
             <a:avLst/>

</xml_diff>

<commit_message>
Decks and procedure: disagreements found by a consistency pass
Procedure deck: the ~2 h stat is session time, not robot time; the deliverables list
carries the TCP routine errors, board dimensions, fixture changes with times and the
run-out fixture photo; the manifest notes allow nine rotation values for the matrix
form. Build deck: stock reference spheres carry appendix A's limitations; "none found
stocked above 1.5 inch" instead of "none exists"; the base plate holds on a
non-magnetic table; sphere B wall "at least 6 mm; ceramic as an alternative"; nest
balls bonded, as drawing SC1-06 says. Procedure section 7 adds the matrix rotation
type (r1..r9), which make_manifest accepts. Content check, validation and renders pass.

Co-Authored-By: Claude Fable 5.1 <noreply@anthropic.com>
Claude-Session: https://claude.ai/code/session_016X9U4SzM2dXD3fEs3wV3Mm
</commit_message>
<xml_diff>
--- a/docs/presentations/stage1_procurement_build.pptx
+++ b/docs/presentations/stage1_procurement_build.pptx
@@ -121,20 +121,20 @@
   <p:extLst>
     <p:ext uri="{521415D9-36F7-43E2-AB2F-B90AF26B5E84}">
       <p14:sectionLst xmlns:p14="http://schemas.microsoft.com/office/powerpoint/2010/main">
-        <p14:section name="Introduction" id="{a54f1a1d-a46b-8f63-ef00-023de9a958a4}">
+        <p14:section name="Introduction" id="{a6b68c66-d857-a733-8122-ae8d5aa7510c}">
           <p14:sldIdLst>
             <p14:sldId id="256"/>
             <p14:sldId id="257"/>
           </p14:sldIdLst>
         </p14:section>
-        <p14:section name="Scope of work" id="{8f9132ad-4ce3-89e7-b00c-c3df993f14f9}">
+        <p14:section name="Scope of work" id="{2aaac125-19c6-cae7-a6f5-6527dcc6dc60}">
           <p14:sldIdLst>
             <p14:sldId id="258"/>
             <p14:sldId id="259"/>
             <p14:sldId id="260"/>
           </p14:sldIdLst>
         </p14:section>
-        <p14:section name="Procurement" id="{175d0e93-2f74-411c-c88b-2ce8c86b17bb}">
+        <p14:section name="Procurement" id="{a7a76c2b-506d-7cf4-a44a-934951e2e73b}">
           <p14:sldIdLst>
             <p14:sldId id="261"/>
             <p14:sldId id="262"/>
@@ -143,7 +143,7 @@
             <p14:sldId id="265"/>
           </p14:sldIdLst>
         </p14:section>
-        <p14:section name="Mechanical build" id="{b31fbc3d-863b-d1a6-f66d-dabccb5b983f}">
+        <p14:section name="Mechanical build" id="{887b9cf7-a070-c385-0311-74260a6c3c81}">
           <p14:sldIdLst>
             <p14:sldId id="266"/>
             <p14:sldId id="267"/>
@@ -996,7 +996,7 @@
           <a:p>
             <a:r>
               <a:rPr lang="en-US" dirty="0"/>
-              <a:t>A sphere resting on three fixed balls always has its center at the same point in space, whatever direction its stem points. That is what lets the robot's own multi-orientation routine find the sphere's center as its tool center point, which deck 2 describes. The nest is simple to make: a steel base with three pockets, the balls pressed in, and holes to bolt it down. Its position matters only in that the robot must be able to seat the sphere from several directions. The dimensioned shop drawings are in appendix D of the stage-1 procedure, and as PNG files in docs/procedures/drawings/ of the repository: SC1-01 and SC1-02 adapter plates, SC1-03 and SC1-04 stems with the sphere interfaces, SC1-05 board adapter, SC1-06 nest base. </a:t>
+              <a:t>A sphere resting on three fixed balls always has its center at the same point in space, whatever direction its stem points. That is what lets the robot's own multi-orientation routine find the sphere's center as its tool center point, which deck 2 describes. The nest is simple to make: a steel base with three pockets, the balls bonded in, and holes to bolt it down. Its position matters only in that the robot must be able to seat the sphere from several directions. The dimensioned shop drawings are in appendix D of the stage-1 procedure, and as PNG files in docs/procedures/drawings/ of the repository: SC1-01 and SC1-02 adapter plates, SC1-03 and SC1-04 stems with the sphere interfaces, SC1-05 board adapter, SC1-06 nest base. </a:t>
             </a:r>
             <a:endParaRPr lang="en-US" dirty="0"/>
           </a:p>
@@ -1788,7 +1788,7 @@
           <a:p>
             <a:r>
               <a:rPr lang="en-US" dirty="0"/>
-              <a:t>This list is appendix A of the procedure in brief. No supplier was found that stocks a precision sphere of the needed sizes with a mounting hole, so the spheres are either made to order or built from a bearing ball by a machine shop. The laser-scanner reference spheres sold in the right sizes generally have form errors of 0.5 to 2 mm, far too coarse; the Rothbucher sphere is the best specified of them. The finished diameters are measured in-house with outside micrometers, which is cheaper than buying certified spheres and is what the calibration actually needs.</a:t>
+              <a:t>This list is appendix A of the procedure in brief. No supplier was found that stocks a precision sphere of the needed sizes with a mounting hole, so the spheres are either made to order or built from a bearing ball by a machine shop. The laser-scanner reference spheres sold in the right sizes generally have form errors of 0.5 to 2 mm, far too coarse; the Rothbucher sphere is the best specified of them. Appendix A limits both stock items: MetrologyWorks spheres (up to 1.5 inch) only if the engineer accepts a smaller sphere A, and the Rothbucher sphere only as a provisional far-range sphere B, measured in-house first; it is not adequate as sphere A or as the final sphere B. The finished diameters are measured in-house with outside micrometers, which is cheaper than buying certified spheres and is what the calibration actually needs.</a:t>
             </a:r>
             <a:endParaRPr lang="en-US" dirty="0"/>
           </a:p>
@@ -2901,11 +2901,11 @@
         <p:spPr>
           <a:xfrm>
             <a:off x="5067217" y="1417320"/>
-            <a:ext cx="6667278" cy="971550"/>
+            <a:ext cx="6667278" cy="919316"/>
           </a:xfrm>
           <a:prstGeom prst="roundRect">
             <a:avLst>
-              <a:gd name="adj" fmla="val 11294"/>
+              <a:gd name="adj" fmla="val 11936"/>
             </a:avLst>
           </a:prstGeom>
           <a:solidFill>
@@ -2922,7 +2922,7 @@
         </p:nvSpPr>
         <p:spPr>
           <a:xfrm>
-            <a:off x="5295817" y="1583055"/>
+            <a:off x="5295817" y="1556938"/>
             <a:ext cx="640080" cy="640080"/>
           </a:xfrm>
           <a:prstGeom prst="ellipse">
@@ -2950,7 +2950,7 @@
         </p:blipFill>
         <p:spPr>
           <a:xfrm>
-            <a:off x="5455837" y="1743075"/>
+            <a:off x="5455837" y="1716958"/>
             <a:ext cx="320040" cy="320040"/>
           </a:xfrm>
           <a:prstGeom prst="rect">
@@ -2967,7 +2967,7 @@
         <p:spPr>
           <a:xfrm>
             <a:off x="6118777" y="1508760"/>
-            <a:ext cx="4975638" cy="788670"/>
+            <a:ext cx="4975638" cy="736436"/>
           </a:xfrm>
           <a:prstGeom prst="rect">
             <a:avLst/>
@@ -3016,12 +3016,12 @@
         </p:nvSpPr>
         <p:spPr>
           <a:xfrm>
-            <a:off x="5067217" y="2663190"/>
-            <a:ext cx="6667278" cy="971550"/>
+            <a:off x="5067217" y="2610956"/>
+            <a:ext cx="6667278" cy="919316"/>
           </a:xfrm>
           <a:prstGeom prst="roundRect">
             <a:avLst>
-              <a:gd name="adj" fmla="val 11294"/>
+              <a:gd name="adj" fmla="val 11936"/>
             </a:avLst>
           </a:prstGeom>
           <a:solidFill>
@@ -3038,7 +3038,7 @@
         </p:nvSpPr>
         <p:spPr>
           <a:xfrm>
-            <a:off x="5295817" y="2828925"/>
+            <a:off x="5295817" y="2750574"/>
             <a:ext cx="640080" cy="640080"/>
           </a:xfrm>
           <a:prstGeom prst="ellipse">
@@ -3066,7 +3066,7 @@
         </p:blipFill>
         <p:spPr>
           <a:xfrm>
-            <a:off x="5455837" y="2988945"/>
+            <a:off x="5455837" y="2910594"/>
             <a:ext cx="320040" cy="320040"/>
           </a:xfrm>
           <a:prstGeom prst="rect">
@@ -3082,8 +3082,8 @@
         </p:nvSpPr>
         <p:spPr>
           <a:xfrm>
-            <a:off x="6118777" y="2754630"/>
-            <a:ext cx="4975638" cy="788670"/>
+            <a:off x="6118777" y="2702396"/>
+            <a:ext cx="4975638" cy="736436"/>
           </a:xfrm>
           <a:prstGeom prst="rect">
             <a:avLst/>
@@ -3132,12 +3132,12 @@
         </p:nvSpPr>
         <p:spPr>
           <a:xfrm>
-            <a:off x="5067217" y="3909060"/>
-            <a:ext cx="6667278" cy="971550"/>
+            <a:off x="5067217" y="3804592"/>
+            <a:ext cx="6667278" cy="1128252"/>
           </a:xfrm>
           <a:prstGeom prst="roundRect">
             <a:avLst>
-              <a:gd name="adj" fmla="val 11294"/>
+              <a:gd name="adj" fmla="val 9725"/>
             </a:avLst>
           </a:prstGeom>
           <a:solidFill>
@@ -3154,7 +3154,7 @@
         </p:nvSpPr>
         <p:spPr>
           <a:xfrm>
-            <a:off x="5295817" y="4074795"/>
+            <a:off x="5295817" y="4048678"/>
             <a:ext cx="640080" cy="640080"/>
           </a:xfrm>
           <a:prstGeom prst="ellipse">
@@ -3182,7 +3182,7 @@
         </p:blipFill>
         <p:spPr>
           <a:xfrm>
-            <a:off x="5455837" y="4234815"/>
+            <a:off x="5455837" y="4208698"/>
             <a:ext cx="320040" cy="320040"/>
           </a:xfrm>
           <a:prstGeom prst="rect">
@@ -3198,8 +3198,8 @@
         </p:nvSpPr>
         <p:spPr>
           <a:xfrm>
-            <a:off x="6118777" y="4000500"/>
-            <a:ext cx="4975638" cy="788670"/>
+            <a:off x="6118777" y="3896032"/>
+            <a:ext cx="4975638" cy="945372"/>
           </a:xfrm>
           <a:prstGeom prst="rect">
             <a:avLst/>
@@ -3234,7 +3234,7 @@
                   <a:schemeClr val="tx1"/>
                 </a:solidFill>
               </a:rPr>
-              <a:t>About 150 x 100 x 12 mm, bolted to the cell table with two M8 screws, so the base holds on any table and does not creep</a:t>
+              <a:t>About 150 x 100 x 12 mm, bolted to the cell table with two M8 screws, so the base holds on a non-magnetic table and does not creep</a:t>
             </a:r>
             <a:endParaRPr lang="en-US" sz="1600" dirty="0"/>
           </a:p>
@@ -3248,12 +3248,12 @@
         </p:nvSpPr>
         <p:spPr>
           <a:xfrm>
-            <a:off x="5067217" y="5154930"/>
-            <a:ext cx="6667278" cy="971550"/>
+            <a:off x="5067217" y="5207164"/>
+            <a:ext cx="6667278" cy="919316"/>
           </a:xfrm>
           <a:prstGeom prst="roundRect">
             <a:avLst>
-              <a:gd name="adj" fmla="val 11294"/>
+              <a:gd name="adj" fmla="val 11936"/>
             </a:avLst>
           </a:prstGeom>
           <a:solidFill>
@@ -3270,7 +3270,7 @@
         </p:nvSpPr>
         <p:spPr>
           <a:xfrm>
-            <a:off x="5295817" y="5320665"/>
+            <a:off x="5295817" y="5346782"/>
             <a:ext cx="640080" cy="640080"/>
           </a:xfrm>
           <a:prstGeom prst="ellipse">
@@ -3298,7 +3298,7 @@
         </p:blipFill>
         <p:spPr>
           <a:xfrm>
-            <a:off x="5455837" y="5480685"/>
+            <a:off x="5455837" y="5506802"/>
             <a:ext cx="320040" cy="320040"/>
           </a:xfrm>
           <a:prstGeom prst="rect">
@@ -3314,8 +3314,8 @@
         </p:nvSpPr>
         <p:spPr>
           <a:xfrm>
-            <a:off x="6118777" y="5246370"/>
-            <a:ext cx="4975638" cy="788670"/>
+            <a:off x="6118777" y="5298604"/>
+            <a:ext cx="4975638" cy="736436"/>
           </a:xfrm>
           <a:prstGeom prst="rect">
             <a:avLst/>
@@ -12792,7 +12792,7 @@
                             <a:schemeClr val="tx1"/>
                           </a:solidFill>
                         </a:rPr>
-                        <a:t>Turned aluminum (6061-T6), solid or hollow with 6 mm wall</a:t>
+                        <a:t>Turned aluminum (6061-T6), solid or hollow with at least 6 mm wall; ceramic as an alternative</a:t>
                       </a:r>
                       <a:endParaRPr lang="en-US" sz="1400" dirty="0"/>
                     </a:p>
@@ -15455,7 +15455,7 @@
                   <a:schemeClr val="tx1"/>
                 </a:solidFill>
               </a:rPr>
-              <a:t>No pre-tapped precision sphere exists above 1.5 inch</a:t>
+              <a:t>None found stocked above 1.5 inch; custom order only</a:t>
             </a:r>
             <a:endParaRPr lang="en-US" sz="1600" dirty="0"/>
           </a:p>
@@ -16106,7 +16106,7 @@
                             <a:schemeClr val="tx1"/>
                           </a:solidFill>
                         </a:rPr>
-                        <a:t>MetrologyWorks up to 1.5 inch; Rothbucher 145 mm, sphericity 0.3 mm</a:t>
+                        <a:t>MetrologyWorks: smaller sphere A only. Rothbucher: provisional far-range B only.</a:t>
                       </a:r>
                       <a:endParaRPr lang="en-US" sz="1400" dirty="0"/>
                     </a:p>

</xml_diff>

<commit_message>
One sphere: decks, and a planner that keeps near-range positions
- Both decks rewritten for one sphere: fixtures, build and buy lists,
  cost ($1,875 to $5,150; $3,375 to $9,650 made to order), a one-column
  sphere specification, suppliers, mounting and sphere-end slides with
  the new crops, inspection reports and the in-house check list, the
  200-pose plan, one TCP, and every speaker note that counted two
  spheres. The title graphic shows one sphere.
- Planner: each station's grid is fitted to the room the sphere's image
  leaves (found by bisection with the exact silhouette test), with at
  least 3 positions per axis, so the near stations keep 9 overlapping
  placements instead of only the center. Plan: 151 sphere poses, 49
  board poses. Procedure section 6, appendix B and code_design updated;
  161 tests pass.

Co-Authored-By: Claude Opus 5.5 <noreply@anthropic.com>
Claude-Session: https://claude.ai/code/session_01LnkFMdRYsdw8VhXMWXEpNu
</commit_message>
<xml_diff>
--- a/docs/presentations/stage1_procurement_build.pptx
+++ b/docs/presentations/stage1_procurement_build.pptx
@@ -121,20 +121,20 @@
   <p:extLst>
     <p:ext uri="{521415D9-36F7-43E2-AB2F-B90AF26B5E84}">
       <p14:sectionLst xmlns:p14="http://schemas.microsoft.com/office/powerpoint/2010/main">
-        <p14:section name="Introduction" id="{a6b68c66-d857-a733-8122-ae8d5aa7510c}">
+        <p14:section name="Introduction" id="{333c239a-7a51-38cd-a630-aaa413c91ef9}">
           <p14:sldIdLst>
             <p14:sldId id="256"/>
             <p14:sldId id="257"/>
           </p14:sldIdLst>
         </p14:section>
-        <p14:section name="Scope of work" id="{2aaac125-19c6-cae7-a6f5-6527dcc6dc60}">
+        <p14:section name="Scope of work" id="{2066cdb6-62f9-f471-71a5-580eeee48728}">
           <p14:sldIdLst>
             <p14:sldId id="258"/>
             <p14:sldId id="259"/>
             <p14:sldId id="260"/>
           </p14:sldIdLst>
         </p14:section>
-        <p14:section name="Procurement" id="{a7a76c2b-506d-7cf4-a44a-934951e2e73b}">
+        <p14:section name="Procurement" id="{a3802c80-787a-22a1-c69a-76c3eb9bc8da}">
           <p14:sldIdLst>
             <p14:sldId id="261"/>
             <p14:sldId id="262"/>
@@ -143,7 +143,7 @@
             <p14:sldId id="265"/>
           </p14:sldIdLst>
         </p14:section>
-        <p14:section name="Mechanical build" id="{887b9cf7-a070-c385-0311-74260a6c3c81}">
+        <p14:section name="Mechanical build" id="{bb96e8ee-f057-064a-5c6d-385ae4f907b2}">
           <p14:sldIdLst>
             <p14:sldId id="266"/>
             <p14:sldId id="267"/>
@@ -556,7 +556,7 @@
           <a:p>
             <a:r>
               <a:rPr lang="en-US" dirty="0"/>
-              <a:t>This is the first of two decks on the stage-1 calibration captures. It covers what has to be bought and made before a capture session: two matte spheres, a flat board, their mountings on the robot flange, and a three-ball nest, with estimated costs and candidate suppliers. The second deck covers the test procedure itself and what the robot program must do. Both are summaries of the stage-1 capture procedure in docs/procedures, whose section 3a and appendix A hold the full build details.</a:t>
+              <a:t>This is the first of two decks on the stage-1 calibration captures. It covers what has to be bought and made before a capture session: one matte sphere, a flat board, their mountings on the robot flange, and a three-ball nest, with estimated costs and candidate suppliers. The second deck covers the test procedure itself and what the robot program must do. Both are summaries of the stage-1 capture procedure in docs/procedures, whose section 3a and appendix A hold the full build details.</a:t>
             </a:r>
             <a:endParaRPr lang="en-US" dirty="0"/>
           </a:p>
@@ -732,7 +732,7 @@
           <a:p>
             <a:r>
               <a:rPr lang="en-US" dirty="0"/>
-              <a:t>Where the sphere center ends up does not need to be known from drawings, because the tool-center-point routine measures it; what matters is that it does not move afterwards. The adapter plate's mounting face, outer face and tapped hole are machined in one lathe setup, located on the flange pilot, so the hole is perpendicular to the face within 0.02 mm over 100 mm. The stems are deliberately thick: a 12 mm stem would let sphere A sag about 0.07 mm, and that sag would change with the robot's orientation. The shoulder on the stem, machined square in the same setup as its thread, sets the stem perpendicular to the adapter. The dimensioned shop drawings are in appendix D of the stage-1 procedure, and as PNG files in docs/procedures/drawings/ of the repository: SC1-01 and SC1-02 adapter plates, SC1-03 and SC1-04 stems with the sphere interfaces, SC1-05 board adapter, SC1-06 nest base. The adapter plates are 63 mm across, 16 mm thick for sphere A and 22 mm for sphere B, with a 31.5 mm centering spigot and one 6 mm dowel for the ISO 9409-1-50-4-M6 flange.</a:t>
+              <a:t>Where the sphere center ends up does not need to be known from drawings, because the tool-center-point routine measures it; what matters is that it does not move afterwards. The adapter plate's mounting face, outer face and tapped hole are machined in one lathe setup, located on the flange pilot, so the hole is perpendicular to the face within 0.02 mm over 100 mm. The stem is deliberately thick: a 25 mm stem would let the sphere sag about 0.1 mm, and that sag would change with the robot's orientation. The shoulder on the stem, machined square in the same setup as its thread, sets the stem perpendicular to the adapter. The dimensioned shop drawings are in appendix D of the stage-1 procedure, and as PNG files in docs/procedures/drawings/ of the repository: SC1-02 adapter plate, SC1-04 stem with the sphere interface, SC1-05 board adapter, SC1-06 nest base (SC1-01 and SC1-03, for the former second sphere, are archived). The adapter plate is 63 mm across and 22 mm thick, with a 31.5 mm centering spigot and one 6 mm dowel for the ISO 9409-1-50-4-M6 flange.</a:t>
             </a:r>
             <a:endParaRPr lang="en-US" dirty="0"/>
           </a:p>
@@ -820,7 +820,7 @@
           <a:p>
             <a:r>
               <a:rPr lang="en-US" dirty="0"/>
-              <a:t>Precision ceramic spheres are sold with a threaded insert bonded in by the maker; the stem tip is turned to a matching thread with a small shoulder that seats on the flat around the insert, with a drop of medium-strength thread locker. Bearing-grade steel balls are hardened to about 60 HRC and cannot be tapped, so a shop makes a blind hole about 0.6 R deep by carbide drilling or electrical discharge machining, sized for a light press fit, and the stem is bonded in with anaerobic retaining compound. Never weld or braze: the heat distorts the sphere. A turned aluminum sphere B can have the stem thread cut into it when it is made. The dimensioned shop drawings are in appendix D of the stage-1 procedure, and as PNG files in docs/procedures/drawings/ of the repository: SC1-01 and SC1-02 adapter plates, SC1-03 and SC1-04 stems with the sphere interfaces, SC1-05 board adapter, SC1-06 nest base. </a:t>
+              <a:t>The turned aluminum sphere has an M20 x 30 mm hole tapped at a pole, with a 32 mm spot face, cut in the same setup in which it is turned. The stem's M20 tip threads in and its end seats on the spot face, with a drop of medium-strength thread locker. Only if the sphere is bought in steel or ceramic does the bonded alternative apply: hardened spheres cannot be tapped, so a shop makes a blind hole 16 H7 by 46 mm by carbide drilling or electrical discharge machining, sized for a light press fit, and the stem is bonded in with anaerobic retaining compound. Never weld or braze: the heat distorts the sphere. The dimensioned shop drawings are in appendix D of the stage-1 procedure, and as PNG files in docs/procedures/drawings/ of the repository: SC1-02 adapter plate, SC1-04 stem with the sphere interface, SC1-05 board adapter, SC1-06 nest base (SC1-01 and SC1-03, for the former second sphere, are archived).</a:t>
             </a:r>
             <a:endParaRPr lang="en-US" dirty="0"/>
           </a:p>
@@ -908,7 +908,7 @@
           <a:p>
             <a:r>
               <a:rPr lang="en-US" dirty="0"/>
-              <a:t>Thickness is not a stiffness question: a 6 mm plate sags only about 0.002 mm under its own weight. It only has to survive the finish and the mounting flat. Bead-blasting peens one face and bows a thin plate, so paint over the ground or glass surface instead. Flatness is checked last, after painting and mounting, because that is the state the sensor sees; the flatness report is also the reference for the board-flatness check in the validation. The dimensioned shop drawings are in appendix D of the stage-1 procedure, and as PNG files in docs/procedures/drawings/ of the repository: SC1-01 and SC1-02 adapter plates, SC1-03 and SC1-04 stems with the sphere interfaces, SC1-05 board adapter, SC1-06 nest base. </a:t>
+              <a:t>Thickness is not a stiffness question: a 6 mm plate sags only about 0.002 mm under its own weight. It only has to survive the finish and the mounting flat. Bead-blasting peens one face and bows a thin plate, so paint over the ground or glass surface instead. Flatness is checked last, after painting and mounting, because that is the state the sensor sees; the flatness report is also the reference for the board-flatness check in the validation. The dimensioned shop drawings are in appendix D of the stage-1 procedure, and as PNG files in docs/procedures/drawings/ of the repository: SC1-02 adapter plate, SC1-04 stem with the sphere interface, SC1-05 board adapter, SC1-06 nest base (SC1-01 and SC1-03, for the former second sphere, are archived).</a:t>
             </a:r>
             <a:endParaRPr lang="en-US" dirty="0"/>
           </a:p>
@@ -996,7 +996,7 @@
           <a:p>
             <a:r>
               <a:rPr lang="en-US" dirty="0"/>
-              <a:t>A sphere resting on three fixed balls always has its center at the same point in space, whatever direction its stem points. That is what lets the robot's own multi-orientation routine find the sphere's center as its tool center point, which deck 2 describes. The nest is simple to make: a steel base with three pockets, the balls bonded in, and holes to bolt it down. Its position matters only in that the robot must be able to seat the sphere from several directions. The dimensioned shop drawings are in appendix D of the stage-1 procedure, and as PNG files in docs/procedures/drawings/ of the repository: SC1-01 and SC1-02 adapter plates, SC1-03 and SC1-04 stems with the sphere interfaces, SC1-05 board adapter, SC1-06 nest base. </a:t>
+              <a:t>A sphere resting on three fixed balls always has its center at the same point in space, whatever direction its stem points. That is what lets the robot's own multi-orientation routine find the sphere's center as its tool center point, which deck 2 describes. The nest is simple to make: a steel base with three pockets, the balls bonded in, and holes to bolt it down. Its position matters only in that the robot must be able to seat the sphere from several directions. The dimensioned shop drawings are in appendix D of the stage-1 procedure, and as PNG files in docs/procedures/drawings/ of the repository: SC1-02 adapter plate, SC1-04 stem with the sphere interface, SC1-05 board adapter, SC1-06 nest base (SC1-01 and SC1-03, for the former second sphere, are archived).</a:t>
             </a:r>
             <a:endParaRPr lang="en-US" dirty="0"/>
           </a:p>
@@ -1084,7 +1084,7 @@
           <a:p>
             <a:r>
               <a:rPr lang="en-US" dirty="0"/>
-              <a:t>These are the build checks of sections 1 and 3a of the procedure, gathered in one place. Each one protects something the software cannot repair later: a crooked or bending stem moves the sphere center away from the measured tool center point, a shiny spot gives bad reads, and an unmeasured diameter or a bowed board puts a wrong reference into every observation. The fixture weights feed the robot's tool load data, which its absolute accuracy depends on. The dimensioned shop drawings are in appendix D of the stage-1 procedure, and as PNG files in docs/procedures/drawings/ of the repository: SC1-01 and SC1-02 adapter plates, SC1-03 and SC1-04 stems with the sphere interfaces, SC1-05 board adapter, SC1-06 nest base. </a:t>
+              <a:t>These are the only checks made in-house (decision D-18 of the analysis); every toleranced feature of the machined parts and of the sphere is in the fabricators' inspection reports, which are the as-built record. Each check protects something the software cannot repair later: a shiny spot gives bad reads, an unmeasured diameter or a bowed board puts a wrong reference into every observation, and a board face that is not square to the flange tilts every board pose. The run-out reading checks only that squareness; it cannot see a dished face, which is why flatness is checked with the straightedge. The fixture weights feed the robot's tool load data, which its absolute accuracy depends on. The dimensioned shop drawings are in appendix D of the stage-1 procedure, and as PNG files in docs/procedures/drawings/ of the repository: SC1-02 adapter plate, SC1-04 stem with the sphere interface, SC1-05 board adapter, SC1-06 nest base (SC1-01 and SC1-03, for the former second sphere, are archived).</a:t>
             </a:r>
             <a:endParaRPr lang="en-US" dirty="0"/>
           </a:p>
@@ -1172,7 +1172,7 @@
           <a:p>
             <a:r>
               <a:rPr lang="en-US" dirty="0"/>
-              <a:t>The calibration compares what the sensor measures with targets of known shape held at known poses by the robot. Two sphere sizes are used because the bias from averaging over a curved surface depends on curvature; two radii a factor of two apart let the correction map carry curvature as an input and remove that bias. Both spheres are used around 500 to 550 mm so the two radii overlap. The board supplies zero curvature and controlled tilts. A sphere's orientation does not matter, only its center, which is why the mounting must hold the center fixed rather than aim the sphere precisely.</a:t>
+              <a:t>The calibration compares what the sensor measures with targets of known shape held at known poses by the robot. The sensor averages depth over a patch of pixels, and on a curved surface that averaging biases the depth by an amount that depends on how curved the surface looks per pixel, not on its physical radius alone. Moving one sphere from 300 to 1,100 mm changes that apparent curvature more than thirteenfold, so one sphere swept through the volume measures the effect; a second, smaller sphere is no longer needed (decision D-15 of the analysis). What is given up is the cross-check two radii would give, that a small sphere near the sensor and a large one twice as far away show the same bias. The larger sphere is kept because it still covers enough pixels at 1,100 mm. The board supplies zero curvature and controlled tilts. A sphere's orientation does not matter, only its center, which is why the mounting must hold the center fixed rather than aim the sphere precisely.</a:t>
             </a:r>
             <a:endParaRPr lang="en-US" dirty="0"/>
           </a:p>
@@ -1260,7 +1260,7 @@
           <a:p>
             <a:r>
               <a:rPr lang="en-US" dirty="0"/>
-              <a:t>This is the complete list of apparatus to build before the first session, as section 1b of the procedure gives it. The dimensioned shop drawings are in appendix D of the stage-1 procedure, and as PNG files in docs/procedures/drawings/ of the repository: SC1-01 and SC1-02 adapter plates, SC1-03 and SC1-04 stems with the sphere interfaces, SC1-05 board adapter, SC1-06 nest base. The rigid sensor mount is built from the existing drawing from previous work. The run-out fixture needs no drawing: it is a bought dial indicator on a bought magnetic base, standing on a plain steel plate bolted to the table. Everything already in hand, everything to buy and the preparation tasks are on the following slides and in sections 1a, 1c and 1f.</a:t>
+              <a:t>This is the complete list of apparatus to build before the first session, as section 1b of the procedure gives it. Each purchase order asks the fabricator for an inspection report of the toleranced features on the drawing; those reports are the as-built record. The dimensioned shop drawings are in appendix D of the stage-1 procedure, and as PNG files in docs/procedures/drawings/ of the repository: SC1-02 adapter plate, SC1-04 stem with the sphere interface, SC1-05 board adapter, SC1-06 nest base (SC1-01 and SC1-03, for the former second sphere, are archived). The rigid sensor mount is built from the existing drawing from previous work. The run-out fixture needs no drawing: it is a bought dial indicator on a bought magnetic base, standing on a plain steel plate bolted to the table. Everything already in hand, everything to buy and the preparation tasks are on the following slides and in sections 1a, 1c and 1f.</a:t>
             </a:r>
             <a:endParaRPr lang="en-US" dirty="0"/>
           </a:p>
@@ -1348,7 +1348,7 @@
           <a:p>
             <a:r>
               <a:rPr lang="en-US" dirty="0"/>
-              <a:t>These are the tools and consumables, section 1c of the procedure. The two outside micrometers replace any laboratory measurement: the sphere diameters are measured in-house after the matte finish, at six or more orientations, and the spread of the readings doubles as the sphericity check. The micrometers come with setting standards, which are used to check them before each measurement. The straightedge with a 0.05 mm feeler leaf checks the board's flatness after painting and after mounting. Items already in hand are the sensor, the robot, the capture computer with its communication software, which also takes the capture trigger from the robot, and the analysis computer.</a:t>
+              <a:t>These are the tools and consumables, section 1c of the procedure. One outside micrometer, 150 to 175 mm, replaces any laboratory measurement: the sphere's diameter is measured in-house after the matte finish, at six or more orientations, and the spread of the readings doubles as the sphericity check. It comes with a setting standard, used to check it before each measurement. The straightedge with a 0.05 mm feeler leaf checks the board's flatness after painting and after mounting; the run-out on the robot checks only that the face is square to the flange, not that it is flat. These, the calipers for the board's size and the nest re-seat check are the only in-house checks; everything else is in the fabricators' inspection reports. Items already in hand are the sensor, the robot, the capture computer with its communication software, which also takes the capture trigger from the robot, and the analysis computer.</a:t>
             </a:r>
             <a:endParaRPr lang="en-US" dirty="0"/>
           </a:p>
@@ -1436,7 +1436,7 @@
           <a:p>
             <a:r>
               <a:rPr lang="en-US" dirty="0"/>
-              <a:t>These estimates come from suppliers' list prices where they exist and from typical job-shop rates of about 80 to 150 dollars an hour otherwise. The sphere figures no longer include a laboratory measurement: the diameters are measured in-house with the micrometers on the buy list. The two totals differ only in the spheres: a bearing ball with a bonded stem and a turned aluminum sphere, against both spheres made to order by a ball or ceramics maker. The rigid sensor mount is built from an existing drawing and is not estimated here. Quotes are needed before ordering, and the sphere choice is still to be settled after a canvass of the market.</a:t>
+              <a:t>These estimates come from suppliers' list prices where they exist and from typical job-shop rates of about 80 to 150 dollars an hour otherwise. With one sphere, one adapter plate, one stem and one micrometer are needed. The sphere figure includes no laboratory measurement: the diameter is measured in-house with the micrometer on the buy list. The two totals differ only in the sphere: turned in aluminum by a job shop with the thread cut in, against made to order by a ball or ceramics maker. The fabricators' inspection reports may carry a fee; ask for it in each quote. The rigid sensor mount is built from an existing drawing and is not estimated here. Quotes are needed before ordering.</a:t>
             </a:r>
             <a:endParaRPr lang="en-US" dirty="0"/>
           </a:p>
@@ -1524,7 +1524,7 @@
           <a:p>
             <a:r>
               <a:rPr lang="en-US" dirty="0"/>
-              <a:t>This is the purchase specification of section 1d of the procedure, to hand to a supplier or a machine shop. The diameter requirement is decision D-13: known to 0.025 mm after the matte finish, measured in-house with the outside micrometers; the mean of six or more readings goes in the pose log, and their spread checks the 0.02 mm sphericity. Aluminum grows 0.0035 mm in diameter per degree C at sphere B's size, so it is measured at the temperature of the session. The dimensioned shop drawings are in appendix D of the stage-1 procedure, and as PNG files in docs/procedures/drawings/ of the repository: SC1-01 and SC1-02 adapter plates, SC1-03 and SC1-04 stems with the sphere interfaces, SC1-05 board adapter, SC1-06 nest base. </a:t>
+              <a:t>This is the purchase specification of section 1d of the procedure, to hand to the shop that turns the sphere. The name sphere B is kept because the drawings and the related projects use it. The diameter requirement is decision D-13: known to 0.025 mm after the matte finish, measured in-house with the outside micrometer; the mean of six or more readings goes in the pose log, and their spread checks the 0.02 mm sphericity. Aluminum grows 0.0035 mm in diameter per degree C at this size, so it is measured at the temperature of the session. The dimensioned shop drawings are in appendix D of the stage-1 procedure, and as PNG files in docs/procedures/drawings/ of the repository: SC1-02 adapter plate, SC1-04 stem with the sphere interface, SC1-05 board adapter, SC1-06 nest base (SC1-01 and SC1-03, for the former second sphere, are archived).</a:t>
             </a:r>
             <a:endParaRPr lang="en-US" dirty="0"/>
           </a:p>
@@ -1612,7 +1612,7 @@
           <a:p>
             <a:r>
               <a:rPr lang="en-US" dirty="0"/>
-              <a:t>The board is checked flat after painting and after mounting because that is the state the sensor sees, and the flatness report is the reference for the board-flatness check in the validation. A 6 mm plate sags only about 0.002 mm under its own weight, so thickness is a matter of surviving the finish and the mounting, not stiffness. The bottom and left edges locate the board against the three edge pins of the board adapter, which centers it on the flange axis. The dimensioned shop drawings are in appendix D of the stage-1 procedure, and as PNG files in docs/procedures/drawings/ of the repository: SC1-01 and SC1-02 adapter plates, SC1-03 and SC1-04 stems with the sphere interfaces, SC1-05 board adapter, SC1-06 nest base. </a:t>
+              <a:t>The board is checked flat after painting and after mounting because that is the state the sensor sees, and the flatness report is the reference for the board-flatness check in the validation. A 6 mm plate sags only about 0.002 mm under its own weight, so thickness is a matter of surviving the finish and the mounting, not stiffness. The bottom and left edges locate the board against the three edge pins of the board adapter, which centers it on the flange axis. The dimensioned shop drawings are in appendix D of the stage-1 procedure, and as PNG files in docs/procedures/drawings/ of the repository: SC1-02 adapter plate, SC1-04 stem with the sphere interface, SC1-05 board adapter, SC1-06 nest base (SC1-01 and SC1-03, for the former second sphere, are archived).</a:t>
             </a:r>
             <a:endParaRPr lang="en-US" dirty="0"/>
           </a:p>
@@ -1700,7 +1700,7 @@
           <a:p>
             <a:r>
               <a:rPr lang="en-US" dirty="0"/>
-              <a:t>A mirror finish returns one bright highlight from the sensor's projector and almost nothing else, so every sphere must be made matte. Bead-blasting is preferred because it changes the diameter by only micrometers. The diameter requirement is decision D-13: known to 0.025 mm after finishing, which is a radius error of about 0.0125 mm, an eighth of the target at 500 mm; no maker's certificate is needed. The diameter is measured in-house with the outside micrometers; EDM means electrical discharge machining. Bearing-grade balls are hardened to about 60 HRC and cannot be tapped afterwards, which is why steel spheres get a bonded stem.</a:t>
+              <a:t>A mirror finish returns one bright highlight from the sensor's projector and almost nothing else, so the sphere must be matte; the hard anodize of the aluminum sphere gives that directly. The diameter requirement is decision D-13: known to 0.025 mm after finishing, which is a radius error of about 0.0125 mm, an eighth of the target at 500 mm; no maker's certificate is needed. The diameter is measured in-house with the outside micrometer. Only if the sphere is bought in steel or ceramic does the alternative mounting apply: such spheres are hardened and cannot be tapped, so they get a bonded stem.</a:t>
             </a:r>
             <a:endParaRPr lang="en-US" dirty="0"/>
           </a:p>
@@ -1788,7 +1788,7 @@
           <a:p>
             <a:r>
               <a:rPr lang="en-US" dirty="0"/>
-              <a:t>This list is appendix A of the procedure in brief. No supplier was found that stocks a precision sphere of the needed sizes with a mounting hole, so the spheres are either made to order or built from a bearing ball by a machine shop. The laser-scanner reference spheres sold in the right sizes generally have form errors of 0.5 to 2 mm, far too coarse; the Rothbucher sphere is the best specified of them. Appendix A limits both stock items: MetrologyWorks spheres (up to 1.5 inch) only if the engineer accepts a smaller sphere A, and the Rothbucher sphere only as a provisional far-range sphere B, measured in-house first; it is not adequate as sphere A or as the final sphere B. The finished diameters are measured in-house with outside micrometers, which is cheaper than buying certified spheres and is what the calibration actually needs.</a:t>
+              <a:t>This list is appendix A of the procedure in brief. No supplier was found that stocks a precision 6 inch sphere with a mounting hole, so the sphere is either turned in aluminum with the thread cut in, or made to order by a ball or ceramics maker. The laser-scanner reference spheres sold near this size have form errors of 0.3 to 2 mm; the Rothbucher sphere is the best specified of them, and even it is too coarse now that one sphere must serve near range too, where the depth-scaled target is 0.04 to 0.1 mm. The finished diameter is measured in-house with the outside micrometer, which is cheaper than buying a certified sphere and is what the calibration actually needs.</a:t>
             </a:r>
             <a:endParaRPr lang="en-US" dirty="0"/>
           </a:p>
@@ -2583,7 +2583,7 @@
                   <a:schemeClr val="accent6"/>
                 </a:solidFill>
               </a:rPr>
-              <a:t>The spheres, board and fixtures needed for the depth-sensor calibration captures</a:t>
+              <a:t>The sphere, board and fixtures needed for the depth-sensor calibration captures</a:t>
             </a:r>
             <a:endParaRPr lang="en-US" sz="2200" dirty="0"/>
           </a:p>
@@ -2694,38 +2694,13 @@
       </p:sp>
       <p:sp>
         <p:nvSpPr>
-          <p:cNvPr id="8" name="Graphic sphere A"/>
+          <p:cNvPr id="8" name="Graphic board"/>
           <p:cNvSpPr/>
           <p:nvPr/>
         </p:nvSpPr>
         <p:spPr>
           <a:xfrm>
-            <a:off x="3200400" y="4526280"/>
-            <a:ext cx="1234440" cy="1234440"/>
-          </a:xfrm>
-          <a:prstGeom prst="ellipse">
-            <a:avLst/>
-          </a:prstGeom>
-          <a:solidFill>
-            <a:schemeClr val="accent1"/>
-          </a:solidFill>
-          <a:ln w="25400">
-            <a:solidFill>
-              <a:schemeClr val="accent6"/>
-            </a:solidFill>
-            <a:prstDash val="solid"/>
-          </a:ln>
-        </p:spPr>
-      </p:sp>
-      <p:sp>
-        <p:nvSpPr>
-          <p:cNvPr id="9" name="Graphic board"/>
-          <p:cNvSpPr/>
-          <p:nvPr/>
-        </p:nvSpPr>
-        <p:spPr>
-          <a:xfrm>
-            <a:off x="4709160" y="4389120"/>
+            <a:off x="3200400" y="4389120"/>
             <a:ext cx="1920240" cy="1371600"/>
           </a:xfrm>
           <a:prstGeom prst="roundRect">
@@ -3484,7 +3459,7 @@
         <p:spPr>
           <a:xfrm>
             <a:off x="457200" y="1417320"/>
-            <a:ext cx="6301964" cy="4709160"/>
+            <a:ext cx="6384984" cy="4709160"/>
           </a:xfrm>
           <a:prstGeom prst="rect">
             <a:avLst/>
@@ -3500,7 +3475,7 @@
         <p:spPr>
           <a:xfrm>
             <a:off x="457200" y="1417320"/>
-            <a:ext cx="6301964" cy="4709160"/>
+            <a:ext cx="6384984" cy="4709160"/>
           </a:xfrm>
           <a:prstGeom prst="rect">
             <a:avLst/>
@@ -3521,8 +3496,8 @@
         </p:nvSpPr>
         <p:spPr>
           <a:xfrm>
-            <a:off x="7033484" y="1417320"/>
-            <a:ext cx="4701011" cy="3977640"/>
+            <a:off x="7116504" y="1417320"/>
+            <a:ext cx="4617991" cy="3977640"/>
           </a:xfrm>
           <a:prstGeom prst="roundRect">
             <a:avLst>
@@ -3543,8 +3518,8 @@
         </p:nvSpPr>
         <p:spPr>
           <a:xfrm>
-            <a:off x="7262084" y="1645920"/>
-            <a:ext cx="4243811" cy="3520440"/>
+            <a:off x="7345104" y="1645920"/>
+            <a:ext cx="4160791" cy="3520440"/>
           </a:xfrm>
           <a:prstGeom prst="rect">
             <a:avLst/>
@@ -3587,7 +3562,7 @@
                   <a:schemeClr val="tx1"/>
                 </a:solidFill>
               </a:rPr>
-              <a:t>Ground stem, 16 mm for A and 30 mm for B, keeps sag to 0.02 to 0.05 mm</a:t>
+              <a:t>Ground 30 mm stem keeps sag to about 0.05 mm</a:t>
             </a:r>
             <a:endParaRPr lang="en-US" sz="1600" dirty="0"/>
           </a:p>
@@ -3655,8 +3630,8 @@
         </p:nvSpPr>
         <p:spPr>
           <a:xfrm>
-            <a:off x="7033484" y="5669280"/>
-            <a:ext cx="4701011" cy="457200"/>
+            <a:off x="7116504" y="5669280"/>
+            <a:ext cx="4617991" cy="457200"/>
           </a:xfrm>
           <a:prstGeom prst="rect">
             <a:avLst/>
@@ -3788,7 +3763,7 @@
                 <a:ea typeface="+mj-lt" pitchFamily="34" charset="-122"/>
                 <a:cs typeface="+mj-lt" pitchFamily="34" charset="-120"/>
               </a:rPr>
-              <a:t>The sphere end: threaded insert or bonded stem</a:t>
+              <a:t>The sphere end: thread cut at the pole, or a bonded stem</a:t>
             </a:r>
             <a:endParaRPr lang="en-US" sz="3400" dirty="0"/>
           </a:p>
@@ -3811,7 +3786,7 @@
         <p:spPr>
           <a:xfrm>
             <a:off x="457200" y="1417320"/>
-            <a:ext cx="5132321" cy="3657600"/>
+            <a:ext cx="5134708" cy="3657600"/>
           </a:xfrm>
           <a:prstGeom prst="rect">
             <a:avLst/>
@@ -3827,7 +3802,7 @@
         <p:spPr>
           <a:xfrm>
             <a:off x="457200" y="1417320"/>
-            <a:ext cx="5132321" cy="3657600"/>
+            <a:ext cx="5134708" cy="3657600"/>
           </a:xfrm>
           <a:prstGeom prst="rect">
             <a:avLst/>
@@ -3856,8 +3831,8 @@
         </p:blipFill>
         <p:spPr>
           <a:xfrm>
-            <a:off x="6711683" y="1417320"/>
-            <a:ext cx="5022812" cy="3657600"/>
+            <a:off x="6747498" y="1417320"/>
+            <a:ext cx="4986997" cy="3657600"/>
           </a:xfrm>
           <a:prstGeom prst="rect">
             <a:avLst/>
@@ -3872,8 +3847,8 @@
         </p:nvSpPr>
         <p:spPr>
           <a:xfrm>
-            <a:off x="6711683" y="1417320"/>
-            <a:ext cx="5022812" cy="3657600"/>
+            <a:off x="6747498" y="1417320"/>
+            <a:ext cx="4986997" cy="3657600"/>
           </a:xfrm>
           <a:prstGeom prst="rect">
             <a:avLst/>
@@ -3895,7 +3870,7 @@
         <p:spPr>
           <a:xfrm>
             <a:off x="457200" y="5257800"/>
-            <a:ext cx="5132321" cy="320040"/>
+            <a:ext cx="5134708" cy="320040"/>
           </a:xfrm>
           <a:prstGeom prst="rect">
             <a:avLst/>
@@ -3916,7 +3891,7 @@
                   <a:schemeClr val="tx2"/>
                 </a:solidFill>
               </a:rPr>
-              <a:t>Ceramic sphere: maker's threaded insert</a:t>
+              <a:t>Aluminum sphere B: thread cut at the pole</a:t>
             </a:r>
             <a:endParaRPr lang="en-US" sz="1600" dirty="0"/>
           </a:p>
@@ -3930,8 +3905,8 @@
         </p:nvSpPr>
         <p:spPr>
           <a:xfrm>
-            <a:off x="6711683" y="5257800"/>
-            <a:ext cx="5022812" cy="320040"/>
+            <a:off x="6747498" y="5257800"/>
+            <a:ext cx="4986997" cy="320040"/>
           </a:xfrm>
           <a:prstGeom prst="rect">
             <a:avLst/>
@@ -3952,7 +3927,7 @@
                   <a:schemeClr val="tx2"/>
                 </a:solidFill>
               </a:rPr>
-              <a:t>Steel sphere: bonded blind hole</a:t>
+              <a:t>Steel or ceramic alternative: bonded blind hole</a:t>
             </a:r>
             <a:endParaRPr lang="en-US" sz="1600" dirty="0"/>
           </a:p>
@@ -4756,7 +4731,7 @@
                 <a:ea typeface="+mj-lt" pitchFamily="34" charset="-122"/>
                 <a:cs typeface="+mj-lt" pitchFamily="34" charset="-120"/>
               </a:rPr>
-              <a:t>A three-ball nest holds each sphere at a fixed center</a:t>
+              <a:t>A three-ball nest holds the sphere at a fixed center</a:t>
             </a:r>
             <a:endParaRPr lang="en-US" sz="3400" dirty="0"/>
           </a:p>
@@ -5574,7 +5549,7 @@
                   <a:schemeClr val="tx1"/>
                 </a:solidFill>
               </a:rPr>
-              <a:t>Used once per sphere at setup, and after any remount of an adapter or stem</a:t>
+              <a:t>Used once at setup, and after any remount of the adapter or stem</a:t>
             </a:r>
             <a:endParaRPr lang="en-US" sz="1600" dirty="0"/>
           </a:p>
@@ -5745,7 +5720,7 @@
                   <a:schemeClr val="tx1"/>
                 </a:solidFill>
               </a:rPr>
-              <a:t>Adapter plates, stems, board adapter and nest base made to drawings SC1-01 to SC1-06</a:t>
+              <a:t>Fabricator's inspection report received for the sphere and for SC1-02, SC1-04, SC1-05 and SC1-06</a:t>
             </a:r>
             <a:endParaRPr lang="en-US" sz="1600" dirty="0"/>
           </a:p>
@@ -5805,7 +5780,7 @@
                   <a:schemeClr val="tx1"/>
                 </a:solidFill>
               </a:rPr>
-              <a:t>Adapter thread square to its stem-side face within 0.02 mm over 100 mm</a:t>
+              <a:t>Sphere matte, uniform and free of highlights</a:t>
             </a:r>
             <a:endParaRPr lang="en-US" sz="1600" dirty="0"/>
           </a:p>
@@ -5865,7 +5840,7 @@
                   <a:schemeClr val="tx1"/>
                 </a:solidFill>
               </a:rPr>
-              <a:t>Each stem straight: check against the straightedge</a:t>
+              <a:t>Sphere diameter and sphericity by micrometer after finishing: spread within 0.02 mm, temperature recorded</a:t>
             </a:r>
             <a:endParaRPr lang="en-US" sz="1600" dirty="0"/>
           </a:p>
@@ -5925,7 +5900,7 @@
                   <a:schemeClr val="tx1"/>
                 </a:solidFill>
               </a:rPr>
-              <a:t>Both spheres matte, uniform and free of highlights</a:t>
+              <a:t>Board flat to 0.05 mm by straightedge and feeler leaf, after painting and mounting</a:t>
             </a:r>
             <a:endParaRPr lang="en-US" sz="1600" dirty="0"/>
           </a:p>
@@ -5985,7 +5960,7 @@
                   <a:schemeClr val="tx1"/>
                 </a:solidFill>
               </a:rPr>
-              <a:t>Each sphere diameter measured by micrometer after finishing, spread within 0.02 mm, temperature recorded</a:t>
+              <a:t>Board width and length measured with calipers</a:t>
             </a:r>
             <a:endParaRPr lang="en-US" sz="1600" dirty="0"/>
           </a:p>
@@ -6045,7 +6020,7 @@
                   <a:schemeClr val="tx1"/>
                 </a:solidFill>
               </a:rPr>
-              <a:t>Board flat to 0.05 mm after painting and mounting</a:t>
+              <a:t>At setup (deck 2): board run-out within 0.05 mm on the robot; nest re-seat within 0.1 mm</a:t>
             </a:r>
             <a:endParaRPr lang="en-US" sz="1600" dirty="0"/>
           </a:p>
@@ -6105,7 +6080,7 @@
                   <a:schemeClr val="tx1"/>
                 </a:solidFill>
               </a:rPr>
-              <a:t>Each fixture weighed for its tool load data; witness marks across each stem-adapter joint</a:t>
+              <a:t>Each fixture weighed for its tool load data; witness mark across the stem-adapter joint</a:t>
             </a:r>
             <a:endParaRPr lang="en-US" sz="1600" dirty="0"/>
           </a:p>
@@ -6282,7 +6257,7 @@
                 <a:ea typeface="+mj-lt" pitchFamily="34" charset="-122"/>
                 <a:cs typeface="+mj-lt" pitchFamily="34" charset="-120"/>
               </a:rPr>
-              <a:t>Two spheres and a board carry the known geometry</a:t>
+              <a:t>One sphere and a board carry the known geometry</a:t>
             </a:r>
             <a:endParaRPr lang="en-US" sz="3400" dirty="0"/>
           </a:p>
@@ -6331,8 +6306,8 @@
         </p:blipFill>
         <p:spPr>
           <a:xfrm>
-            <a:off x="685800" y="1997249"/>
-            <a:ext cx="6492240" cy="2909221"/>
+            <a:off x="685800" y="2060124"/>
+            <a:ext cx="6492240" cy="2783472"/>
           </a:xfrm>
           <a:prstGeom prst="rect">
             <a:avLst/>
@@ -6347,7 +6322,7 @@
         </p:nvSpPr>
         <p:spPr>
           <a:xfrm>
-            <a:off x="685800" y="5089351"/>
+            <a:off x="685800" y="5026476"/>
             <a:ext cx="6492240" cy="457200"/>
           </a:xfrm>
           <a:prstGeom prst="rect">
@@ -6450,122 +6425,6 @@
         <p:spPr>
           <a:xfrm>
             <a:off x="8732520" y="1645920"/>
-            <a:ext cx="2773375" cy="929640"/>
-          </a:xfrm>
-          <a:prstGeom prst="rect">
-            <a:avLst/>
-          </a:prstGeom>
-          <a:noFill/>
-          <a:ln/>
-        </p:spPr>
-        <p:txBody>
-          <a:bodyPr wrap="square" lIns="0" tIns="0" rIns="0" bIns="0" rtlCol="0" anchor="ctr"/>
-          <a:lstStyle/>
-          <a:p>
-            <a:pPr algn="l" indent="0" marL="0">
-              <a:buNone/>
-            </a:pPr>
-            <a:r>
-              <a:rPr lang="en-US" sz="1800" b="1" dirty="0">
-                <a:solidFill>
-                  <a:schemeClr val="tx2"/>
-                </a:solidFill>
-              </a:rPr>
-              <a:t>Sphere A</a:t>
-            </a:r>
-            <a:endParaRPr lang="en-US" sz="1600" dirty="0"/>
-          </a:p>
-          <a:p>
-            <a:pPr algn="l" indent="0" marL="0">
-              <a:buNone/>
-            </a:pPr>
-            <a:r>
-              <a:rPr lang="en-US" sz="1400" dirty="0">
-                <a:solidFill>
-                  <a:schemeClr val="tx1"/>
-                </a:solidFill>
-              </a:rPr>
-              <a:t>76.2 mm diameter; used from 300 to 550 mm</a:t>
-            </a:r>
-            <a:endParaRPr lang="en-US" sz="1600" dirty="0"/>
-          </a:p>
-        </p:txBody>
-      </p:sp>
-      <p:sp>
-        <p:nvSpPr>
-          <p:cNvPr id="10" name="Fixture 2 card"/>
-          <p:cNvSpPr/>
-          <p:nvPr/>
-        </p:nvSpPr>
-        <p:spPr>
-          <a:xfrm>
-            <a:off x="7680960" y="3078480"/>
-            <a:ext cx="4053535" cy="1386840"/>
-          </a:xfrm>
-          <a:prstGeom prst="roundRect">
-            <a:avLst>
-              <a:gd name="adj" fmla="val 7912"/>
-            </a:avLst>
-          </a:prstGeom>
-          <a:solidFill>
-            <a:schemeClr val="bg2"/>
-          </a:solidFill>
-          <a:ln/>
-        </p:spPr>
-      </p:sp>
-      <p:sp>
-        <p:nvSpPr>
-          <p:cNvPr id="11" name="Fixture 2 icon circle"/>
-          <p:cNvSpPr/>
-          <p:nvPr/>
-        </p:nvSpPr>
-        <p:spPr>
-          <a:xfrm>
-            <a:off x="7909560" y="3451860"/>
-            <a:ext cx="640080" cy="640080"/>
-          </a:xfrm>
-          <a:prstGeom prst="ellipse">
-            <a:avLst/>
-          </a:prstGeom>
-          <a:solidFill>
-            <a:schemeClr val="accent2"/>
-          </a:solidFill>
-          <a:ln/>
-        </p:spPr>
-      </p:sp>
-      <p:pic>
-        <p:nvPicPr>
-          <p:cNvPr id="12" name="Fixture 2 icon glyph" descr="circle icon">    </p:cNvPr>
-          <p:cNvPicPr>
-            <a:picLocks noChangeAspect="1"/>
-          </p:cNvPicPr>
-          <p:nvPr/>
-        </p:nvPicPr>
-        <p:blipFill>
-          <a:blip r:embed="rId3"/>
-          <a:stretch>
-            <a:fillRect/>
-          </a:stretch>
-        </p:blipFill>
-        <p:spPr>
-          <a:xfrm>
-            <a:off x="8069580" y="3611880"/>
-            <a:ext cx="320040" cy="320040"/>
-          </a:xfrm>
-          <a:prstGeom prst="rect">
-            <a:avLst/>
-          </a:prstGeom>
-        </p:spPr>
-      </p:pic>
-      <p:sp>
-        <p:nvSpPr>
-          <p:cNvPr id="13" name="Fixture 2 text"/>
-          <p:cNvSpPr txBox="1"/>
-          <p:nvPr/>
-        </p:nvSpPr>
-        <p:spPr>
-          <a:xfrm>
-            <a:off x="8732520" y="3307080"/>
             <a:ext cx="2773375" cy="929640"/>
           </a:xfrm>
           <a:prstGeom prst="rect">
@@ -6601,7 +6460,123 @@
                   <a:schemeClr val="tx1"/>
                 </a:solidFill>
               </a:rPr>
-              <a:t>152.4 mm diameter; used from 500 to 1,100 mm</a:t>
+              <a:t>152.4 mm diameter, turned aluminum, matte; the only sphere</a:t>
+            </a:r>
+            <a:endParaRPr lang="en-US" sz="1600" dirty="0"/>
+          </a:p>
+        </p:txBody>
+      </p:sp>
+      <p:sp>
+        <p:nvSpPr>
+          <p:cNvPr id="10" name="Fixture 2 card"/>
+          <p:cNvSpPr/>
+          <p:nvPr/>
+        </p:nvSpPr>
+        <p:spPr>
+          <a:xfrm>
+            <a:off x="7680960" y="3078480"/>
+            <a:ext cx="4053535" cy="1386840"/>
+          </a:xfrm>
+          <a:prstGeom prst="roundRect">
+            <a:avLst>
+              <a:gd name="adj" fmla="val 7912"/>
+            </a:avLst>
+          </a:prstGeom>
+          <a:solidFill>
+            <a:schemeClr val="bg2"/>
+          </a:solidFill>
+          <a:ln/>
+        </p:spPr>
+      </p:sp>
+      <p:sp>
+        <p:nvSpPr>
+          <p:cNvPr id="11" name="Fixture 2 icon circle"/>
+          <p:cNvSpPr/>
+          <p:nvPr/>
+        </p:nvSpPr>
+        <p:spPr>
+          <a:xfrm>
+            <a:off x="7909560" y="3451860"/>
+            <a:ext cx="640080" cy="640080"/>
+          </a:xfrm>
+          <a:prstGeom prst="ellipse">
+            <a:avLst/>
+          </a:prstGeom>
+          <a:solidFill>
+            <a:schemeClr val="accent2"/>
+          </a:solidFill>
+          <a:ln/>
+        </p:spPr>
+      </p:sp>
+      <p:pic>
+        <p:nvPicPr>
+          <p:cNvPr id="12" name="Fixture 2 icon glyph" descr="circle icon">    </p:cNvPr>
+          <p:cNvPicPr>
+            <a:picLocks noChangeAspect="1"/>
+          </p:cNvPicPr>
+          <p:nvPr/>
+        </p:nvPicPr>
+        <p:blipFill>
+          <a:blip r:embed="rId3"/>
+          <a:stretch>
+            <a:fillRect/>
+          </a:stretch>
+        </p:blipFill>
+        <p:spPr>
+          <a:xfrm>
+            <a:off x="8069580" y="3611880"/>
+            <a:ext cx="320040" cy="320040"/>
+          </a:xfrm>
+          <a:prstGeom prst="rect">
+            <a:avLst/>
+          </a:prstGeom>
+        </p:spPr>
+      </p:pic>
+      <p:sp>
+        <p:nvSpPr>
+          <p:cNvPr id="13" name="Fixture 2 text"/>
+          <p:cNvSpPr txBox="1"/>
+          <p:nvPr/>
+        </p:nvSpPr>
+        <p:spPr>
+          <a:xfrm>
+            <a:off x="8732520" y="3307080"/>
+            <a:ext cx="2773375" cy="929640"/>
+          </a:xfrm>
+          <a:prstGeom prst="rect">
+            <a:avLst/>
+          </a:prstGeom>
+          <a:noFill/>
+          <a:ln/>
+        </p:spPr>
+        <p:txBody>
+          <a:bodyPr wrap="square" lIns="0" tIns="0" rIns="0" bIns="0" rtlCol="0" anchor="ctr"/>
+          <a:lstStyle/>
+          <a:p>
+            <a:pPr algn="l" indent="0" marL="0">
+              <a:buNone/>
+            </a:pPr>
+            <a:r>
+              <a:rPr lang="en-US" sz="1800" b="1" dirty="0">
+                <a:solidFill>
+                  <a:schemeClr val="tx2"/>
+                </a:solidFill>
+              </a:rPr>
+              <a:t>Curvature sweep</a:t>
+            </a:r>
+            <a:endParaRPr lang="en-US" sz="1600" dirty="0"/>
+          </a:p>
+          <a:p>
+            <a:pPr algn="l" indent="0" marL="0">
+              <a:buNone/>
+            </a:pPr>
+            <a:r>
+              <a:rPr lang="en-US" sz="1400" dirty="0">
+                <a:solidFill>
+                  <a:schemeClr val="tx1"/>
+                </a:solidFill>
+              </a:rPr>
+              <a:t>Nine stations from 300 to 1,100 mm, each about 1.19 times farther than the last</a:t>
             </a:r>
             <a:endParaRPr lang="en-US" sz="1600" dirty="0"/>
           </a:p>
@@ -7046,7 +7021,7 @@
                   </a:tcPr>
                 </a:tc>
               </a:tr>
-              <a:tr h="455023">
+              <a:tr h="529046">
                 <a:tc>
                   <a:txBody>
                     <a:bodyPr/>
@@ -7061,7 +7036,7 @@
                             <a:schemeClr val="tx1"/>
                           </a:solidFill>
                         </a:rPr>
-                        <a:t>Sphere A with mounting interface</a:t>
+                        <a:t>Sphere B with mounting interface</a:t>
                       </a:r>
                       <a:endParaRPr lang="en-US" sz="1400" dirty="0"/>
                     </a:p>
@@ -7183,7 +7158,7 @@
                             <a:schemeClr val="tx1"/>
                           </a:solidFill>
                         </a:rPr>
-                        <a:t>SC1-03 (hole detail)</a:t>
+                        <a:t>SC1-04 (interface detail)</a:t>
                       </a:r>
                       <a:endParaRPr lang="en-US" sz="1400" dirty="0"/>
                     </a:p>
@@ -7231,7 +7206,7 @@
                   </a:tcPr>
                 </a:tc>
               </a:tr>
-              <a:tr h="455023">
+              <a:tr h="529046">
                 <a:tc>
                   <a:txBody>
                     <a:bodyPr/>
@@ -7246,7 +7221,377 @@
                             <a:schemeClr val="tx1"/>
                           </a:solidFill>
                         </a:rPr>
-                        <a:t>Sphere B with mounting interface</a:t>
+                        <a:t>Sphere-flange mount: adapter plate and stem</a:t>
+                      </a:r>
+                      <a:endParaRPr lang="en-US" sz="1400" dirty="0"/>
+                    </a:p>
+                  </a:txBody>
+                  <a:tcPr marL="109728" marR="109728" marT="45720" marB="45720" anchor="ctr">
+                    <a:lnL w="6350" cap="flat" cmpd="sng" algn="ctr">
+                      <a:solidFill>
+                        <a:schemeClr val="accent6"/>
+                      </a:solidFill>
+                      <a:prstDash val="solid"/>
+                      <a:round/>
+                      <a:headEnd type="none" w="med" len="med"/>
+                      <a:tailEnd type="none" w="med" len="med"/>
+                    </a:lnL>
+                    <a:lnR w="6350" cap="flat" cmpd="sng" algn="ctr">
+                      <a:solidFill>
+                        <a:schemeClr val="accent6"/>
+                      </a:solidFill>
+                      <a:prstDash val="solid"/>
+                      <a:round/>
+                      <a:headEnd type="none" w="med" len="med"/>
+                      <a:tailEnd type="none" w="med" len="med"/>
+                    </a:lnR>
+                    <a:lnT w="6350" cap="flat" cmpd="sng" algn="ctr">
+                      <a:solidFill>
+                        <a:schemeClr val="accent6"/>
+                      </a:solidFill>
+                      <a:prstDash val="solid"/>
+                      <a:round/>
+                      <a:headEnd type="none" w="med" len="med"/>
+                      <a:tailEnd type="none" w="med" len="med"/>
+                    </a:lnT>
+                    <a:lnB w="6350" cap="flat" cmpd="sng" algn="ctr">
+                      <a:solidFill>
+                        <a:schemeClr val="accent6"/>
+                      </a:solidFill>
+                      <a:prstDash val="solid"/>
+                      <a:round/>
+                      <a:headEnd type="none" w="med" len="med"/>
+                      <a:tailEnd type="none" w="med" len="med"/>
+                    </a:lnB>
+                    <a:solidFill>
+                      <a:schemeClr val="bg2"/>
+                    </a:solidFill>
+                  </a:tcPr>
+                </a:tc>
+                <a:tc>
+                  <a:txBody>
+                    <a:bodyPr/>
+                    <a:lstStyle/>
+                    <a:p>
+                      <a:pPr algn="l" indent="0" marL="0">
+                        <a:buNone/>
+                      </a:pPr>
+                      <a:r>
+                        <a:rPr lang="en-US" sz="1400" dirty="0">
+                          <a:solidFill>
+                            <a:schemeClr val="tx1"/>
+                          </a:solidFill>
+                        </a:rPr>
+                        <a:t>1 + 1</a:t>
+                      </a:r>
+                      <a:endParaRPr lang="en-US" sz="1400" dirty="0"/>
+                    </a:p>
+                  </a:txBody>
+                  <a:tcPr marL="109728" marR="109728" marT="45720" marB="45720" anchor="ctr">
+                    <a:lnL w="6350" cap="flat" cmpd="sng" algn="ctr">
+                      <a:solidFill>
+                        <a:schemeClr val="accent6"/>
+                      </a:solidFill>
+                      <a:prstDash val="solid"/>
+                      <a:round/>
+                      <a:headEnd type="none" w="med" len="med"/>
+                      <a:tailEnd type="none" w="med" len="med"/>
+                    </a:lnL>
+                    <a:lnR w="6350" cap="flat" cmpd="sng" algn="ctr">
+                      <a:solidFill>
+                        <a:schemeClr val="accent6"/>
+                      </a:solidFill>
+                      <a:prstDash val="solid"/>
+                      <a:round/>
+                      <a:headEnd type="none" w="med" len="med"/>
+                      <a:tailEnd type="none" w="med" len="med"/>
+                    </a:lnR>
+                    <a:lnT w="6350" cap="flat" cmpd="sng" algn="ctr">
+                      <a:solidFill>
+                        <a:schemeClr val="accent6"/>
+                      </a:solidFill>
+                      <a:prstDash val="solid"/>
+                      <a:round/>
+                      <a:headEnd type="none" w="med" len="med"/>
+                      <a:tailEnd type="none" w="med" len="med"/>
+                    </a:lnT>
+                    <a:lnB w="6350" cap="flat" cmpd="sng" algn="ctr">
+                      <a:solidFill>
+                        <a:schemeClr val="accent6"/>
+                      </a:solidFill>
+                      <a:prstDash val="solid"/>
+                      <a:round/>
+                      <a:headEnd type="none" w="med" len="med"/>
+                      <a:tailEnd type="none" w="med" len="med"/>
+                    </a:lnB>
+                    <a:solidFill>
+                      <a:schemeClr val="bg2"/>
+                    </a:solidFill>
+                  </a:tcPr>
+                </a:tc>
+                <a:tc>
+                  <a:txBody>
+                    <a:bodyPr/>
+                    <a:lstStyle/>
+                    <a:p>
+                      <a:pPr algn="l" indent="0" marL="0">
+                        <a:buNone/>
+                      </a:pPr>
+                      <a:r>
+                        <a:rPr lang="en-US" sz="1400" dirty="0">
+                          <a:solidFill>
+                            <a:schemeClr val="tx1"/>
+                          </a:solidFill>
+                        </a:rPr>
+                        <a:t>SC1-02, SC1-04</a:t>
+                      </a:r>
+                      <a:endParaRPr lang="en-US" sz="1400" dirty="0"/>
+                    </a:p>
+                  </a:txBody>
+                  <a:tcPr marL="109728" marR="109728" marT="45720" marB="45720" anchor="ctr">
+                    <a:lnL w="6350" cap="flat" cmpd="sng" algn="ctr">
+                      <a:solidFill>
+                        <a:schemeClr val="accent6"/>
+                      </a:solidFill>
+                      <a:prstDash val="solid"/>
+                      <a:round/>
+                      <a:headEnd type="none" w="med" len="med"/>
+                      <a:tailEnd type="none" w="med" len="med"/>
+                    </a:lnL>
+                    <a:lnR w="6350" cap="flat" cmpd="sng" algn="ctr">
+                      <a:solidFill>
+                        <a:schemeClr val="accent6"/>
+                      </a:solidFill>
+                      <a:prstDash val="solid"/>
+                      <a:round/>
+                      <a:headEnd type="none" w="med" len="med"/>
+                      <a:tailEnd type="none" w="med" len="med"/>
+                    </a:lnR>
+                    <a:lnT w="6350" cap="flat" cmpd="sng" algn="ctr">
+                      <a:solidFill>
+                        <a:schemeClr val="accent6"/>
+                      </a:solidFill>
+                      <a:prstDash val="solid"/>
+                      <a:round/>
+                      <a:headEnd type="none" w="med" len="med"/>
+                      <a:tailEnd type="none" w="med" len="med"/>
+                    </a:lnT>
+                    <a:lnB w="6350" cap="flat" cmpd="sng" algn="ctr">
+                      <a:solidFill>
+                        <a:schemeClr val="accent6"/>
+                      </a:solidFill>
+                      <a:prstDash val="solid"/>
+                      <a:round/>
+                      <a:headEnd type="none" w="med" len="med"/>
+                      <a:tailEnd type="none" w="med" len="med"/>
+                    </a:lnB>
+                    <a:solidFill>
+                      <a:schemeClr val="bg2"/>
+                    </a:solidFill>
+                  </a:tcPr>
+                </a:tc>
+              </a:tr>
+              <a:tr h="529046">
+                <a:tc>
+                  <a:txBody>
+                    <a:bodyPr/>
+                    <a:lstStyle/>
+                    <a:p>
+                      <a:pPr algn="l" indent="0" marL="0">
+                        <a:buNone/>
+                      </a:pPr>
+                      <a:r>
+                        <a:rPr lang="en-US" sz="1400" dirty="0">
+                          <a:solidFill>
+                            <a:schemeClr val="tx1"/>
+                          </a:solidFill>
+                        </a:rPr>
+                        <a:t>Flat target (board)</a:t>
+                      </a:r>
+                      <a:endParaRPr lang="en-US" sz="1400" dirty="0"/>
+                    </a:p>
+                  </a:txBody>
+                  <a:tcPr marL="109728" marR="109728" marT="45720" marB="45720" anchor="ctr">
+                    <a:lnL w="6350" cap="flat" cmpd="sng" algn="ctr">
+                      <a:solidFill>
+                        <a:schemeClr val="accent6"/>
+                      </a:solidFill>
+                      <a:prstDash val="solid"/>
+                      <a:round/>
+                      <a:headEnd type="none" w="med" len="med"/>
+                      <a:tailEnd type="none" w="med" len="med"/>
+                    </a:lnL>
+                    <a:lnR w="6350" cap="flat" cmpd="sng" algn="ctr">
+                      <a:solidFill>
+                        <a:schemeClr val="accent6"/>
+                      </a:solidFill>
+                      <a:prstDash val="solid"/>
+                      <a:round/>
+                      <a:headEnd type="none" w="med" len="med"/>
+                      <a:tailEnd type="none" w="med" len="med"/>
+                    </a:lnR>
+                    <a:lnT w="6350" cap="flat" cmpd="sng" algn="ctr">
+                      <a:solidFill>
+                        <a:schemeClr val="accent6"/>
+                      </a:solidFill>
+                      <a:prstDash val="solid"/>
+                      <a:round/>
+                      <a:headEnd type="none" w="med" len="med"/>
+                      <a:tailEnd type="none" w="med" len="med"/>
+                    </a:lnT>
+                    <a:lnB w="6350" cap="flat" cmpd="sng" algn="ctr">
+                      <a:solidFill>
+                        <a:schemeClr val="accent6"/>
+                      </a:solidFill>
+                      <a:prstDash val="solid"/>
+                      <a:round/>
+                      <a:headEnd type="none" w="med" len="med"/>
+                      <a:tailEnd type="none" w="med" len="med"/>
+                    </a:lnB>
+                    <a:solidFill>
+                      <a:schemeClr val="bg1"/>
+                    </a:solidFill>
+                  </a:tcPr>
+                </a:tc>
+                <a:tc>
+                  <a:txBody>
+                    <a:bodyPr/>
+                    <a:lstStyle/>
+                    <a:p>
+                      <a:pPr algn="l" indent="0" marL="0">
+                        <a:buNone/>
+                      </a:pPr>
+                      <a:r>
+                        <a:rPr lang="en-US" sz="1400" dirty="0">
+                          <a:solidFill>
+                            <a:schemeClr val="tx1"/>
+                          </a:solidFill>
+                        </a:rPr>
+                        <a:t>1</a:t>
+                      </a:r>
+                      <a:endParaRPr lang="en-US" sz="1400" dirty="0"/>
+                    </a:p>
+                  </a:txBody>
+                  <a:tcPr marL="109728" marR="109728" marT="45720" marB="45720" anchor="ctr">
+                    <a:lnL w="6350" cap="flat" cmpd="sng" algn="ctr">
+                      <a:solidFill>
+                        <a:schemeClr val="accent6"/>
+                      </a:solidFill>
+                      <a:prstDash val="solid"/>
+                      <a:round/>
+                      <a:headEnd type="none" w="med" len="med"/>
+                      <a:tailEnd type="none" w="med" len="med"/>
+                    </a:lnL>
+                    <a:lnR w="6350" cap="flat" cmpd="sng" algn="ctr">
+                      <a:solidFill>
+                        <a:schemeClr val="accent6"/>
+                      </a:solidFill>
+                      <a:prstDash val="solid"/>
+                      <a:round/>
+                      <a:headEnd type="none" w="med" len="med"/>
+                      <a:tailEnd type="none" w="med" len="med"/>
+                    </a:lnR>
+                    <a:lnT w="6350" cap="flat" cmpd="sng" algn="ctr">
+                      <a:solidFill>
+                        <a:schemeClr val="accent6"/>
+                      </a:solidFill>
+                      <a:prstDash val="solid"/>
+                      <a:round/>
+                      <a:headEnd type="none" w="med" len="med"/>
+                      <a:tailEnd type="none" w="med" len="med"/>
+                    </a:lnT>
+                    <a:lnB w="6350" cap="flat" cmpd="sng" algn="ctr">
+                      <a:solidFill>
+                        <a:schemeClr val="accent6"/>
+                      </a:solidFill>
+                      <a:prstDash val="solid"/>
+                      <a:round/>
+                      <a:headEnd type="none" w="med" len="med"/>
+                      <a:tailEnd type="none" w="med" len="med"/>
+                    </a:lnB>
+                    <a:solidFill>
+                      <a:schemeClr val="bg1"/>
+                    </a:solidFill>
+                  </a:tcPr>
+                </a:tc>
+                <a:tc>
+                  <a:txBody>
+                    <a:bodyPr/>
+                    <a:lstStyle/>
+                    <a:p>
+                      <a:pPr algn="l" indent="0" marL="0">
+                        <a:buNone/>
+                      </a:pPr>
+                      <a:r>
+                        <a:rPr lang="en-US" sz="1400" dirty="0">
+                          <a:solidFill>
+                            <a:schemeClr val="tx1"/>
+                          </a:solidFill>
+                        </a:rPr>
+                        <a:t>SC1-05 (outline)</a:t>
+                      </a:r>
+                      <a:endParaRPr lang="en-US" sz="1400" dirty="0"/>
+                    </a:p>
+                  </a:txBody>
+                  <a:tcPr marL="109728" marR="109728" marT="45720" marB="45720" anchor="ctr">
+                    <a:lnL w="6350" cap="flat" cmpd="sng" algn="ctr">
+                      <a:solidFill>
+                        <a:schemeClr val="accent6"/>
+                      </a:solidFill>
+                      <a:prstDash val="solid"/>
+                      <a:round/>
+                      <a:headEnd type="none" w="med" len="med"/>
+                      <a:tailEnd type="none" w="med" len="med"/>
+                    </a:lnL>
+                    <a:lnR w="6350" cap="flat" cmpd="sng" algn="ctr">
+                      <a:solidFill>
+                        <a:schemeClr val="accent6"/>
+                      </a:solidFill>
+                      <a:prstDash val="solid"/>
+                      <a:round/>
+                      <a:headEnd type="none" w="med" len="med"/>
+                      <a:tailEnd type="none" w="med" len="med"/>
+                    </a:lnR>
+                    <a:lnT w="6350" cap="flat" cmpd="sng" algn="ctr">
+                      <a:solidFill>
+                        <a:schemeClr val="accent6"/>
+                      </a:solidFill>
+                      <a:prstDash val="solid"/>
+                      <a:round/>
+                      <a:headEnd type="none" w="med" len="med"/>
+                      <a:tailEnd type="none" w="med" len="med"/>
+                    </a:lnT>
+                    <a:lnB w="6350" cap="flat" cmpd="sng" algn="ctr">
+                      <a:solidFill>
+                        <a:schemeClr val="accent6"/>
+                      </a:solidFill>
+                      <a:prstDash val="solid"/>
+                      <a:round/>
+                      <a:headEnd type="none" w="med" len="med"/>
+                      <a:tailEnd type="none" w="med" len="med"/>
+                    </a:lnB>
+                    <a:solidFill>
+                      <a:schemeClr val="bg1"/>
+                    </a:solidFill>
+                  </a:tcPr>
+                </a:tc>
+              </a:tr>
+              <a:tr h="529046">
+                <a:tc>
+                  <a:txBody>
+                    <a:bodyPr/>
+                    <a:lstStyle/>
+                    <a:p>
+                      <a:pPr algn="l" indent="0" marL="0">
+                        <a:buNone/>
+                      </a:pPr>
+                      <a:r>
+                        <a:rPr lang="en-US" sz="1400" dirty="0">
+                          <a:solidFill>
+                            <a:schemeClr val="tx1"/>
+                          </a:solidFill>
+                        </a:rPr>
+                        <a:t>Flat-target mount (board adapter)</a:t>
                       </a:r>
                       <a:endParaRPr lang="en-US" sz="1400" dirty="0"/>
                     </a:p>
@@ -7368,7 +7713,7 @@
                             <a:schemeClr val="tx1"/>
                           </a:solidFill>
                         </a:rPr>
-                        <a:t>SC1-04 (interface detail)</a:t>
+                        <a:t>SC1-05</a:t>
                       </a:r>
                       <a:endParaRPr lang="en-US" sz="1400" dirty="0"/>
                     </a:p>
@@ -7416,7 +7761,7 @@
                   </a:tcPr>
                 </a:tc>
               </a:tr>
-              <a:tr h="455023">
+              <a:tr h="529046">
                 <a:tc>
                   <a:txBody>
                     <a:bodyPr/>
@@ -7431,7 +7776,7 @@
                             <a:schemeClr val="tx1"/>
                           </a:solidFill>
                         </a:rPr>
-                        <a:t>Sphere-flange mounts: adapter plates and stems</a:t>
+                        <a:t>Three-ball bed (nest)</a:t>
                       </a:r>
                       <a:endParaRPr lang="en-US" sz="1400" dirty="0"/>
                     </a:p>
@@ -7492,7 +7837,7 @@
                             <a:schemeClr val="tx1"/>
                           </a:solidFill>
                         </a:rPr>
-                        <a:t>2 + 2</a:t>
+                        <a:t>1</a:t>
                       </a:r>
                       <a:endParaRPr lang="en-US" sz="1400" dirty="0"/>
                     </a:p>
@@ -7553,7 +7898,7 @@
                             <a:schemeClr val="tx1"/>
                           </a:solidFill>
                         </a:rPr>
-                        <a:t>SC1-01 to SC1-04</a:t>
+                        <a:t>SC1-06</a:t>
                       </a:r>
                       <a:endParaRPr lang="en-US" sz="1400" dirty="0"/>
                     </a:p>
@@ -7601,7 +7946,7 @@
                   </a:tcPr>
                 </a:tc>
               </a:tr>
-              <a:tr h="455023">
+              <a:tr h="529046">
                 <a:tc>
                   <a:txBody>
                     <a:bodyPr/>
@@ -7616,7 +7961,7 @@
                             <a:schemeClr val="tx1"/>
                           </a:solidFill>
                         </a:rPr>
-                        <a:t>Flat target (board)</a:t>
+                        <a:t>Run-out fixture: dial indicator on a magnetic base and steel base plate</a:t>
                       </a:r>
                       <a:endParaRPr lang="en-US" sz="1400" dirty="0"/>
                     </a:p>
@@ -7738,7 +8083,7 @@
                             <a:schemeClr val="tx1"/>
                           </a:solidFill>
                         </a:rPr>
-                        <a:t>SC1-05 (outline)</a:t>
+                        <a:t>none needed</a:t>
                       </a:r>
                       <a:endParaRPr lang="en-US" sz="1400" dirty="0"/>
                     </a:p>
@@ -7786,7 +8131,7 @@
                   </a:tcPr>
                 </a:tc>
               </a:tr>
-              <a:tr h="455023">
+              <a:tr h="529046">
                 <a:tc>
                   <a:txBody>
                     <a:bodyPr/>
@@ -7801,7 +8146,7 @@
                             <a:schemeClr val="tx1"/>
                           </a:solidFill>
                         </a:rPr>
-                        <a:t>Flat-target mount (board adapter)</a:t>
+                        <a:t>Rigid sensor mount</a:t>
                       </a:r>
                       <a:endParaRPr lang="en-US" sz="1400" dirty="0"/>
                     </a:p>
@@ -7923,561 +8268,6 @@
                             <a:schemeClr val="tx1"/>
                           </a:solidFill>
                         </a:rPr>
-                        <a:t>SC1-05</a:t>
-                      </a:r>
-                      <a:endParaRPr lang="en-US" sz="1400" dirty="0"/>
-                    </a:p>
-                  </a:txBody>
-                  <a:tcPr marL="109728" marR="109728" marT="45720" marB="45720" anchor="ctr">
-                    <a:lnL w="6350" cap="flat" cmpd="sng" algn="ctr">
-                      <a:solidFill>
-                        <a:schemeClr val="accent6"/>
-                      </a:solidFill>
-                      <a:prstDash val="solid"/>
-                      <a:round/>
-                      <a:headEnd type="none" w="med" len="med"/>
-                      <a:tailEnd type="none" w="med" len="med"/>
-                    </a:lnL>
-                    <a:lnR w="6350" cap="flat" cmpd="sng" algn="ctr">
-                      <a:solidFill>
-                        <a:schemeClr val="accent6"/>
-                      </a:solidFill>
-                      <a:prstDash val="solid"/>
-                      <a:round/>
-                      <a:headEnd type="none" w="med" len="med"/>
-                      <a:tailEnd type="none" w="med" len="med"/>
-                    </a:lnR>
-                    <a:lnT w="6350" cap="flat" cmpd="sng" algn="ctr">
-                      <a:solidFill>
-                        <a:schemeClr val="accent6"/>
-                      </a:solidFill>
-                      <a:prstDash val="solid"/>
-                      <a:round/>
-                      <a:headEnd type="none" w="med" len="med"/>
-                      <a:tailEnd type="none" w="med" len="med"/>
-                    </a:lnT>
-                    <a:lnB w="6350" cap="flat" cmpd="sng" algn="ctr">
-                      <a:solidFill>
-                        <a:schemeClr val="accent6"/>
-                      </a:solidFill>
-                      <a:prstDash val="solid"/>
-                      <a:round/>
-                      <a:headEnd type="none" w="med" len="med"/>
-                      <a:tailEnd type="none" w="med" len="med"/>
-                    </a:lnB>
-                    <a:solidFill>
-                      <a:schemeClr val="bg1"/>
-                    </a:solidFill>
-                  </a:tcPr>
-                </a:tc>
-              </a:tr>
-              <a:tr h="455023">
-                <a:tc>
-                  <a:txBody>
-                    <a:bodyPr/>
-                    <a:lstStyle/>
-                    <a:p>
-                      <a:pPr algn="l" indent="0" marL="0">
-                        <a:buNone/>
-                      </a:pPr>
-                      <a:r>
-                        <a:rPr lang="en-US" sz="1400" dirty="0">
-                          <a:solidFill>
-                            <a:schemeClr val="tx1"/>
-                          </a:solidFill>
-                        </a:rPr>
-                        <a:t>Three-ball bed (nest)</a:t>
-                      </a:r>
-                      <a:endParaRPr lang="en-US" sz="1400" dirty="0"/>
-                    </a:p>
-                  </a:txBody>
-                  <a:tcPr marL="109728" marR="109728" marT="45720" marB="45720" anchor="ctr">
-                    <a:lnL w="6350" cap="flat" cmpd="sng" algn="ctr">
-                      <a:solidFill>
-                        <a:schemeClr val="accent6"/>
-                      </a:solidFill>
-                      <a:prstDash val="solid"/>
-                      <a:round/>
-                      <a:headEnd type="none" w="med" len="med"/>
-                      <a:tailEnd type="none" w="med" len="med"/>
-                    </a:lnL>
-                    <a:lnR w="6350" cap="flat" cmpd="sng" algn="ctr">
-                      <a:solidFill>
-                        <a:schemeClr val="accent6"/>
-                      </a:solidFill>
-                      <a:prstDash val="solid"/>
-                      <a:round/>
-                      <a:headEnd type="none" w="med" len="med"/>
-                      <a:tailEnd type="none" w="med" len="med"/>
-                    </a:lnR>
-                    <a:lnT w="6350" cap="flat" cmpd="sng" algn="ctr">
-                      <a:solidFill>
-                        <a:schemeClr val="accent6"/>
-                      </a:solidFill>
-                      <a:prstDash val="solid"/>
-                      <a:round/>
-                      <a:headEnd type="none" w="med" len="med"/>
-                      <a:tailEnd type="none" w="med" len="med"/>
-                    </a:lnT>
-                    <a:lnB w="6350" cap="flat" cmpd="sng" algn="ctr">
-                      <a:solidFill>
-                        <a:schemeClr val="accent6"/>
-                      </a:solidFill>
-                      <a:prstDash val="solid"/>
-                      <a:round/>
-                      <a:headEnd type="none" w="med" len="med"/>
-                      <a:tailEnd type="none" w="med" len="med"/>
-                    </a:lnB>
-                    <a:solidFill>
-                      <a:schemeClr val="bg2"/>
-                    </a:solidFill>
-                  </a:tcPr>
-                </a:tc>
-                <a:tc>
-                  <a:txBody>
-                    <a:bodyPr/>
-                    <a:lstStyle/>
-                    <a:p>
-                      <a:pPr algn="l" indent="0" marL="0">
-                        <a:buNone/>
-                      </a:pPr>
-                      <a:r>
-                        <a:rPr lang="en-US" sz="1400" dirty="0">
-                          <a:solidFill>
-                            <a:schemeClr val="tx1"/>
-                          </a:solidFill>
-                        </a:rPr>
-                        <a:t>1</a:t>
-                      </a:r>
-                      <a:endParaRPr lang="en-US" sz="1400" dirty="0"/>
-                    </a:p>
-                  </a:txBody>
-                  <a:tcPr marL="109728" marR="109728" marT="45720" marB="45720" anchor="ctr">
-                    <a:lnL w="6350" cap="flat" cmpd="sng" algn="ctr">
-                      <a:solidFill>
-                        <a:schemeClr val="accent6"/>
-                      </a:solidFill>
-                      <a:prstDash val="solid"/>
-                      <a:round/>
-                      <a:headEnd type="none" w="med" len="med"/>
-                      <a:tailEnd type="none" w="med" len="med"/>
-                    </a:lnL>
-                    <a:lnR w="6350" cap="flat" cmpd="sng" algn="ctr">
-                      <a:solidFill>
-                        <a:schemeClr val="accent6"/>
-                      </a:solidFill>
-                      <a:prstDash val="solid"/>
-                      <a:round/>
-                      <a:headEnd type="none" w="med" len="med"/>
-                      <a:tailEnd type="none" w="med" len="med"/>
-                    </a:lnR>
-                    <a:lnT w="6350" cap="flat" cmpd="sng" algn="ctr">
-                      <a:solidFill>
-                        <a:schemeClr val="accent6"/>
-                      </a:solidFill>
-                      <a:prstDash val="solid"/>
-                      <a:round/>
-                      <a:headEnd type="none" w="med" len="med"/>
-                      <a:tailEnd type="none" w="med" len="med"/>
-                    </a:lnT>
-                    <a:lnB w="6350" cap="flat" cmpd="sng" algn="ctr">
-                      <a:solidFill>
-                        <a:schemeClr val="accent6"/>
-                      </a:solidFill>
-                      <a:prstDash val="solid"/>
-                      <a:round/>
-                      <a:headEnd type="none" w="med" len="med"/>
-                      <a:tailEnd type="none" w="med" len="med"/>
-                    </a:lnB>
-                    <a:solidFill>
-                      <a:schemeClr val="bg2"/>
-                    </a:solidFill>
-                  </a:tcPr>
-                </a:tc>
-                <a:tc>
-                  <a:txBody>
-                    <a:bodyPr/>
-                    <a:lstStyle/>
-                    <a:p>
-                      <a:pPr algn="l" indent="0" marL="0">
-                        <a:buNone/>
-                      </a:pPr>
-                      <a:r>
-                        <a:rPr lang="en-US" sz="1400" dirty="0">
-                          <a:solidFill>
-                            <a:schemeClr val="tx1"/>
-                          </a:solidFill>
-                        </a:rPr>
-                        <a:t>SC1-06</a:t>
-                      </a:r>
-                      <a:endParaRPr lang="en-US" sz="1400" dirty="0"/>
-                    </a:p>
-                  </a:txBody>
-                  <a:tcPr marL="109728" marR="109728" marT="45720" marB="45720" anchor="ctr">
-                    <a:lnL w="6350" cap="flat" cmpd="sng" algn="ctr">
-                      <a:solidFill>
-                        <a:schemeClr val="accent6"/>
-                      </a:solidFill>
-                      <a:prstDash val="solid"/>
-                      <a:round/>
-                      <a:headEnd type="none" w="med" len="med"/>
-                      <a:tailEnd type="none" w="med" len="med"/>
-                    </a:lnL>
-                    <a:lnR w="6350" cap="flat" cmpd="sng" algn="ctr">
-                      <a:solidFill>
-                        <a:schemeClr val="accent6"/>
-                      </a:solidFill>
-                      <a:prstDash val="solid"/>
-                      <a:round/>
-                      <a:headEnd type="none" w="med" len="med"/>
-                      <a:tailEnd type="none" w="med" len="med"/>
-                    </a:lnR>
-                    <a:lnT w="6350" cap="flat" cmpd="sng" algn="ctr">
-                      <a:solidFill>
-                        <a:schemeClr val="accent6"/>
-                      </a:solidFill>
-                      <a:prstDash val="solid"/>
-                      <a:round/>
-                      <a:headEnd type="none" w="med" len="med"/>
-                      <a:tailEnd type="none" w="med" len="med"/>
-                    </a:lnT>
-                    <a:lnB w="6350" cap="flat" cmpd="sng" algn="ctr">
-                      <a:solidFill>
-                        <a:schemeClr val="accent6"/>
-                      </a:solidFill>
-                      <a:prstDash val="solid"/>
-                      <a:round/>
-                      <a:headEnd type="none" w="med" len="med"/>
-                      <a:tailEnd type="none" w="med" len="med"/>
-                    </a:lnB>
-                    <a:solidFill>
-                      <a:schemeClr val="bg2"/>
-                    </a:solidFill>
-                  </a:tcPr>
-                </a:tc>
-              </a:tr>
-              <a:tr h="518160">
-                <a:tc>
-                  <a:txBody>
-                    <a:bodyPr/>
-                    <a:lstStyle/>
-                    <a:p>
-                      <a:pPr algn="l" indent="0" marL="0">
-                        <a:buNone/>
-                      </a:pPr>
-                      <a:r>
-                        <a:rPr lang="en-US" sz="1400" dirty="0">
-                          <a:solidFill>
-                            <a:schemeClr val="tx1"/>
-                          </a:solidFill>
-                        </a:rPr>
-                        <a:t>Run-out fixture: dial indicator on a magnetic base and steel base plate</a:t>
-                      </a:r>
-                      <a:endParaRPr lang="en-US" sz="1400" dirty="0"/>
-                    </a:p>
-                  </a:txBody>
-                  <a:tcPr marL="109728" marR="109728" marT="45720" marB="45720" anchor="ctr">
-                    <a:lnL w="6350" cap="flat" cmpd="sng" algn="ctr">
-                      <a:solidFill>
-                        <a:schemeClr val="accent6"/>
-                      </a:solidFill>
-                      <a:prstDash val="solid"/>
-                      <a:round/>
-                      <a:headEnd type="none" w="med" len="med"/>
-                      <a:tailEnd type="none" w="med" len="med"/>
-                    </a:lnL>
-                    <a:lnR w="6350" cap="flat" cmpd="sng" algn="ctr">
-                      <a:solidFill>
-                        <a:schemeClr val="accent6"/>
-                      </a:solidFill>
-                      <a:prstDash val="solid"/>
-                      <a:round/>
-                      <a:headEnd type="none" w="med" len="med"/>
-                      <a:tailEnd type="none" w="med" len="med"/>
-                    </a:lnR>
-                    <a:lnT w="6350" cap="flat" cmpd="sng" algn="ctr">
-                      <a:solidFill>
-                        <a:schemeClr val="accent6"/>
-                      </a:solidFill>
-                      <a:prstDash val="solid"/>
-                      <a:round/>
-                      <a:headEnd type="none" w="med" len="med"/>
-                      <a:tailEnd type="none" w="med" len="med"/>
-                    </a:lnT>
-                    <a:lnB w="6350" cap="flat" cmpd="sng" algn="ctr">
-                      <a:solidFill>
-                        <a:schemeClr val="accent6"/>
-                      </a:solidFill>
-                      <a:prstDash val="solid"/>
-                      <a:round/>
-                      <a:headEnd type="none" w="med" len="med"/>
-                      <a:tailEnd type="none" w="med" len="med"/>
-                    </a:lnB>
-                    <a:solidFill>
-                      <a:schemeClr val="bg1"/>
-                    </a:solidFill>
-                  </a:tcPr>
-                </a:tc>
-                <a:tc>
-                  <a:txBody>
-                    <a:bodyPr/>
-                    <a:lstStyle/>
-                    <a:p>
-                      <a:pPr algn="l" indent="0" marL="0">
-                        <a:buNone/>
-                      </a:pPr>
-                      <a:r>
-                        <a:rPr lang="en-US" sz="1400" dirty="0">
-                          <a:solidFill>
-                            <a:schemeClr val="tx1"/>
-                          </a:solidFill>
-                        </a:rPr>
-                        <a:t>1</a:t>
-                      </a:r>
-                      <a:endParaRPr lang="en-US" sz="1400" dirty="0"/>
-                    </a:p>
-                  </a:txBody>
-                  <a:tcPr marL="109728" marR="109728" marT="45720" marB="45720" anchor="ctr">
-                    <a:lnL w="6350" cap="flat" cmpd="sng" algn="ctr">
-                      <a:solidFill>
-                        <a:schemeClr val="accent6"/>
-                      </a:solidFill>
-                      <a:prstDash val="solid"/>
-                      <a:round/>
-                      <a:headEnd type="none" w="med" len="med"/>
-                      <a:tailEnd type="none" w="med" len="med"/>
-                    </a:lnL>
-                    <a:lnR w="6350" cap="flat" cmpd="sng" algn="ctr">
-                      <a:solidFill>
-                        <a:schemeClr val="accent6"/>
-                      </a:solidFill>
-                      <a:prstDash val="solid"/>
-                      <a:round/>
-                      <a:headEnd type="none" w="med" len="med"/>
-                      <a:tailEnd type="none" w="med" len="med"/>
-                    </a:lnR>
-                    <a:lnT w="6350" cap="flat" cmpd="sng" algn="ctr">
-                      <a:solidFill>
-                        <a:schemeClr val="accent6"/>
-                      </a:solidFill>
-                      <a:prstDash val="solid"/>
-                      <a:round/>
-                      <a:headEnd type="none" w="med" len="med"/>
-                      <a:tailEnd type="none" w="med" len="med"/>
-                    </a:lnT>
-                    <a:lnB w="6350" cap="flat" cmpd="sng" algn="ctr">
-                      <a:solidFill>
-                        <a:schemeClr val="accent6"/>
-                      </a:solidFill>
-                      <a:prstDash val="solid"/>
-                      <a:round/>
-                      <a:headEnd type="none" w="med" len="med"/>
-                      <a:tailEnd type="none" w="med" len="med"/>
-                    </a:lnB>
-                    <a:solidFill>
-                      <a:schemeClr val="bg1"/>
-                    </a:solidFill>
-                  </a:tcPr>
-                </a:tc>
-                <a:tc>
-                  <a:txBody>
-                    <a:bodyPr/>
-                    <a:lstStyle/>
-                    <a:p>
-                      <a:pPr algn="l" indent="0" marL="0">
-                        <a:buNone/>
-                      </a:pPr>
-                      <a:r>
-                        <a:rPr lang="en-US" sz="1400" dirty="0">
-                          <a:solidFill>
-                            <a:schemeClr val="tx1"/>
-                          </a:solidFill>
-                        </a:rPr>
-                        <a:t>none needed</a:t>
-                      </a:r>
-                      <a:endParaRPr lang="en-US" sz="1400" dirty="0"/>
-                    </a:p>
-                  </a:txBody>
-                  <a:tcPr marL="109728" marR="109728" marT="45720" marB="45720" anchor="ctr">
-                    <a:lnL w="6350" cap="flat" cmpd="sng" algn="ctr">
-                      <a:solidFill>
-                        <a:schemeClr val="accent6"/>
-                      </a:solidFill>
-                      <a:prstDash val="solid"/>
-                      <a:round/>
-                      <a:headEnd type="none" w="med" len="med"/>
-                      <a:tailEnd type="none" w="med" len="med"/>
-                    </a:lnL>
-                    <a:lnR w="6350" cap="flat" cmpd="sng" algn="ctr">
-                      <a:solidFill>
-                        <a:schemeClr val="accent6"/>
-                      </a:solidFill>
-                      <a:prstDash val="solid"/>
-                      <a:round/>
-                      <a:headEnd type="none" w="med" len="med"/>
-                      <a:tailEnd type="none" w="med" len="med"/>
-                    </a:lnR>
-                    <a:lnT w="6350" cap="flat" cmpd="sng" algn="ctr">
-                      <a:solidFill>
-                        <a:schemeClr val="accent6"/>
-                      </a:solidFill>
-                      <a:prstDash val="solid"/>
-                      <a:round/>
-                      <a:headEnd type="none" w="med" len="med"/>
-                      <a:tailEnd type="none" w="med" len="med"/>
-                    </a:lnT>
-                    <a:lnB w="6350" cap="flat" cmpd="sng" algn="ctr">
-                      <a:solidFill>
-                        <a:schemeClr val="accent6"/>
-                      </a:solidFill>
-                      <a:prstDash val="solid"/>
-                      <a:round/>
-                      <a:headEnd type="none" w="med" len="med"/>
-                      <a:tailEnd type="none" w="med" len="med"/>
-                    </a:lnB>
-                    <a:solidFill>
-                      <a:schemeClr val="bg1"/>
-                    </a:solidFill>
-                  </a:tcPr>
-                </a:tc>
-              </a:tr>
-              <a:tr h="455023">
-                <a:tc>
-                  <a:txBody>
-                    <a:bodyPr/>
-                    <a:lstStyle/>
-                    <a:p>
-                      <a:pPr algn="l" indent="0" marL="0">
-                        <a:buNone/>
-                      </a:pPr>
-                      <a:r>
-                        <a:rPr lang="en-US" sz="1400" dirty="0">
-                          <a:solidFill>
-                            <a:schemeClr val="tx1"/>
-                          </a:solidFill>
-                        </a:rPr>
-                        <a:t>Rigid sensor mount</a:t>
-                      </a:r>
-                      <a:endParaRPr lang="en-US" sz="1400" dirty="0"/>
-                    </a:p>
-                  </a:txBody>
-                  <a:tcPr marL="109728" marR="109728" marT="45720" marB="45720" anchor="ctr">
-                    <a:lnL w="6350" cap="flat" cmpd="sng" algn="ctr">
-                      <a:solidFill>
-                        <a:schemeClr val="accent6"/>
-                      </a:solidFill>
-                      <a:prstDash val="solid"/>
-                      <a:round/>
-                      <a:headEnd type="none" w="med" len="med"/>
-                      <a:tailEnd type="none" w="med" len="med"/>
-                    </a:lnL>
-                    <a:lnR w="6350" cap="flat" cmpd="sng" algn="ctr">
-                      <a:solidFill>
-                        <a:schemeClr val="accent6"/>
-                      </a:solidFill>
-                      <a:prstDash val="solid"/>
-                      <a:round/>
-                      <a:headEnd type="none" w="med" len="med"/>
-                      <a:tailEnd type="none" w="med" len="med"/>
-                    </a:lnR>
-                    <a:lnT w="6350" cap="flat" cmpd="sng" algn="ctr">
-                      <a:solidFill>
-                        <a:schemeClr val="accent6"/>
-                      </a:solidFill>
-                      <a:prstDash val="solid"/>
-                      <a:round/>
-                      <a:headEnd type="none" w="med" len="med"/>
-                      <a:tailEnd type="none" w="med" len="med"/>
-                    </a:lnT>
-                    <a:lnB w="6350" cap="flat" cmpd="sng" algn="ctr">
-                      <a:solidFill>
-                        <a:schemeClr val="accent6"/>
-                      </a:solidFill>
-                      <a:prstDash val="solid"/>
-                      <a:round/>
-                      <a:headEnd type="none" w="med" len="med"/>
-                      <a:tailEnd type="none" w="med" len="med"/>
-                    </a:lnB>
-                    <a:solidFill>
-                      <a:schemeClr val="bg2"/>
-                    </a:solidFill>
-                  </a:tcPr>
-                </a:tc>
-                <a:tc>
-                  <a:txBody>
-                    <a:bodyPr/>
-                    <a:lstStyle/>
-                    <a:p>
-                      <a:pPr algn="l" indent="0" marL="0">
-                        <a:buNone/>
-                      </a:pPr>
-                      <a:r>
-                        <a:rPr lang="en-US" sz="1400" dirty="0">
-                          <a:solidFill>
-                            <a:schemeClr val="tx1"/>
-                          </a:solidFill>
-                        </a:rPr>
-                        <a:t>1</a:t>
-                      </a:r>
-                      <a:endParaRPr lang="en-US" sz="1400" dirty="0"/>
-                    </a:p>
-                  </a:txBody>
-                  <a:tcPr marL="109728" marR="109728" marT="45720" marB="45720" anchor="ctr">
-                    <a:lnL w="6350" cap="flat" cmpd="sng" algn="ctr">
-                      <a:solidFill>
-                        <a:schemeClr val="accent6"/>
-                      </a:solidFill>
-                      <a:prstDash val="solid"/>
-                      <a:round/>
-                      <a:headEnd type="none" w="med" len="med"/>
-                      <a:tailEnd type="none" w="med" len="med"/>
-                    </a:lnL>
-                    <a:lnR w="6350" cap="flat" cmpd="sng" algn="ctr">
-                      <a:solidFill>
-                        <a:schemeClr val="accent6"/>
-                      </a:solidFill>
-                      <a:prstDash val="solid"/>
-                      <a:round/>
-                      <a:headEnd type="none" w="med" len="med"/>
-                      <a:tailEnd type="none" w="med" len="med"/>
-                    </a:lnR>
-                    <a:lnT w="6350" cap="flat" cmpd="sng" algn="ctr">
-                      <a:solidFill>
-                        <a:schemeClr val="accent6"/>
-                      </a:solidFill>
-                      <a:prstDash val="solid"/>
-                      <a:round/>
-                      <a:headEnd type="none" w="med" len="med"/>
-                      <a:tailEnd type="none" w="med" len="med"/>
-                    </a:lnT>
-                    <a:lnB w="6350" cap="flat" cmpd="sng" algn="ctr">
-                      <a:solidFill>
-                        <a:schemeClr val="accent6"/>
-                      </a:solidFill>
-                      <a:prstDash val="solid"/>
-                      <a:round/>
-                      <a:headEnd type="none" w="med" len="med"/>
-                      <a:tailEnd type="none" w="med" len="med"/>
-                    </a:lnB>
-                    <a:solidFill>
-                      <a:schemeClr val="bg2"/>
-                    </a:solidFill>
-                  </a:tcPr>
-                </a:tc>
-                <a:tc>
-                  <a:txBody>
-                    <a:bodyPr/>
-                    <a:lstStyle/>
-                    <a:p>
-                      <a:pPr algn="l" indent="0" marL="0">
-                        <a:buNone/>
-                      </a:pPr>
-                      <a:r>
-                        <a:rPr lang="en-US" sz="1400" dirty="0">
-                          <a:solidFill>
-                            <a:schemeClr val="tx1"/>
-                          </a:solidFill>
-                        </a:rPr>
                         <a:t>existing drawing</a:t>
                       </a:r>
                       <a:endParaRPr lang="en-US" sz="1400" dirty="0"/>
@@ -8521,7 +8311,7 @@
                       <a:tailEnd type="none" w="med" len="med"/>
                     </a:lnB>
                     <a:solidFill>
-                      <a:schemeClr val="bg2"/>
+                      <a:schemeClr val="bg1"/>
                     </a:solidFill>
                   </a:tcPr>
                 </a:tc>
@@ -8955,7 +8745,7 @@
                   </a:tcPr>
                 </a:tc>
               </a:tr>
-              <a:tr h="529046">
+              <a:tr h="617220">
                 <a:tc>
                   <a:txBody>
                     <a:bodyPr/>
@@ -8970,7 +8760,7 @@
                             <a:schemeClr val="tx1"/>
                           </a:solidFill>
                         </a:rPr>
-                        <a:t>Outside micrometers 75-100 and 150-175 mm, with setting standards</a:t>
+                        <a:t>Outside micrometer 150-175 mm, with setting standard</a:t>
                       </a:r>
                       <a:endParaRPr lang="en-US" sz="1400" dirty="0"/>
                     </a:p>
@@ -9031,7 +8821,7 @@
                             <a:schemeClr val="tx1"/>
                           </a:solidFill>
                         </a:rPr>
-                        <a:t>Sphere diameters, measured in-house</a:t>
+                        <a:t>Sphere diameter and sphericity, in-house</a:t>
                       </a:r>
                       <a:endParaRPr lang="en-US" sz="1400" dirty="0"/>
                     </a:p>
@@ -9092,7 +8882,7 @@
                             <a:schemeClr val="tx1"/>
                           </a:solidFill>
                         </a:rPr>
-                        <a:t>$405 to $520</a:t>
+                        <a:t>$235 to $300</a:t>
                       </a:r>
                       <a:endParaRPr lang="en-US" sz="1400" dirty="0"/>
                     </a:p>
@@ -9140,7 +8930,7 @@
                   </a:tcPr>
                 </a:tc>
               </a:tr>
-              <a:tr h="529046">
+              <a:tr h="617220">
                 <a:tc>
                   <a:txBody>
                     <a:bodyPr/>
@@ -9216,7 +9006,7 @@
                             <a:schemeClr val="tx1"/>
                           </a:solidFill>
                         </a:rPr>
-                        <a:t>Rough TCP length; board distance D</a:t>
+                        <a:t>Rough TCP length; board distance D; board size</a:t>
                       </a:r>
                       <a:endParaRPr lang="en-US" sz="1400" dirty="0"/>
                     </a:p>
@@ -9325,7 +9115,7 @@
                   </a:tcPr>
                 </a:tc>
               </a:tr>
-              <a:tr h="529046">
+              <a:tr h="617220">
                 <a:tc>
                   <a:txBody>
                     <a:bodyPr/>
@@ -9401,7 +9191,7 @@
                             <a:schemeClr val="tx1"/>
                           </a:solidFill>
                         </a:rPr>
-                        <a:t>Board flatness; stem straightness</a:t>
+                        <a:t>Board flatness</a:t>
                       </a:r>
                       <a:endParaRPr lang="en-US" sz="1400" dirty="0"/>
                     </a:p>
@@ -9510,7 +9300,7 @@
                   </a:tcPr>
                 </a:tc>
               </a:tr>
-              <a:tr h="529046">
+              <a:tr h="617220">
                 <a:tc>
                   <a:txBody>
                     <a:bodyPr/>
@@ -9695,192 +9485,7 @@
                   </a:tcPr>
                 </a:tc>
               </a:tr>
-              <a:tr h="529046">
-                <a:tc>
-                  <a:txBody>
-                    <a:bodyPr/>
-                    <a:lstStyle/>
-                    <a:p>
-                      <a:pPr algn="l" indent="0" marL="0">
-                        <a:buNone/>
-                      </a:pPr>
-                      <a:r>
-                        <a:rPr lang="en-US" sz="1400" dirty="0">
-                          <a:solidFill>
-                            <a:schemeClr val="tx1"/>
-                          </a:solidFill>
-                        </a:rPr>
-                        <a:t>Machinist's square</a:t>
-                      </a:r>
-                      <a:endParaRPr lang="en-US" sz="1400" dirty="0"/>
-                    </a:p>
-                  </a:txBody>
-                  <a:tcPr marL="109728" marR="109728" marT="45720" marB="45720" anchor="ctr">
-                    <a:lnL w="6350" cap="flat" cmpd="sng" algn="ctr">
-                      <a:solidFill>
-                        <a:schemeClr val="accent6"/>
-                      </a:solidFill>
-                      <a:prstDash val="solid"/>
-                      <a:round/>
-                      <a:headEnd type="none" w="med" len="med"/>
-                      <a:tailEnd type="none" w="med" len="med"/>
-                    </a:lnL>
-                    <a:lnR w="6350" cap="flat" cmpd="sng" algn="ctr">
-                      <a:solidFill>
-                        <a:schemeClr val="accent6"/>
-                      </a:solidFill>
-                      <a:prstDash val="solid"/>
-                      <a:round/>
-                      <a:headEnd type="none" w="med" len="med"/>
-                      <a:tailEnd type="none" w="med" len="med"/>
-                    </a:lnR>
-                    <a:lnT w="6350" cap="flat" cmpd="sng" algn="ctr">
-                      <a:solidFill>
-                        <a:schemeClr val="accent6"/>
-                      </a:solidFill>
-                      <a:prstDash val="solid"/>
-                      <a:round/>
-                      <a:headEnd type="none" w="med" len="med"/>
-                      <a:tailEnd type="none" w="med" len="med"/>
-                    </a:lnT>
-                    <a:lnB w="6350" cap="flat" cmpd="sng" algn="ctr">
-                      <a:solidFill>
-                        <a:schemeClr val="accent6"/>
-                      </a:solidFill>
-                      <a:prstDash val="solid"/>
-                      <a:round/>
-                      <a:headEnd type="none" w="med" len="med"/>
-                      <a:tailEnd type="none" w="med" len="med"/>
-                    </a:lnB>
-                    <a:solidFill>
-                      <a:schemeClr val="bg1"/>
-                    </a:solidFill>
-                  </a:tcPr>
-                </a:tc>
-                <a:tc>
-                  <a:txBody>
-                    <a:bodyPr/>
-                    <a:lstStyle/>
-                    <a:p>
-                      <a:pPr algn="l" indent="0" marL="0">
-                        <a:buNone/>
-                      </a:pPr>
-                      <a:r>
-                        <a:rPr lang="en-US" sz="1400" dirty="0">
-                          <a:solidFill>
-                            <a:schemeClr val="tx1"/>
-                          </a:solidFill>
-                        </a:rPr>
-                        <a:t>Board x axis</a:t>
-                      </a:r>
-                      <a:endParaRPr lang="en-US" sz="1400" dirty="0"/>
-                    </a:p>
-                  </a:txBody>
-                  <a:tcPr marL="109728" marR="109728" marT="45720" marB="45720" anchor="ctr">
-                    <a:lnL w="6350" cap="flat" cmpd="sng" algn="ctr">
-                      <a:solidFill>
-                        <a:schemeClr val="accent6"/>
-                      </a:solidFill>
-                      <a:prstDash val="solid"/>
-                      <a:round/>
-                      <a:headEnd type="none" w="med" len="med"/>
-                      <a:tailEnd type="none" w="med" len="med"/>
-                    </a:lnL>
-                    <a:lnR w="6350" cap="flat" cmpd="sng" algn="ctr">
-                      <a:solidFill>
-                        <a:schemeClr val="accent6"/>
-                      </a:solidFill>
-                      <a:prstDash val="solid"/>
-                      <a:round/>
-                      <a:headEnd type="none" w="med" len="med"/>
-                      <a:tailEnd type="none" w="med" len="med"/>
-                    </a:lnR>
-                    <a:lnT w="6350" cap="flat" cmpd="sng" algn="ctr">
-                      <a:solidFill>
-                        <a:schemeClr val="accent6"/>
-                      </a:solidFill>
-                      <a:prstDash val="solid"/>
-                      <a:round/>
-                      <a:headEnd type="none" w="med" len="med"/>
-                      <a:tailEnd type="none" w="med" len="med"/>
-                    </a:lnT>
-                    <a:lnB w="6350" cap="flat" cmpd="sng" algn="ctr">
-                      <a:solidFill>
-                        <a:schemeClr val="accent6"/>
-                      </a:solidFill>
-                      <a:prstDash val="solid"/>
-                      <a:round/>
-                      <a:headEnd type="none" w="med" len="med"/>
-                      <a:tailEnd type="none" w="med" len="med"/>
-                    </a:lnB>
-                    <a:solidFill>
-                      <a:schemeClr val="bg1"/>
-                    </a:solidFill>
-                  </a:tcPr>
-                </a:tc>
-                <a:tc>
-                  <a:txBody>
-                    <a:bodyPr/>
-                    <a:lstStyle/>
-                    <a:p>
-                      <a:pPr algn="r" indent="0" marL="0">
-                        <a:buNone/>
-                      </a:pPr>
-                      <a:r>
-                        <a:rPr lang="en-US" sz="1400" b="1" dirty="0">
-                          <a:solidFill>
-                            <a:schemeClr val="tx1"/>
-                          </a:solidFill>
-                        </a:rPr>
-                        <a:t>$30 to $80</a:t>
-                      </a:r>
-                      <a:endParaRPr lang="en-US" sz="1400" dirty="0"/>
-                    </a:p>
-                  </a:txBody>
-                  <a:tcPr marL="109728" marR="109728" marT="45720" marB="45720" anchor="ctr">
-                    <a:lnL w="6350" cap="flat" cmpd="sng" algn="ctr">
-                      <a:solidFill>
-                        <a:schemeClr val="accent6"/>
-                      </a:solidFill>
-                      <a:prstDash val="solid"/>
-                      <a:round/>
-                      <a:headEnd type="none" w="med" len="med"/>
-                      <a:tailEnd type="none" w="med" len="med"/>
-                    </a:lnL>
-                    <a:lnR w="6350" cap="flat" cmpd="sng" algn="ctr">
-                      <a:solidFill>
-                        <a:schemeClr val="accent6"/>
-                      </a:solidFill>
-                      <a:prstDash val="solid"/>
-                      <a:round/>
-                      <a:headEnd type="none" w="med" len="med"/>
-                      <a:tailEnd type="none" w="med" len="med"/>
-                    </a:lnR>
-                    <a:lnT w="6350" cap="flat" cmpd="sng" algn="ctr">
-                      <a:solidFill>
-                        <a:schemeClr val="accent6"/>
-                      </a:solidFill>
-                      <a:prstDash val="solid"/>
-                      <a:round/>
-                      <a:headEnd type="none" w="med" len="med"/>
-                      <a:tailEnd type="none" w="med" len="med"/>
-                    </a:lnT>
-                    <a:lnB w="6350" cap="flat" cmpd="sng" algn="ctr">
-                      <a:solidFill>
-                        <a:schemeClr val="accent6"/>
-                      </a:solidFill>
-                      <a:prstDash val="solid"/>
-                      <a:round/>
-                      <a:headEnd type="none" w="med" len="med"/>
-                      <a:tailEnd type="none" w="med" len="med"/>
-                    </a:lnB>
-                    <a:solidFill>
-                      <a:schemeClr val="bg1"/>
-                    </a:solidFill>
-                  </a:tcPr>
-                </a:tc>
-              </a:tr>
-              <a:tr h="529046">
+              <a:tr h="617220">
                 <a:tc>
                   <a:txBody>
                     <a:bodyPr/>
@@ -9938,7 +9543,7 @@
                       <a:tailEnd type="none" w="med" len="med"/>
                     </a:lnB>
                     <a:solidFill>
-                      <a:schemeClr val="bg2"/>
+                      <a:schemeClr val="bg1"/>
                     </a:solidFill>
                   </a:tcPr>
                 </a:tc>
@@ -9999,7 +9604,7 @@
                       <a:tailEnd type="none" w="med" len="med"/>
                     </a:lnB>
                     <a:solidFill>
-                      <a:schemeClr val="bg2"/>
+                      <a:schemeClr val="bg1"/>
                     </a:solidFill>
                   </a:tcPr>
                 </a:tc>
@@ -10060,12 +9665,12 @@
                       <a:tailEnd type="none" w="med" len="med"/>
                     </a:lnB>
                     <a:solidFill>
-                      <a:schemeClr val="bg2"/>
+                      <a:schemeClr val="bg1"/>
                     </a:solidFill>
                   </a:tcPr>
                 </a:tc>
               </a:tr>
-              <a:tr h="529046">
+              <a:tr h="617220">
                 <a:tc>
                   <a:txBody>
                     <a:bodyPr/>
@@ -10123,7 +9728,7 @@
                       <a:tailEnd type="none" w="med" len="med"/>
                     </a:lnB>
                     <a:solidFill>
-                      <a:schemeClr val="bg1"/>
+                      <a:schemeClr val="bg2"/>
                     </a:solidFill>
                   </a:tcPr>
                 </a:tc>
@@ -10141,7 +9746,7 @@
                             <a:schemeClr val="tx1"/>
                           </a:solidFill>
                         </a:rPr>
-                        <a:t>Thread locker, retaining compound, shims, alcohol, padded cases</a:t>
+                        <a:t>Thread locker, retaining compound, shims, alcohol, padded case</a:t>
                       </a:r>
                       <a:endParaRPr lang="en-US" sz="1400" dirty="0"/>
                     </a:p>
@@ -10184,7 +9789,7 @@
                       <a:tailEnd type="none" w="med" len="med"/>
                     </a:lnB>
                     <a:solidFill>
-                      <a:schemeClr val="bg1"/>
+                      <a:schemeClr val="bg2"/>
                     </a:solidFill>
                   </a:tcPr>
                 </a:tc>
@@ -10245,7 +9850,7 @@
                       <a:tailEnd type="none" w="med" len="med"/>
                     </a:lnB>
                     <a:solidFill>
-                      <a:schemeClr val="bg1"/>
+                      <a:schemeClr val="bg2"/>
                     </a:solidFill>
                   </a:tcPr>
                 </a:tc>
@@ -10395,7 +10000,7 @@
                 <a:ea typeface="+mj-lt" pitchFamily="34" charset="-122"/>
                 <a:cs typeface="+mj-lt" pitchFamily="34" charset="-120"/>
               </a:rPr>
-              <a:t>Building and buying cost about $2,525 to $6,500</a:t>
+              <a:t>Building and buying cost about $1,875 to $5,150</a:t>
             </a:r>
             <a:endParaRPr lang="en-US" sz="3400" dirty="0"/>
           </a:p>
@@ -10551,131 +10156,7 @@
                   </a:tcPr>
                 </a:tc>
               </a:tr>
-              <a:tr h="455023">
-                <a:tc>
-                  <a:txBody>
-                    <a:bodyPr/>
-                    <a:lstStyle/>
-                    <a:p>
-                      <a:pPr algn="l" indent="0" marL="0">
-                        <a:buNone/>
-                      </a:pPr>
-                      <a:r>
-                        <a:rPr lang="en-US" sz="1400" dirty="0">
-                          <a:solidFill>
-                            <a:schemeClr val="tx1"/>
-                          </a:solidFill>
-                        </a:rPr>
-                        <a:t>Sphere A with mounting interface</a:t>
-                      </a:r>
-                      <a:endParaRPr lang="en-US" sz="1400" dirty="0"/>
-                    </a:p>
-                  </a:txBody>
-                  <a:tcPr marL="109728" marR="109728" marT="45720" marB="45720" anchor="ctr">
-                    <a:lnL w="6350" cap="flat" cmpd="sng" algn="ctr">
-                      <a:solidFill>
-                        <a:schemeClr val="accent6"/>
-                      </a:solidFill>
-                      <a:prstDash val="solid"/>
-                      <a:round/>
-                      <a:headEnd type="none" w="med" len="med"/>
-                      <a:tailEnd type="none" w="med" len="med"/>
-                    </a:lnL>
-                    <a:lnR w="6350" cap="flat" cmpd="sng" algn="ctr">
-                      <a:solidFill>
-                        <a:schemeClr val="accent6"/>
-                      </a:solidFill>
-                      <a:prstDash val="solid"/>
-                      <a:round/>
-                      <a:headEnd type="none" w="med" len="med"/>
-                      <a:tailEnd type="none" w="med" len="med"/>
-                    </a:lnR>
-                    <a:lnT w="6350" cap="flat" cmpd="sng" algn="ctr">
-                      <a:solidFill>
-                        <a:schemeClr val="accent6"/>
-                      </a:solidFill>
-                      <a:prstDash val="solid"/>
-                      <a:round/>
-                      <a:headEnd type="none" w="med" len="med"/>
-                      <a:tailEnd type="none" w="med" len="med"/>
-                    </a:lnT>
-                    <a:lnB w="6350" cap="flat" cmpd="sng" algn="ctr">
-                      <a:solidFill>
-                        <a:schemeClr val="accent6"/>
-                      </a:solidFill>
-                      <a:prstDash val="solid"/>
-                      <a:round/>
-                      <a:headEnd type="none" w="med" len="med"/>
-                      <a:tailEnd type="none" w="med" len="med"/>
-                    </a:lnB>
-                    <a:solidFill>
-                      <a:schemeClr val="bg1"/>
-                    </a:solidFill>
-                  </a:tcPr>
-                </a:tc>
-                <a:tc>
-                  <a:txBody>
-                    <a:bodyPr/>
-                    <a:lstStyle/>
-                    <a:p>
-                      <a:pPr algn="r" indent="0" marL="0">
-                        <a:buNone/>
-                      </a:pPr>
-                      <a:r>
-                        <a:rPr lang="en-US" sz="1400" b="1" dirty="0">
-                          <a:solidFill>
-                            <a:schemeClr val="tx1"/>
-                          </a:solidFill>
-                        </a:rPr>
-                        <a:t>$250 to $550</a:t>
-                      </a:r>
-                      <a:endParaRPr lang="en-US" sz="1400" dirty="0"/>
-                    </a:p>
-                  </a:txBody>
-                  <a:tcPr marL="109728" marR="109728" marT="45720" marB="45720" anchor="ctr">
-                    <a:lnL w="6350" cap="flat" cmpd="sng" algn="ctr">
-                      <a:solidFill>
-                        <a:schemeClr val="accent6"/>
-                      </a:solidFill>
-                      <a:prstDash val="solid"/>
-                      <a:round/>
-                      <a:headEnd type="none" w="med" len="med"/>
-                      <a:tailEnd type="none" w="med" len="med"/>
-                    </a:lnL>
-                    <a:lnR w="6350" cap="flat" cmpd="sng" algn="ctr">
-                      <a:solidFill>
-                        <a:schemeClr val="accent6"/>
-                      </a:solidFill>
-                      <a:prstDash val="solid"/>
-                      <a:round/>
-                      <a:headEnd type="none" w="med" len="med"/>
-                      <a:tailEnd type="none" w="med" len="med"/>
-                    </a:lnR>
-                    <a:lnT w="6350" cap="flat" cmpd="sng" algn="ctr">
-                      <a:solidFill>
-                        <a:schemeClr val="accent6"/>
-                      </a:solidFill>
-                      <a:prstDash val="solid"/>
-                      <a:round/>
-                      <a:headEnd type="none" w="med" len="med"/>
-                      <a:tailEnd type="none" w="med" len="med"/>
-                    </a:lnT>
-                    <a:lnB w="6350" cap="flat" cmpd="sng" algn="ctr">
-                      <a:solidFill>
-                        <a:schemeClr val="accent6"/>
-                      </a:solidFill>
-                      <a:prstDash val="solid"/>
-                      <a:round/>
-                      <a:headEnd type="none" w="med" len="med"/>
-                      <a:tailEnd type="none" w="med" len="med"/>
-                    </a:lnB>
-                    <a:solidFill>
-                      <a:schemeClr val="bg1"/>
-                    </a:solidFill>
-                  </a:tcPr>
-                </a:tc>
-              </a:tr>
-              <a:tr h="455023">
+              <a:tr h="529046">
                 <a:tc>
                   <a:txBody>
                     <a:bodyPr/>
@@ -10733,7 +10214,7 @@
                       <a:tailEnd type="none" w="med" len="med"/>
                     </a:lnB>
                     <a:solidFill>
-                      <a:schemeClr val="bg2"/>
+                      <a:schemeClr val="bg1"/>
                     </a:solidFill>
                   </a:tcPr>
                 </a:tc>
@@ -10794,12 +10275,12 @@
                       <a:tailEnd type="none" w="med" len="med"/>
                     </a:lnB>
                     <a:solidFill>
-                      <a:schemeClr val="bg2"/>
+                      <a:schemeClr val="bg1"/>
                     </a:solidFill>
                   </a:tcPr>
                 </a:tc>
               </a:tr>
-              <a:tr h="455023">
+              <a:tr h="529046">
                 <a:tc>
                   <a:txBody>
                     <a:bodyPr/>
@@ -10814,7 +10295,7 @@
                             <a:schemeClr val="tx1"/>
                           </a:solidFill>
                         </a:rPr>
-                        <a:t>Sphere-flange mounts: two adapter plates and two stems</a:t>
+                        <a:t>Sphere-flange mount: adapter plate and stem</a:t>
                       </a:r>
                       <a:endParaRPr lang="en-US" sz="1400" dirty="0"/>
                     </a:p>
@@ -10857,7 +10338,7 @@
                       <a:tailEnd type="none" w="med" len="med"/>
                     </a:lnB>
                     <a:solidFill>
-                      <a:schemeClr val="bg1"/>
+                      <a:schemeClr val="bg2"/>
                     </a:solidFill>
                   </a:tcPr>
                 </a:tc>
@@ -10875,7 +10356,7 @@
                             <a:schemeClr val="tx1"/>
                           </a:solidFill>
                         </a:rPr>
-                        <a:t>$400 to $1,000</a:t>
+                        <a:t>$200 to $500</a:t>
                       </a:r>
                       <a:endParaRPr lang="en-US" sz="1400" dirty="0"/>
                     </a:p>
@@ -10918,12 +10399,12 @@
                       <a:tailEnd type="none" w="med" len="med"/>
                     </a:lnB>
                     <a:solidFill>
-                      <a:schemeClr val="bg1"/>
+                      <a:schemeClr val="bg2"/>
                     </a:solidFill>
                   </a:tcPr>
                 </a:tc>
               </a:tr>
-              <a:tr h="455023">
+              <a:tr h="529046">
                 <a:tc>
                   <a:txBody>
                     <a:bodyPr/>
@@ -10981,7 +10462,7 @@
                       <a:tailEnd type="none" w="med" len="med"/>
                     </a:lnB>
                     <a:solidFill>
-                      <a:schemeClr val="bg2"/>
+                      <a:schemeClr val="bg1"/>
                     </a:solidFill>
                   </a:tcPr>
                 </a:tc>
@@ -11042,12 +10523,12 @@
                       <a:tailEnd type="none" w="med" len="med"/>
                     </a:lnB>
                     <a:solidFill>
-                      <a:schemeClr val="bg2"/>
+                      <a:schemeClr val="bg1"/>
                     </a:solidFill>
                   </a:tcPr>
                 </a:tc>
               </a:tr>
-              <a:tr h="455023">
+              <a:tr h="529046">
                 <a:tc>
                   <a:txBody>
                     <a:bodyPr/>
@@ -11105,7 +10586,7 @@
                       <a:tailEnd type="none" w="med" len="med"/>
                     </a:lnB>
                     <a:solidFill>
-                      <a:schemeClr val="bg1"/>
+                      <a:schemeClr val="bg2"/>
                     </a:solidFill>
                   </a:tcPr>
                 </a:tc>
@@ -11166,12 +10647,12 @@
                       <a:tailEnd type="none" w="med" len="med"/>
                     </a:lnB>
                     <a:solidFill>
-                      <a:schemeClr val="bg1"/>
+                      <a:schemeClr val="bg2"/>
                     </a:solidFill>
                   </a:tcPr>
                 </a:tc>
               </a:tr>
-              <a:tr h="455023">
+              <a:tr h="529046">
                 <a:tc>
                   <a:txBody>
                     <a:bodyPr/>
@@ -11229,7 +10710,7 @@
                       <a:tailEnd type="none" w="med" len="med"/>
                     </a:lnB>
                     <a:solidFill>
-                      <a:schemeClr val="bg2"/>
+                      <a:schemeClr val="bg1"/>
                     </a:solidFill>
                   </a:tcPr>
                 </a:tc>
@@ -11290,12 +10771,12 @@
                       <a:tailEnd type="none" w="med" len="med"/>
                     </a:lnB>
                     <a:solidFill>
-                      <a:schemeClr val="bg2"/>
+                      <a:schemeClr val="bg1"/>
                     </a:solidFill>
                   </a:tcPr>
                 </a:tc>
               </a:tr>
-              <a:tr h="518160">
+              <a:tr h="529046">
                 <a:tc>
                   <a:txBody>
                     <a:bodyPr/>
@@ -11353,7 +10834,7 @@
                       <a:tailEnd type="none" w="med" len="med"/>
                     </a:lnB>
                     <a:solidFill>
-                      <a:schemeClr val="bg1"/>
+                      <a:schemeClr val="bg2"/>
                     </a:solidFill>
                   </a:tcPr>
                 </a:tc>
@@ -11414,12 +10895,12 @@
                       <a:tailEnd type="none" w="med" len="med"/>
                     </a:lnB>
                     <a:solidFill>
-                      <a:schemeClr val="bg1"/>
+                      <a:schemeClr val="bg2"/>
                     </a:solidFill>
                   </a:tcPr>
                 </a:tc>
               </a:tr>
-              <a:tr h="455023">
+              <a:tr h="529046">
                 <a:tc>
                   <a:txBody>
                     <a:bodyPr/>
@@ -11477,7 +10958,7 @@
                       <a:tailEnd type="none" w="med" len="med"/>
                     </a:lnB>
                     <a:solidFill>
-                      <a:schemeClr val="bg2"/>
+                      <a:schemeClr val="bg1"/>
                     </a:solidFill>
                   </a:tcPr>
                 </a:tc>
@@ -11538,7 +11019,7 @@
                       <a:tailEnd type="none" w="med" len="med"/>
                     </a:lnB>
                     <a:solidFill>
-                      <a:schemeClr val="bg2"/>
+                      <a:schemeClr val="bg1"/>
                     </a:solidFill>
                   </a:tcPr>
                 </a:tc>
@@ -11602,7 +11083,7 @@
                 <a:ea typeface="+mj-lt" pitchFamily="34" charset="-122"/>
                 <a:cs typeface="+mj-lt" pitchFamily="34" charset="-120"/>
               </a:rPr>
-              <a:t>$2,525 to $6,500</a:t>
+              <a:t>$1,875 to $5,150</a:t>
             </a:r>
             <a:endParaRPr lang="en-US" sz="3200" dirty="0"/>
           </a:p>
@@ -11638,7 +11119,7 @@
                   <a:schemeClr val="tx1"/>
                 </a:solidFill>
               </a:rPr>
-              <a:t>bearing-ball sphere A, aluminum sphere B, tools included</a:t>
+              <a:t>aluminum sphere B turned by a job shop, tools included</a:t>
             </a:r>
             <a:endParaRPr lang="en-US" sz="1400" dirty="0"/>
           </a:p>
@@ -11699,7 +11180,7 @@
                 <a:ea typeface="+mj-lt" pitchFamily="34" charset="-122"/>
                 <a:cs typeface="+mj-lt" pitchFamily="34" charset="-120"/>
               </a:rPr>
-              <a:t>$4,375 to $11,950</a:t>
+              <a:t>$3,375 to $9,650</a:t>
             </a:r>
             <a:endParaRPr lang="en-US" sz="3200" dirty="0"/>
           </a:p>
@@ -11735,7 +11216,7 @@
                   <a:schemeClr val="tx1"/>
                 </a:solidFill>
               </a:rPr>
-              <a:t>both spheres made to order, tools included</a:t>
+              <a:t>sphere B made to order, tools included</a:t>
             </a:r>
             <a:endParaRPr lang="en-US" sz="1400" dirty="0"/>
           </a:p>
@@ -11771,7 +11252,7 @@
                   <a:schemeClr val="accent5"/>
                 </a:solidFill>
               </a:rPr>
-              <a:t>Tools and consumables $685 to $1,430, included in the totals. Estimates of October 2026, plus or minus 50 percent; sphere B is the least certain.</a:t>
+              <a:t>Tools and consumables $485 to $1,130, included in the totals. Estimates of October 2026, plus or minus 50 percent; sphere B is the least certain.</a:t>
             </a:r>
             <a:endParaRPr lang="en-US" sz="1200" dirty="0"/>
           </a:p>
@@ -11882,7 +11363,7 @@
                 <a:ea typeface="+mj-lt" pitchFamily="34" charset="-122"/>
                 <a:cs typeface="+mj-lt" pitchFamily="34" charset="-120"/>
               </a:rPr>
-              <a:t>Purchase specification: target spheres</a:t>
+              <a:t>Purchase specification: the target sphere</a:t>
             </a:r>
             <a:endParaRPr lang="en-US" sz="3400" dirty="0"/>
           </a:p>
@@ -11911,9 +11392,8 @@
             <a:tbl>
               <a:tblPr/>
               <a:tblGrid>
-                <a:gridCol w="2103120"/>
-                <a:gridCol w="4937760"/>
-                <a:gridCol w="4236415"/>
+                <a:gridCol w="2377440"/>
+                <a:gridCol w="8899855"/>
               </a:tblGrid>
               <a:tr h="457200">
                 <a:tc>
@@ -11931,67 +11411,6 @@
                           </a:solidFill>
                         </a:rPr>
                         <a:t>Requirement</a:t>
-                      </a:r>
-                      <a:endParaRPr lang="en-US" sz="1400" dirty="0"/>
-                    </a:p>
-                  </a:txBody>
-                  <a:tcPr marL="109728" marR="109728" marT="45720" marB="45720" anchor="ctr">
-                    <a:lnL w="6350" cap="flat" cmpd="sng" algn="ctr">
-                      <a:solidFill>
-                        <a:schemeClr val="accent6"/>
-                      </a:solidFill>
-                      <a:prstDash val="solid"/>
-                      <a:round/>
-                      <a:headEnd type="none" w="med" len="med"/>
-                      <a:tailEnd type="none" w="med" len="med"/>
-                    </a:lnL>
-                    <a:lnR w="6350" cap="flat" cmpd="sng" algn="ctr">
-                      <a:solidFill>
-                        <a:schemeClr val="accent6"/>
-                      </a:solidFill>
-                      <a:prstDash val="solid"/>
-                      <a:round/>
-                      <a:headEnd type="none" w="med" len="med"/>
-                      <a:tailEnd type="none" w="med" len="med"/>
-                    </a:lnR>
-                    <a:lnT w="6350" cap="flat" cmpd="sng" algn="ctr">
-                      <a:solidFill>
-                        <a:schemeClr val="accent6"/>
-                      </a:solidFill>
-                      <a:prstDash val="solid"/>
-                      <a:round/>
-                      <a:headEnd type="none" w="med" len="med"/>
-                      <a:tailEnd type="none" w="med" len="med"/>
-                    </a:lnT>
-                    <a:lnB w="6350" cap="flat" cmpd="sng" algn="ctr">
-                      <a:solidFill>
-                        <a:schemeClr val="accent6"/>
-                      </a:solidFill>
-                      <a:prstDash val="solid"/>
-                      <a:round/>
-                      <a:headEnd type="none" w="med" len="med"/>
-                      <a:tailEnd type="none" w="med" len="med"/>
-                    </a:lnB>
-                    <a:solidFill>
-                      <a:schemeClr val="tx2"/>
-                    </a:solidFill>
-                  </a:tcPr>
-                </a:tc>
-                <a:tc>
-                  <a:txBody>
-                    <a:bodyPr/>
-                    <a:lstStyle/>
-                    <a:p>
-                      <a:pPr algn="l" indent="0" marL="0">
-                        <a:buNone/>
-                      </a:pPr>
-                      <a:r>
-                        <a:rPr lang="en-US" sz="1400" b="1" dirty="0">
-                          <a:solidFill>
-                            <a:schemeClr val="bg1"/>
-                          </a:solidFill>
-                        </a:rPr>
-                        <a:t>Sphere A</a:t>
                       </a:r>
                       <a:endParaRPr lang="en-US" sz="1400" dirty="0"/>
                     </a:p>
@@ -12100,7 +11519,7 @@
                   </a:tcPr>
                 </a:tc>
               </a:tr>
-              <a:tr h="529046">
+              <a:tr h="455023">
                 <a:tc>
                   <a:txBody>
                     <a:bodyPr/>
@@ -12116,67 +11535,6 @@
                           </a:solidFill>
                         </a:rPr>
                         <a:t>Nominal diameter</a:t>
-                      </a:r>
-                      <a:endParaRPr lang="en-US" sz="1400" dirty="0"/>
-                    </a:p>
-                  </a:txBody>
-                  <a:tcPr marL="109728" marR="109728" marT="45720" marB="45720" anchor="ctr">
-                    <a:lnL w="6350" cap="flat" cmpd="sng" algn="ctr">
-                      <a:solidFill>
-                        <a:schemeClr val="accent6"/>
-                      </a:solidFill>
-                      <a:prstDash val="solid"/>
-                      <a:round/>
-                      <a:headEnd type="none" w="med" len="med"/>
-                      <a:tailEnd type="none" w="med" len="med"/>
-                    </a:lnL>
-                    <a:lnR w="6350" cap="flat" cmpd="sng" algn="ctr">
-                      <a:solidFill>
-                        <a:schemeClr val="accent6"/>
-                      </a:solidFill>
-                      <a:prstDash val="solid"/>
-                      <a:round/>
-                      <a:headEnd type="none" w="med" len="med"/>
-                      <a:tailEnd type="none" w="med" len="med"/>
-                    </a:lnR>
-                    <a:lnT w="6350" cap="flat" cmpd="sng" algn="ctr">
-                      <a:solidFill>
-                        <a:schemeClr val="accent6"/>
-                      </a:solidFill>
-                      <a:prstDash val="solid"/>
-                      <a:round/>
-                      <a:headEnd type="none" w="med" len="med"/>
-                      <a:tailEnd type="none" w="med" len="med"/>
-                    </a:lnT>
-                    <a:lnB w="6350" cap="flat" cmpd="sng" algn="ctr">
-                      <a:solidFill>
-                        <a:schemeClr val="accent6"/>
-                      </a:solidFill>
-                      <a:prstDash val="solid"/>
-                      <a:round/>
-                      <a:headEnd type="none" w="med" len="med"/>
-                      <a:tailEnd type="none" w="med" len="med"/>
-                    </a:lnB>
-                    <a:solidFill>
-                      <a:schemeClr val="bg1"/>
-                    </a:solidFill>
-                  </a:tcPr>
-                </a:tc>
-                <a:tc>
-                  <a:txBody>
-                    <a:bodyPr/>
-                    <a:lstStyle/>
-                    <a:p>
-                      <a:pPr algn="l" indent="0" marL="0">
-                        <a:buNone/>
-                      </a:pPr>
-                      <a:r>
-                        <a:rPr lang="en-US" sz="1400" dirty="0">
-                          <a:solidFill>
-                            <a:schemeClr val="tx1"/>
-                          </a:solidFill>
-                        </a:rPr>
-                        <a:t>76.2 mm (3 inch)</a:t>
                       </a:r>
                       <a:endParaRPr lang="en-US" sz="1400" dirty="0"/>
                     </a:p>
@@ -12285,7 +11643,7 @@
                   </a:tcPr>
                 </a:tc>
               </a:tr>
-              <a:tr h="529046">
+              <a:tr h="518160">
                 <a:tc>
                   <a:txBody>
                     <a:bodyPr/>
@@ -12361,68 +11719,7 @@
                             <a:schemeClr val="tx1"/>
                           </a:solidFill>
                         </a:rPr>
-                        <a:t>Known to 0.025 mm, by micrometer at six or more orientations after finishing</a:t>
-                      </a:r>
-                      <a:endParaRPr lang="en-US" sz="1400" dirty="0"/>
-                    </a:p>
-                  </a:txBody>
-                  <a:tcPr marL="109728" marR="109728" marT="45720" marB="45720" anchor="ctr">
-                    <a:lnL w="6350" cap="flat" cmpd="sng" algn="ctr">
-                      <a:solidFill>
-                        <a:schemeClr val="accent6"/>
-                      </a:solidFill>
-                      <a:prstDash val="solid"/>
-                      <a:round/>
-                      <a:headEnd type="none" w="med" len="med"/>
-                      <a:tailEnd type="none" w="med" len="med"/>
-                    </a:lnL>
-                    <a:lnR w="6350" cap="flat" cmpd="sng" algn="ctr">
-                      <a:solidFill>
-                        <a:schemeClr val="accent6"/>
-                      </a:solidFill>
-                      <a:prstDash val="solid"/>
-                      <a:round/>
-                      <a:headEnd type="none" w="med" len="med"/>
-                      <a:tailEnd type="none" w="med" len="med"/>
-                    </a:lnR>
-                    <a:lnT w="6350" cap="flat" cmpd="sng" algn="ctr">
-                      <a:solidFill>
-                        <a:schemeClr val="accent6"/>
-                      </a:solidFill>
-                      <a:prstDash val="solid"/>
-                      <a:round/>
-                      <a:headEnd type="none" w="med" len="med"/>
-                      <a:tailEnd type="none" w="med" len="med"/>
-                    </a:lnT>
-                    <a:lnB w="6350" cap="flat" cmpd="sng" algn="ctr">
-                      <a:solidFill>
-                        <a:schemeClr val="accent6"/>
-                      </a:solidFill>
-                      <a:prstDash val="solid"/>
-                      <a:round/>
-                      <a:headEnd type="none" w="med" len="med"/>
-                      <a:tailEnd type="none" w="med" len="med"/>
-                    </a:lnB>
-                    <a:solidFill>
-                      <a:schemeClr val="bg2"/>
-                    </a:solidFill>
-                  </a:tcPr>
-                </a:tc>
-                <a:tc>
-                  <a:txBody>
-                    <a:bodyPr/>
-                    <a:lstStyle/>
-                    <a:p>
-                      <a:pPr algn="l" indent="0" marL="0">
-                        <a:buNone/>
-                      </a:pPr>
-                      <a:r>
-                        <a:rPr lang="en-US" sz="1400" dirty="0">
-                          <a:solidFill>
-                            <a:schemeClr val="tx1"/>
-                          </a:solidFill>
-                        </a:rPr>
-                        <a:t>Same; measure at the session's room temperature</a:t>
+                        <a:t>Known to 0.025 mm, by micrometer at six or more orientations after finishing, at the session's room temperature</a:t>
                       </a:r>
                       <a:endParaRPr lang="en-US" sz="1400" dirty="0"/>
                     </a:p>
@@ -12470,7 +11767,7 @@
                   </a:tcPr>
                 </a:tc>
               </a:tr>
-              <a:tr h="529046">
+              <a:tr h="455023">
                 <a:tc>
                   <a:txBody>
                     <a:bodyPr/>
@@ -12593,69 +11890,8 @@
                     </a:solidFill>
                   </a:tcPr>
                 </a:tc>
-                <a:tc>
-                  <a:txBody>
-                    <a:bodyPr/>
-                    <a:lstStyle/>
-                    <a:p>
-                      <a:pPr algn="l" indent="0" marL="0">
-                        <a:buNone/>
-                      </a:pPr>
-                      <a:r>
-                        <a:rPr lang="en-US" sz="1400" dirty="0">
-                          <a:solidFill>
-                            <a:schemeClr val="tx1"/>
-                          </a:solidFill>
-                        </a:rPr>
-                        <a:t>0.02 mm or better</a:t>
-                      </a:r>
-                      <a:endParaRPr lang="en-US" sz="1400" dirty="0"/>
-                    </a:p>
-                  </a:txBody>
-                  <a:tcPr marL="109728" marR="109728" marT="45720" marB="45720" anchor="ctr">
-                    <a:lnL w="6350" cap="flat" cmpd="sng" algn="ctr">
-                      <a:solidFill>
-                        <a:schemeClr val="accent6"/>
-                      </a:solidFill>
-                      <a:prstDash val="solid"/>
-                      <a:round/>
-                      <a:headEnd type="none" w="med" len="med"/>
-                      <a:tailEnd type="none" w="med" len="med"/>
-                    </a:lnL>
-                    <a:lnR w="6350" cap="flat" cmpd="sng" algn="ctr">
-                      <a:solidFill>
-                        <a:schemeClr val="accent6"/>
-                      </a:solidFill>
-                      <a:prstDash val="solid"/>
-                      <a:round/>
-                      <a:headEnd type="none" w="med" len="med"/>
-                      <a:tailEnd type="none" w="med" len="med"/>
-                    </a:lnR>
-                    <a:lnT w="6350" cap="flat" cmpd="sng" algn="ctr">
-                      <a:solidFill>
-                        <a:schemeClr val="accent6"/>
-                      </a:solidFill>
-                      <a:prstDash val="solid"/>
-                      <a:round/>
-                      <a:headEnd type="none" w="med" len="med"/>
-                      <a:tailEnd type="none" w="med" len="med"/>
-                    </a:lnT>
-                    <a:lnB w="6350" cap="flat" cmpd="sng" algn="ctr">
-                      <a:solidFill>
-                        <a:schemeClr val="accent6"/>
-                      </a:solidFill>
-                      <a:prstDash val="solid"/>
-                      <a:round/>
-                      <a:headEnd type="none" w="med" len="med"/>
-                      <a:tailEnd type="none" w="med" len="med"/>
-                    </a:lnB>
-                    <a:solidFill>
-                      <a:schemeClr val="bg1"/>
-                    </a:solidFill>
-                  </a:tcPr>
-                </a:tc>
               </a:tr>
-              <a:tr h="529046">
+              <a:tr h="455023">
                 <a:tc>
                   <a:txBody>
                     <a:bodyPr/>
@@ -12671,67 +11907,6 @@
                           </a:solidFill>
                         </a:rPr>
                         <a:t>Material</a:t>
-                      </a:r>
-                      <a:endParaRPr lang="en-US" sz="1400" dirty="0"/>
-                    </a:p>
-                  </a:txBody>
-                  <a:tcPr marL="109728" marR="109728" marT="45720" marB="45720" anchor="ctr">
-                    <a:lnL w="6350" cap="flat" cmpd="sng" algn="ctr">
-                      <a:solidFill>
-                        <a:schemeClr val="accent6"/>
-                      </a:solidFill>
-                      <a:prstDash val="solid"/>
-                      <a:round/>
-                      <a:headEnd type="none" w="med" len="med"/>
-                      <a:tailEnd type="none" w="med" len="med"/>
-                    </a:lnL>
-                    <a:lnR w="6350" cap="flat" cmpd="sng" algn="ctr">
-                      <a:solidFill>
-                        <a:schemeClr val="accent6"/>
-                      </a:solidFill>
-                      <a:prstDash val="solid"/>
-                      <a:round/>
-                      <a:headEnd type="none" w="med" len="med"/>
-                      <a:tailEnd type="none" w="med" len="med"/>
-                    </a:lnR>
-                    <a:lnT w="6350" cap="flat" cmpd="sng" algn="ctr">
-                      <a:solidFill>
-                        <a:schemeClr val="accent6"/>
-                      </a:solidFill>
-                      <a:prstDash val="solid"/>
-                      <a:round/>
-                      <a:headEnd type="none" w="med" len="med"/>
-                      <a:tailEnd type="none" w="med" len="med"/>
-                    </a:lnT>
-                    <a:lnB w="6350" cap="flat" cmpd="sng" algn="ctr">
-                      <a:solidFill>
-                        <a:schemeClr val="accent6"/>
-                      </a:solidFill>
-                      <a:prstDash val="solid"/>
-                      <a:round/>
-                      <a:headEnd type="none" w="med" len="med"/>
-                      <a:tailEnd type="none" w="med" len="med"/>
-                    </a:lnB>
-                    <a:solidFill>
-                      <a:schemeClr val="bg2"/>
-                    </a:solidFill>
-                  </a:tcPr>
-                </a:tc>
-                <a:tc>
-                  <a:txBody>
-                    <a:bodyPr/>
-                    <a:lstStyle/>
-                    <a:p>
-                      <a:pPr algn="l" indent="0" marL="0">
-                        <a:buNone/>
-                      </a:pPr>
-                      <a:r>
-                        <a:rPr lang="en-US" sz="1400" dirty="0">
-                          <a:solidFill>
-                            <a:schemeClr val="tx1"/>
-                          </a:solidFill>
-                        </a:rPr>
-                        <a:t>Bearing-grade steel (52100 or 440C, grade 25 or better) or ceramic</a:t>
                       </a:r>
                       <a:endParaRPr lang="en-US" sz="1400" dirty="0"/>
                     </a:p>
@@ -12840,7 +12015,7 @@
                   </a:tcPr>
                 </a:tc>
               </a:tr>
-              <a:tr h="529046">
+              <a:tr h="455023">
                 <a:tc>
                   <a:txBody>
                     <a:bodyPr/>
@@ -12916,68 +12091,7 @@
                             <a:schemeClr val="tx1"/>
                           </a:solidFill>
                         </a:rPr>
-                        <a:t>Matte, light, uniform: fine glass-bead blast or thin matte paint</a:t>
-                      </a:r>
-                      <a:endParaRPr lang="en-US" sz="1400" dirty="0"/>
-                    </a:p>
-                  </a:txBody>
-                  <a:tcPr marL="109728" marR="109728" marT="45720" marB="45720" anchor="ctr">
-                    <a:lnL w="6350" cap="flat" cmpd="sng" algn="ctr">
-                      <a:solidFill>
-                        <a:schemeClr val="accent6"/>
-                      </a:solidFill>
-                      <a:prstDash val="solid"/>
-                      <a:round/>
-                      <a:headEnd type="none" w="med" len="med"/>
-                      <a:tailEnd type="none" w="med" len="med"/>
-                    </a:lnL>
-                    <a:lnR w="6350" cap="flat" cmpd="sng" algn="ctr">
-                      <a:solidFill>
-                        <a:schemeClr val="accent6"/>
-                      </a:solidFill>
-                      <a:prstDash val="solid"/>
-                      <a:round/>
-                      <a:headEnd type="none" w="med" len="med"/>
-                      <a:tailEnd type="none" w="med" len="med"/>
-                    </a:lnR>
-                    <a:lnT w="6350" cap="flat" cmpd="sng" algn="ctr">
-                      <a:solidFill>
-                        <a:schemeClr val="accent6"/>
-                      </a:solidFill>
-                      <a:prstDash val="solid"/>
-                      <a:round/>
-                      <a:headEnd type="none" w="med" len="med"/>
-                      <a:tailEnd type="none" w="med" len="med"/>
-                    </a:lnT>
-                    <a:lnB w="6350" cap="flat" cmpd="sng" algn="ctr">
-                      <a:solidFill>
-                        <a:schemeClr val="accent6"/>
-                      </a:solidFill>
-                      <a:prstDash val="solid"/>
-                      <a:round/>
-                      <a:headEnd type="none" w="med" len="med"/>
-                      <a:tailEnd type="none" w="med" len="med"/>
-                    </a:lnB>
-                    <a:solidFill>
-                      <a:schemeClr val="bg1"/>
-                    </a:solidFill>
-                  </a:tcPr>
-                </a:tc>
-                <a:tc>
-                  <a:txBody>
-                    <a:bodyPr/>
-                    <a:lstStyle/>
-                    <a:p>
-                      <a:pPr algn="l" indent="0" marL="0">
-                        <a:buNone/>
-                      </a:pPr>
-                      <a:r>
-                        <a:rPr lang="en-US" sz="1400" dirty="0">
-                          <a:solidFill>
-                            <a:schemeClr val="tx1"/>
-                          </a:solidFill>
-                        </a:rPr>
-                        <a:t>Matte hard anodize, same appearance as sphere A</a:t>
+                        <a:t>Matte hard anodize, light gray or natural, uniform, free of highlights</a:t>
                       </a:r>
                       <a:endParaRPr lang="en-US" sz="1400" dirty="0"/>
                     </a:p>
@@ -13025,7 +12139,7 @@
                   </a:tcPr>
                 </a:tc>
               </a:tr>
-              <a:tr h="529046">
+              <a:tr h="455023">
                 <a:tc>
                   <a:txBody>
                     <a:bodyPr/>
@@ -13101,68 +12215,7 @@
                             <a:schemeClr val="tx1"/>
                           </a:solidFill>
                         </a:rPr>
-                        <a:t>Steel: blind hole 10 H7 x 23 mm, stem bonded. Ceramic: maker's M8 insert</a:t>
-                      </a:r>
-                      <a:endParaRPr lang="en-US" sz="1400" dirty="0"/>
-                    </a:p>
-                  </a:txBody>
-                  <a:tcPr marL="109728" marR="109728" marT="45720" marB="45720" anchor="ctr">
-                    <a:lnL w="6350" cap="flat" cmpd="sng" algn="ctr">
-                      <a:solidFill>
-                        <a:schemeClr val="accent6"/>
-                      </a:solidFill>
-                      <a:prstDash val="solid"/>
-                      <a:round/>
-                      <a:headEnd type="none" w="med" len="med"/>
-                      <a:tailEnd type="none" w="med" len="med"/>
-                    </a:lnL>
-                    <a:lnR w="6350" cap="flat" cmpd="sng" algn="ctr">
-                      <a:solidFill>
-                        <a:schemeClr val="accent6"/>
-                      </a:solidFill>
-                      <a:prstDash val="solid"/>
-                      <a:round/>
-                      <a:headEnd type="none" w="med" len="med"/>
-                      <a:tailEnd type="none" w="med" len="med"/>
-                    </a:lnR>
-                    <a:lnT w="6350" cap="flat" cmpd="sng" algn="ctr">
-                      <a:solidFill>
-                        <a:schemeClr val="accent6"/>
-                      </a:solidFill>
-                      <a:prstDash val="solid"/>
-                      <a:round/>
-                      <a:headEnd type="none" w="med" len="med"/>
-                      <a:tailEnd type="none" w="med" len="med"/>
-                    </a:lnT>
-                    <a:lnB w="6350" cap="flat" cmpd="sng" algn="ctr">
-                      <a:solidFill>
-                        <a:schemeClr val="accent6"/>
-                      </a:solidFill>
-                      <a:prstDash val="solid"/>
-                      <a:round/>
-                      <a:headEnd type="none" w="med" len="med"/>
-                      <a:tailEnd type="none" w="med" len="med"/>
-                    </a:lnB>
-                    <a:solidFill>
-                      <a:schemeClr val="bg2"/>
-                    </a:solidFill>
-                  </a:tcPr>
-                </a:tc>
-                <a:tc>
-                  <a:txBody>
-                    <a:bodyPr/>
-                    <a:lstStyle/>
-                    <a:p>
-                      <a:pPr algn="l" indent="0" marL="0">
-                        <a:buNone/>
-                      </a:pPr>
-                      <a:r>
-                        <a:rPr lang="en-US" sz="1400" dirty="0">
-                          <a:solidFill>
-                            <a:schemeClr val="tx1"/>
-                          </a:solidFill>
-                        </a:rPr>
-                        <a:t>M20 x 30 mm tapped hole at a pole, 32 mm spot face</a:t>
+                        <a:t>M20 x 30 mm tapped hole at a pole, 32 mm spot face, cut when the sphere is turned</a:t>
                       </a:r>
                       <a:endParaRPr lang="en-US" sz="1400" dirty="0"/>
                     </a:p>
@@ -13210,7 +12263,7 @@
                   </a:tcPr>
                 </a:tc>
               </a:tr>
-              <a:tr h="529046">
+              <a:tr h="455023">
                 <a:tc>
                   <a:txBody>
                     <a:bodyPr/>
@@ -13226,67 +12279,6 @@
                           </a:solidFill>
                         </a:rPr>
                         <a:t>Approximate mass</a:t>
-                      </a:r>
-                      <a:endParaRPr lang="en-US" sz="1400" dirty="0"/>
-                    </a:p>
-                  </a:txBody>
-                  <a:tcPr marL="109728" marR="109728" marT="45720" marB="45720" anchor="ctr">
-                    <a:lnL w="6350" cap="flat" cmpd="sng" algn="ctr">
-                      <a:solidFill>
-                        <a:schemeClr val="accent6"/>
-                      </a:solidFill>
-                      <a:prstDash val="solid"/>
-                      <a:round/>
-                      <a:headEnd type="none" w="med" len="med"/>
-                      <a:tailEnd type="none" w="med" len="med"/>
-                    </a:lnL>
-                    <a:lnR w="6350" cap="flat" cmpd="sng" algn="ctr">
-                      <a:solidFill>
-                        <a:schemeClr val="accent6"/>
-                      </a:solidFill>
-                      <a:prstDash val="solid"/>
-                      <a:round/>
-                      <a:headEnd type="none" w="med" len="med"/>
-                      <a:tailEnd type="none" w="med" len="med"/>
-                    </a:lnR>
-                    <a:lnT w="6350" cap="flat" cmpd="sng" algn="ctr">
-                      <a:solidFill>
-                        <a:schemeClr val="accent6"/>
-                      </a:solidFill>
-                      <a:prstDash val="solid"/>
-                      <a:round/>
-                      <a:headEnd type="none" w="med" len="med"/>
-                      <a:tailEnd type="none" w="med" len="med"/>
-                    </a:lnT>
-                    <a:lnB w="6350" cap="flat" cmpd="sng" algn="ctr">
-                      <a:solidFill>
-                        <a:schemeClr val="accent6"/>
-                      </a:solidFill>
-                      <a:prstDash val="solid"/>
-                      <a:round/>
-                      <a:headEnd type="none" w="med" len="med"/>
-                      <a:tailEnd type="none" w="med" len="med"/>
-                    </a:lnB>
-                    <a:solidFill>
-                      <a:schemeClr val="bg1"/>
-                    </a:solidFill>
-                  </a:tcPr>
-                </a:tc>
-                <a:tc>
-                  <a:txBody>
-                    <a:bodyPr/>
-                    <a:lstStyle/>
-                    <a:p>
-                      <a:pPr algn="l" indent="0" marL="0">
-                        <a:buNone/>
-                      </a:pPr>
-                      <a:r>
-                        <a:rPr lang="en-US" sz="1400" dirty="0">
-                          <a:solidFill>
-                            <a:schemeClr val="tx1"/>
-                          </a:solidFill>
-                        </a:rPr>
-                        <a:t>0.9 to 1.8 kg</a:t>
                       </a:r>
                       <a:endParaRPr lang="en-US" sz="1400" dirty="0"/>
                     </a:p>
@@ -13395,6 +12387,130 @@
                   </a:tcPr>
                 </a:tc>
               </a:tr>
+              <a:tr h="455023">
+                <a:tc>
+                  <a:txBody>
+                    <a:bodyPr/>
+                    <a:lstStyle/>
+                    <a:p>
+                      <a:pPr algn="l" indent="0" marL="0">
+                        <a:buNone/>
+                      </a:pPr>
+                      <a:r>
+                        <a:rPr lang="en-US" sz="1400" b="1" dirty="0">
+                          <a:solidFill>
+                            <a:schemeClr val="tx2"/>
+                          </a:solidFill>
+                        </a:rPr>
+                        <a:t>Documents</a:t>
+                      </a:r>
+                      <a:endParaRPr lang="en-US" sz="1400" dirty="0"/>
+                    </a:p>
+                  </a:txBody>
+                  <a:tcPr marL="109728" marR="109728" marT="45720" marB="45720" anchor="ctr">
+                    <a:lnL w="6350" cap="flat" cmpd="sng" algn="ctr">
+                      <a:solidFill>
+                        <a:schemeClr val="accent6"/>
+                      </a:solidFill>
+                      <a:prstDash val="solid"/>
+                      <a:round/>
+                      <a:headEnd type="none" w="med" len="med"/>
+                      <a:tailEnd type="none" w="med" len="med"/>
+                    </a:lnL>
+                    <a:lnR w="6350" cap="flat" cmpd="sng" algn="ctr">
+                      <a:solidFill>
+                        <a:schemeClr val="accent6"/>
+                      </a:solidFill>
+                      <a:prstDash val="solid"/>
+                      <a:round/>
+                      <a:headEnd type="none" w="med" len="med"/>
+                      <a:tailEnd type="none" w="med" len="med"/>
+                    </a:lnR>
+                    <a:lnT w="6350" cap="flat" cmpd="sng" algn="ctr">
+                      <a:solidFill>
+                        <a:schemeClr val="accent6"/>
+                      </a:solidFill>
+                      <a:prstDash val="solid"/>
+                      <a:round/>
+                      <a:headEnd type="none" w="med" len="med"/>
+                      <a:tailEnd type="none" w="med" len="med"/>
+                    </a:lnT>
+                    <a:lnB w="6350" cap="flat" cmpd="sng" algn="ctr">
+                      <a:solidFill>
+                        <a:schemeClr val="accent6"/>
+                      </a:solidFill>
+                      <a:prstDash val="solid"/>
+                      <a:round/>
+                      <a:headEnd type="none" w="med" len="med"/>
+                      <a:tailEnd type="none" w="med" len="med"/>
+                    </a:lnB>
+                    <a:solidFill>
+                      <a:schemeClr val="bg2"/>
+                    </a:solidFill>
+                  </a:tcPr>
+                </a:tc>
+                <a:tc>
+                  <a:txBody>
+                    <a:bodyPr/>
+                    <a:lstStyle/>
+                    <a:p>
+                      <a:pPr algn="l" indent="0" marL="0">
+                        <a:buNone/>
+                      </a:pPr>
+                      <a:r>
+                        <a:rPr lang="en-US" sz="1400" dirty="0">
+                          <a:solidFill>
+                            <a:schemeClr val="tx1"/>
+                          </a:solidFill>
+                        </a:rPr>
+                        <a:t>The turner's inspection report: diameter and sphericity as turned, thread and spot face</a:t>
+                      </a:r>
+                      <a:endParaRPr lang="en-US" sz="1400" dirty="0"/>
+                    </a:p>
+                  </a:txBody>
+                  <a:tcPr marL="109728" marR="109728" marT="45720" marB="45720" anchor="ctr">
+                    <a:lnL w="6350" cap="flat" cmpd="sng" algn="ctr">
+                      <a:solidFill>
+                        <a:schemeClr val="accent6"/>
+                      </a:solidFill>
+                      <a:prstDash val="solid"/>
+                      <a:round/>
+                      <a:headEnd type="none" w="med" len="med"/>
+                      <a:tailEnd type="none" w="med" len="med"/>
+                    </a:lnL>
+                    <a:lnR w="6350" cap="flat" cmpd="sng" algn="ctr">
+                      <a:solidFill>
+                        <a:schemeClr val="accent6"/>
+                      </a:solidFill>
+                      <a:prstDash val="solid"/>
+                      <a:round/>
+                      <a:headEnd type="none" w="med" len="med"/>
+                      <a:tailEnd type="none" w="med" len="med"/>
+                    </a:lnR>
+                    <a:lnT w="6350" cap="flat" cmpd="sng" algn="ctr">
+                      <a:solidFill>
+                        <a:schemeClr val="accent6"/>
+                      </a:solidFill>
+                      <a:prstDash val="solid"/>
+                      <a:round/>
+                      <a:headEnd type="none" w="med" len="med"/>
+                      <a:tailEnd type="none" w="med" len="med"/>
+                    </a:lnT>
+                    <a:lnB w="6350" cap="flat" cmpd="sng" algn="ctr">
+                      <a:solidFill>
+                        <a:schemeClr val="accent6"/>
+                      </a:solidFill>
+                      <a:prstDash val="solid"/>
+                      <a:round/>
+                      <a:headEnd type="none" w="med" len="med"/>
+                      <a:tailEnd type="none" w="med" len="med"/>
+                    </a:lnB>
+                    <a:solidFill>
+                      <a:schemeClr val="bg2"/>
+                    </a:solidFill>
+                  </a:tcPr>
+                </a:tc>
+              </a:tr>
             </a:tbl>
           </a:graphicData>
         </a:graphic>
@@ -13429,7 +12545,7 @@
                   <a:schemeClr val="accent5"/>
                 </a:solidFill>
               </a:rPr>
-              <a:t>Procedure section 1d; drawings SC1-03 and SC1-04 show the interfaces.</a:t>
+              <a:t>Procedure section 1d; drawing SC1-04 shows the interface.</a:t>
             </a:r>
             <a:endParaRPr lang="en-US" sz="1200" dirty="0"/>
           </a:p>
@@ -14858,7 +13974,7 @@
                 <a:ea typeface="+mj-lt" pitchFamily="34" charset="-122"/>
                 <a:cs typeface="+mj-lt" pitchFamily="34" charset="-120"/>
               </a:rPr>
-              <a:t>Spheres must be matte and measured, not certified</a:t>
+              <a:t>The sphere must be matte and measured, not certified</a:t>
             </a:r>
             <a:endParaRPr lang="en-US" sz="3400" dirty="0"/>
           </a:p>
@@ -15003,7 +14119,7 @@
                   <a:schemeClr val="tx1"/>
                 </a:solidFill>
               </a:rPr>
-              <a:t>Every bearing ball arrives mirror-bright: unusable</a:t>
+              <a:t>Matte hard anodize on the turned aluminum sphere</a:t>
             </a:r>
             <a:endParaRPr lang="en-US" sz="1600" dirty="0"/>
           </a:p>
@@ -15021,7 +14137,7 @@
                   <a:schemeClr val="tx1"/>
                 </a:solidFill>
               </a:rPr>
-              <a:t>Bead-blast with fine glass bead: removes micrometers</a:t>
+              <a:t>A mirror sphere is unusable: one bright highlight</a:t>
             </a:r>
             <a:endParaRPr lang="en-US" sz="1600" dirty="0"/>
           </a:p>
@@ -15039,7 +14155,7 @@
                   <a:schemeClr val="tx1"/>
                 </a:solidFill>
               </a:rPr>
-              <a:t>Matte paint is second choice: 0.02 to 0.05 mm per coat</a:t>
+              <a:t>Steel or ceramic alternative: bead-blast with fine glass bead</a:t>
             </a:r>
             <a:endParaRPr lang="en-US" sz="1600" dirty="0"/>
           </a:p>
@@ -15057,7 +14173,7 @@
                   <a:schemeClr val="tx1"/>
                 </a:solidFill>
               </a:rPr>
-              <a:t>"Chrome steel" is the 52100 alloy, not plating</a:t>
+              <a:t>Matte paint is the last resort: 0.02 to 0.05 mm per coat</a:t>
             </a:r>
             <a:endParaRPr lang="en-US" sz="1600" dirty="0"/>
           </a:p>
@@ -15401,7 +14517,7 @@
                   <a:schemeClr val="tx1"/>
                 </a:solidFill>
               </a:rPr>
-              <a:t>Hardened balls cannot be tapped</a:t>
+              <a:t>M20 thread cut at the pole when the sphere is turned</a:t>
             </a:r>
             <a:endParaRPr lang="en-US" sz="1600" dirty="0"/>
           </a:p>
@@ -15419,7 +14535,7 @@
                   <a:schemeClr val="tx1"/>
                 </a:solidFill>
               </a:rPr>
-              <a:t>Steel ball: drilled or EDM blind hole, bonded stem</a:t>
+              <a:t>Hardened steel or ceramic cannot be tapped</a:t>
             </a:r>
             <a:endParaRPr lang="en-US" sz="1600" dirty="0"/>
           </a:p>
@@ -15437,7 +14553,7 @@
                   <a:schemeClr val="tx1"/>
                 </a:solidFill>
               </a:rPr>
-              <a:t>Aluminum sphere B: thread cut when it is turned</a:t>
+              <a:t>Alternative: blind hole 16 H7 x 46 mm, stem bonded</a:t>
             </a:r>
             <a:endParaRPr lang="en-US" sz="1600" dirty="0"/>
           </a:p>
@@ -15455,7 +14571,7 @@
                   <a:schemeClr val="tx1"/>
                 </a:solidFill>
               </a:rPr>
-              <a:t>None found stocked above 1.5 inch; custom order only</a:t>
+              <a:t>No tapped 6 inch precision sphere is stocked</a:t>
             </a:r>
             <a:endParaRPr lang="en-US" sz="1600" dirty="0"/>
           </a:p>
@@ -15799,7 +14915,7 @@
                             <a:schemeClr val="tx2"/>
                           </a:solidFill>
                         </a:rPr>
-                        <a:t>Spheres, made to order</a:t>
+                        <a:t>Sphere, made to order</a:t>
                       </a:r>
                       <a:endParaRPr lang="en-US" sz="1400" dirty="0"/>
                     </a:p>
@@ -15860,7 +14976,7 @@
                             <a:schemeClr val="tx1"/>
                           </a:solidFill>
                         </a:rPr>
-                        <a:t>Bal-tec; RGP Balls; Industrial Tectonics; Morgan Advanced Materials</a:t>
+                        <a:t>Precision turning shop (aluminum); Bal-tec; RGP Balls; Industrial Tectonics; Morgan Advanced Materials</a:t>
                       </a:r>
                       <a:endParaRPr lang="en-US" sz="1400" dirty="0"/>
                     </a:p>
@@ -15921,7 +15037,7 @@
                             <a:schemeClr val="tx1"/>
                           </a:solidFill>
                         </a:rPr>
-                        <a:t>3 and 6 inch matte spheres with a mounting hole are custom items</a:t>
+                        <a:t>A 6 inch matte sphere with a mounting hole is a custom item</a:t>
                       </a:r>
                       <a:endParaRPr lang="en-US" sz="1400" dirty="0"/>
                     </a:p>
@@ -15984,7 +15100,7 @@
                             <a:schemeClr val="tx2"/>
                           </a:solidFill>
                         </a:rPr>
-                        <a:t>Matte reference spheres, stock</a:t>
+                        <a:t>Stock reference spheres</a:t>
                       </a:r>
                       <a:endParaRPr lang="en-US" sz="1400" dirty="0"/>
                     </a:p>
@@ -16045,7 +15161,7 @@
                             <a:schemeClr val="tx1"/>
                           </a:solidFill>
                         </a:rPr>
-                        <a:t>MetrologyWorks; Rothbucher RSLB10M (Baseline Equipment)</a:t>
+                        <a:t>Laser-scanner spheres, Rothbucher RSLB10M among them</a:t>
                       </a:r>
                       <a:endParaRPr lang="en-US" sz="1400" dirty="0"/>
                     </a:p>
@@ -16106,7 +15222,7 @@
                             <a:schemeClr val="tx1"/>
                           </a:solidFill>
                         </a:rPr>
-                        <a:t>MetrologyWorks: smaller sphere A only. Rothbucher: provisional far-range B only.</a:t>
+                        <a:t>Not usable: form errors of 0.3 to 2 mm</a:t>
                       </a:r>
                       <a:endParaRPr lang="en-US" sz="1400" dirty="0"/>
                     </a:p>
@@ -16539,7 +15655,7 @@
                             <a:schemeClr val="tx2"/>
                           </a:solidFill>
                         </a:rPr>
-                        <a:t>Adapters, stems, sphere holes</a:t>
+                        <a:t>Adapter, stem, board adapter, nest base</a:t>
                       </a:r>
                       <a:endParaRPr lang="en-US" sz="1400" dirty="0"/>
                     </a:p>
@@ -16600,7 +15716,7 @@
                             <a:schemeClr val="tx1"/>
                           </a:solidFill>
                         </a:rPr>
-                        <a:t>Local machine shop; EDM shop for hardened balls</a:t>
+                        <a:t>Local machine shop</a:t>
                       </a:r>
                       <a:endParaRPr lang="en-US" sz="1400" dirty="0"/>
                     </a:p>
@@ -16661,7 +15777,7 @@
                             <a:schemeClr val="tx1"/>
                           </a:solidFill>
                         </a:rPr>
-                        <a:t>Hardened balls cannot be tapped</a:t>
+                        <a:t>Inspection report of the toleranced features on each order</a:t>
                       </a:r>
                       <a:endParaRPr lang="en-US" sz="1400" dirty="0"/>
                     </a:p>
@@ -16785,7 +15901,7 @@
                             <a:schemeClr val="tx1"/>
                           </a:solidFill>
                         </a:rPr>
-                        <a:t>Outside micrometers: Mitutoyo 103-140-10 and 103-143-10, or Starrett</a:t>
+                        <a:t>Outside micrometer 150-175 mm: Mitutoyo 103-143-10, or Starrett</a:t>
                       </a:r>
                       <a:endParaRPr lang="en-US" sz="1400" dirty="0"/>
                     </a:p>
@@ -16846,7 +15962,7 @@
                             <a:schemeClr val="tx1"/>
                           </a:solidFill>
                         </a:rPr>
-                        <a:t>In-house, after the matte finish; setting standards included</a:t>
+                        <a:t>In-house, after the matte finish; setting standard included</a:t>
                       </a:r>
                       <a:endParaRPr lang="en-US" sz="1400" dirty="0"/>
                     </a:p>

</xml_diff>

<commit_message>
Plan: 50 degree board tilt; smoothing search up to 10^6 (interim)
Interim snapshot: the confirmation rerun of the simulation with these
settings is still running; its results and the simulation folder are
not in this commit.

- Planner default board tilts 0, 20, 40, 50 degrees: the planar
  correction between 40 degrees and the 55 degree cut-off is measured
  instead of inferred. Example plan 217 poses (151 sphere, 66 board).
- Smoothing search grids reach 10^6 (the simulation chose 10^4, the old
  edge, for the position and slope terms).
- Analysis D-19 records the simulation and both changes; procedure
  section 6 and appendix B, figure 2, code_design section 12 and deck 2
  updated. Documents snapshotted in archive/2026-10-09_before_50deg_tilt.
- 161 tests pass.

Co-Authored-By: Claude Opus 5.5 <noreply@anthropic.com>
Claude-Session: https://claude.ai/code/session_01LnkFMdRYsdw8VhXMWXEpNu
</commit_message>
<xml_diff>
--- a/docs/presentations/stage1_procurement_build.pptx
+++ b/docs/presentations/stage1_procurement_build.pptx
@@ -121,20 +121,20 @@
   <p:extLst>
     <p:ext uri="{521415D9-36F7-43E2-AB2F-B90AF26B5E84}">
       <p14:sectionLst xmlns:p14="http://schemas.microsoft.com/office/powerpoint/2010/main">
-        <p14:section name="Introduction" id="{333c239a-7a51-38cd-a630-aaa413c91ef9}">
+        <p14:section name="Introduction" id="{c0888873-2185-e0b6-8786-804269d3c45f}">
           <p14:sldIdLst>
             <p14:sldId id="256"/>
             <p14:sldId id="257"/>
           </p14:sldIdLst>
         </p14:section>
-        <p14:section name="Scope of work" id="{2066cdb6-62f9-f471-71a5-580eeee48728}">
+        <p14:section name="Scope of work" id="{96544cb0-4a29-0a39-faa1-efac535dfc25}">
           <p14:sldIdLst>
             <p14:sldId id="258"/>
             <p14:sldId id="259"/>
             <p14:sldId id="260"/>
           </p14:sldIdLst>
         </p14:section>
-        <p14:section name="Procurement" id="{a3802c80-787a-22a1-c69a-76c3eb9bc8da}">
+        <p14:section name="Procurement" id="{508e7915-92cf-eee1-6828-d60b9919f9ff}">
           <p14:sldIdLst>
             <p14:sldId id="261"/>
             <p14:sldId id="262"/>
@@ -143,7 +143,7 @@
             <p14:sldId id="265"/>
           </p14:sldIdLst>
         </p14:section>
-        <p14:section name="Mechanical build" id="{bb96e8ee-f057-064a-5c6d-385ae4f907b2}">
+        <p14:section name="Mechanical build" id="{4abbc256-9443-6e02-24a4-0d55f9aba358}">
           <p14:sldIdLst>
             <p14:sldId id="266"/>
             <p14:sldId id="267"/>

</xml_diff>